<commit_message>
Correct overstated claims and stats across docs and deck
- Use the accurate factory-fatality figure (~3 deaths/day in registered
  factories, DGFASLI) instead of the mis-stated "6,500/year"; drop the
  unsourced "60% manual handoffs" stat
- Reconcile the projected-breach readout to the engine's actual ~36 min at
  the money-shot frame (was an inconsistent ~22)
- Describe the RAG layer as it is - in-memory cosine over the incident
  corpus with a lexical fallback - and remove the phantom ChromaDB references
- Frame the LangGraph layer as a 6-stage auditable reasoning graph of
  deterministic stages, not autonomous agents
- Scope the vision claim to person / zone-intrusion on a sample frame; PPE
  and a live camera feed are connectors
- Align the deck's secondary precedents to the live match ranking
  (hot-work 73%, confined-space 71%)
- Present the three lighter builds honestly as focused MVPs
- Trim the evacuation/funeral line to a single spoken beat; remove stale
  Neo4j env vars
</commit_message>
<xml_diff>
--- a/docs/Trinetra_Deck.pptx
+++ b/docs/Trinetra_Deck.pptx
@@ -2217,7 +2217,7 @@
                 <a:ea typeface="Trebuchet MS" pitchFamily="34" charset="-122"/>
                 <a:cs typeface="Trebuchet MS" pitchFamily="34" charset="-120"/>
               </a:rPr>
-              <a:t>6,500 deaths a year.</a:t>
+              <a:t>Three workers a day.</a:t>
             </a:r>
             <a:endParaRPr lang="en-US" sz="4000" dirty="0"/>
           </a:p>
@@ -2842,7 +2842,7 @@
                 <a:ea typeface="Trebuchet MS" pitchFamily="34" charset="-122"/>
                 <a:cs typeface="Trebuchet MS" pitchFamily="34" charset="-120"/>
               </a:rPr>
-              <a:t>6,500+</a:t>
+              <a:t>3 / day</a:t>
             </a:r>
             <a:endParaRPr lang="en-US" sz="3300" dirty="0"/>
           </a:p>
@@ -2881,7 +2881,7 @@
                 <a:ea typeface="Calibri" pitchFamily="34" charset="-122"/>
                 <a:cs typeface="Calibri" pitchFamily="34" charset="-120"/>
               </a:rPr>
-              <a:t>fatal workplace accidents / year (India)</a:t>
+              <a:t>deaths in India's registered factories (DGFASLI)</a:t>
             </a:r>
             <a:endParaRPr lang="en-US" sz="1300" dirty="0"/>
           </a:p>
@@ -2967,7 +2967,7 @@
                 <a:ea typeface="Trebuchet MS" pitchFamily="34" charset="-122"/>
                 <a:cs typeface="Trebuchet MS" pitchFamily="34" charset="-120"/>
               </a:rPr>
-              <a:t>60%</a:t>
+              <a:t>0</a:t>
             </a:r>
             <a:endParaRPr lang="en-US" sz="3300" dirty="0"/>
           </a:p>
@@ -3006,7 +3006,7 @@
                 <a:ea typeface="Calibri" pitchFamily="34" charset="-122"/>
                 <a:cs typeface="Calibri" pitchFamily="34" charset="-120"/>
               </a:rPr>
-              <a:t>of large plants rely on manual handoffs</a:t>
+              <a:t>layers connected those signals in time</a:t>
             </a:r>
             <a:endParaRPr lang="en-US" sz="1300" dirty="0"/>
           </a:p>
@@ -3733,7 +3733,7 @@
                 <a:ea typeface="Calibri" pitchFamily="34" charset="-122"/>
                 <a:cs typeface="Calibri" pitchFamily="34" charset="-120"/>
               </a:rPr>
-              <a:t>Three green lights. One lethal combination — hours before it becomes critical.</a:t>
+              <a:t>Three green lights. One lethal combination — minutes before it becomes critical.</a:t>
             </a:r>
             <a:endParaRPr lang="en-US" sz="1500" dirty="0"/>
           </a:p>
@@ -4357,7 +4357,7 @@
                 <a:ea typeface="Calibri" pitchFamily="34" charset="-122"/>
                 <a:cs typeface="Calibri" pitchFamily="34" charset="-120"/>
               </a:rPr>
-              <a:t>COB-1 critical · breach predicted ~22 min</a:t>
+              <a:t>COB-1 critical · breach predicted ~36 min</a:t>
             </a:r>
             <a:endParaRPr lang="en-US" sz="1400" dirty="0"/>
           </a:p>
@@ -4455,7 +4455,7 @@
                 <a:ea typeface="Calibri" pitchFamily="34" charset="-122"/>
                 <a:cs typeface="Calibri" pitchFamily="34" charset="-120"/>
               </a:rPr>
-              <a:t>Six minutes is the difference between an evacuation and a funeral.</a:t>
+              <a:t>Six minutes of warning — while every gas sensor still reads below its setpoint.</a:t>
             </a:r>
             <a:endParaRPr lang="en-US" sz="1500" dirty="0"/>
           </a:p>
@@ -4901,7 +4901,7 @@
                 <a:ea typeface="Trebuchet MS" pitchFamily="34" charset="-122"/>
                 <a:cs typeface="Trebuchet MS" pitchFamily="34" charset="-120"/>
               </a:rPr>
-              <a:t>Multi-Agent</a:t>
+              <a:t>Reasoning Graph</a:t>
             </a:r>
             <a:endParaRPr lang="en-US" sz="1700" dirty="0"/>
           </a:p>
@@ -4940,7 +4940,7 @@
                 <a:ea typeface="Calibri" pitchFamily="34" charset="-122"/>
                 <a:cs typeface="Calibri" pitchFamily="34" charset="-120"/>
               </a:rPr>
-              <a:t>LangGraph 6-agent pipeline</a:t>
+              <a:t>LangGraph 6-stage auditable trace</a:t>
             </a:r>
             <a:endParaRPr lang="en-US" sz="1300" dirty="0"/>
           </a:p>
@@ -5734,7 +5734,7 @@
                 <a:ea typeface="Calibri" pitchFamily="34" charset="-122"/>
                 <a:cs typeface="Calibri" pitchFamily="34" charset="-120"/>
               </a:rPr>
-              <a:t>Texas City refinery</a:t>
+              <a:t>Hot-work ignition</a:t>
             </a:r>
             <a:endParaRPr lang="en-US" sz="1200" dirty="0"/>
           </a:p>
@@ -5800,7 +5800,7 @@
                 <a:ea typeface="Trebuchet MS" pitchFamily="34" charset="-122"/>
                 <a:cs typeface="Trebuchet MS" pitchFamily="34" charset="-120"/>
               </a:rPr>
-              <a:t>72%</a:t>
+              <a:t>71%</a:t>
             </a:r>
             <a:endParaRPr lang="en-US" sz="2200" dirty="0"/>
           </a:p>
@@ -5839,7 +5839,7 @@
                 <a:ea typeface="Calibri" pitchFamily="34" charset="-122"/>
                 <a:cs typeface="Calibri" pitchFamily="34" charset="-120"/>
               </a:rPr>
-              <a:t>Hot-work ignition</a:t>
+              <a:t>Confined-space H2S</a:t>
             </a:r>
             <a:endParaRPr lang="en-US" sz="1200" dirty="0"/>
           </a:p>

</xml_diff>

<commit_message>
Reframe ROI as expected value + add business / GTM / architecture slides
Replace the 116x-per-incident framing with the expected-annual-value model a
serious buyer underwrites: per-incident avoided loss x a conservative event
frequency, with a sensitivity band and a recurring insurance-premium lever.

- impact.py: EV model (anchor 1-in-15-yr -> ~8x; 3.9x-14.4x sensitivity band;
  net Rs 6.7 Cr/yr) plus an insurance-premium reduction (Rs 0.4-1.2 Cr/yr) that
  offsets the platform cost incident or not; per-incident Rs 115.5 Cr retained
- response modal: show EV ROI + sensitivity + insurance offset, not 116x
- deck: new Business Impact (EV), Go-To-Market (buyer / wedge / pricing /
  regulatory trigger + design-partner ask), and Reference Architecture
  (OPC-UA / MQTT -> edge -> engine -> HMI; ~10k tags @ 1 Hz, O(zones)) slides
- demo script: ROI answer reframed to expected value
</commit_message>
<xml_diff>
--- a/docs/Trinetra_Deck.pptx
+++ b/docs/Trinetra_Deck.pptx
@@ -15,9 +15,12 @@
     <p:sldId id="263" r:id="rId9"/>
     <p:sldId id="264" r:id="rId10"/>
     <p:sldId id="265" r:id="rId11"/>
+    <p:sldId id="266" r:id="rId12"/>
+    <p:sldId id="267" r:id="rId13"/>
+    <p:sldId id="268" r:id="rId14"/>
   </p:sldIdLst>
   <p:notesMasterIdLst>
-    <p:notesMasterId r:id="rId12"/>
+    <p:notesMasterId r:id="rId15"/>
   </p:notesMasterIdLst>
   <p:sldSz cx="12191695" cy="6858000"/>
   <p:notesSz cx="6858000" cy="12191695"/>
@@ -623,6 +626,270 @@
             <a:fld id="{F7021451-1387-4CA6-816F-3879F97B5CBC}" type="slidenum">
               <a:rPr lang="en-US"/>
               <a:t>10</a:t>
+            </a:fld>
+            <a:endParaRPr lang="en-US"/>
+          </a:p>
+        </p:txBody>
+      </p:sp>
+    </p:spTree>
+    <p:extLst>
+      <p:ext uri="{BB962C8B-B14F-4D97-AF65-F5344CB8AC3E}">
+        <p14:creationId xmlns:p14="http://schemas.microsoft.com/office/powerpoint/2010/main" val="1024086991"/>
+      </p:ext>
+    </p:extLst>
+  </p:cSld>
+  <p:clrMapOvr>
+    <a:masterClrMapping/>
+  </p:clrMapOvr>
+</p:notes>
+</file>
+
+<file path=ppt/notesSlides/notesSlide11.xml><?xml version="1.0" encoding="utf-8"?>
+<p:notes xmlns:a="http://schemas.openxmlformats.org/drawingml/2006/main" xmlns:r="http://schemas.openxmlformats.org/officeDocument/2006/relationships" xmlns:p="http://schemas.openxmlformats.org/presentationml/2006/main">
+  <p:cSld>
+    <p:spTree>
+      <p:nvGrpSpPr>
+        <p:cNvPr id="1" name=""/>
+        <p:cNvGrpSpPr/>
+        <p:nvPr/>
+      </p:nvGrpSpPr>
+      <p:grpSpPr>
+        <a:xfrm>
+          <a:off x="0" y="0"/>
+          <a:ext cx="0" cy="0"/>
+          <a:chOff x="0" y="0"/>
+          <a:chExt cx="0" cy="0"/>
+        </a:xfrm>
+      </p:grpSpPr>
+      <p:sp>
+        <p:nvSpPr>
+          <p:cNvPr id="2" name="Slide Image Placeholder 1"/>
+          <p:cNvSpPr>
+            <a:spLocks noGrp="1" noRot="1" noChangeAspect="1"/>
+          </p:cNvSpPr>
+          <p:nvPr>
+            <p:ph type="sldImg"/>
+          </p:nvPr>
+        </p:nvSpPr>
+        <p:spPr/>
+      </p:sp>
+      <p:sp>
+        <p:nvSpPr>
+          <p:cNvPr id="3" name="Notes Placeholder 2"/>
+          <p:cNvSpPr>
+            <a:spLocks noGrp="1"/>
+          </p:cNvSpPr>
+          <p:nvPr>
+            <p:ph type="body" idx="1"/>
+          </p:nvPr>
+        </p:nvSpPr>
+        <p:spPr/>
+        <p:txBody>
+          <a:bodyPr/>
+          <a:lstStyle/>
+          <a:p>
+            <a:r>
+              <a:rPr lang="en-US" dirty="0"/>
+              <a:t/>
+            </a:r>
+            <a:endParaRPr lang="en-US" dirty="0"/>
+          </a:p>
+        </p:txBody>
+      </p:sp>
+      <p:sp>
+        <p:nvSpPr>
+          <p:cNvPr id="4" name="Slide Number Placeholder 3"/>
+          <p:cNvSpPr>
+            <a:spLocks noGrp="1"/>
+          </p:cNvSpPr>
+          <p:nvPr>
+            <p:ph type="sldNum" sz="quarter" idx="10"/>
+          </p:nvPr>
+        </p:nvSpPr>
+        <p:spPr/>
+        <p:txBody>
+          <a:bodyPr/>
+          <a:lstStyle/>
+          <a:p>
+            <a:fld id="{F7021451-1387-4CA6-816F-3879F97B5CBC}" type="slidenum">
+              <a:rPr lang="en-US"/>
+              <a:t>11</a:t>
+            </a:fld>
+            <a:endParaRPr lang="en-US"/>
+          </a:p>
+        </p:txBody>
+      </p:sp>
+    </p:spTree>
+    <p:extLst>
+      <p:ext uri="{BB962C8B-B14F-4D97-AF65-F5344CB8AC3E}">
+        <p14:creationId xmlns:p14="http://schemas.microsoft.com/office/powerpoint/2010/main" val="1024086991"/>
+      </p:ext>
+    </p:extLst>
+  </p:cSld>
+  <p:clrMapOvr>
+    <a:masterClrMapping/>
+  </p:clrMapOvr>
+</p:notes>
+</file>
+
+<file path=ppt/notesSlides/notesSlide12.xml><?xml version="1.0" encoding="utf-8"?>
+<p:notes xmlns:a="http://schemas.openxmlformats.org/drawingml/2006/main" xmlns:r="http://schemas.openxmlformats.org/officeDocument/2006/relationships" xmlns:p="http://schemas.openxmlformats.org/presentationml/2006/main">
+  <p:cSld>
+    <p:spTree>
+      <p:nvGrpSpPr>
+        <p:cNvPr id="1" name=""/>
+        <p:cNvGrpSpPr/>
+        <p:nvPr/>
+      </p:nvGrpSpPr>
+      <p:grpSpPr>
+        <a:xfrm>
+          <a:off x="0" y="0"/>
+          <a:ext cx="0" cy="0"/>
+          <a:chOff x="0" y="0"/>
+          <a:chExt cx="0" cy="0"/>
+        </a:xfrm>
+      </p:grpSpPr>
+      <p:sp>
+        <p:nvSpPr>
+          <p:cNvPr id="2" name="Slide Image Placeholder 1"/>
+          <p:cNvSpPr>
+            <a:spLocks noGrp="1" noRot="1" noChangeAspect="1"/>
+          </p:cNvSpPr>
+          <p:nvPr>
+            <p:ph type="sldImg"/>
+          </p:nvPr>
+        </p:nvSpPr>
+        <p:spPr/>
+      </p:sp>
+      <p:sp>
+        <p:nvSpPr>
+          <p:cNvPr id="3" name="Notes Placeholder 2"/>
+          <p:cNvSpPr>
+            <a:spLocks noGrp="1"/>
+          </p:cNvSpPr>
+          <p:nvPr>
+            <p:ph type="body" idx="1"/>
+          </p:nvPr>
+        </p:nvSpPr>
+        <p:spPr/>
+        <p:txBody>
+          <a:bodyPr/>
+          <a:lstStyle/>
+          <a:p>
+            <a:r>
+              <a:rPr lang="en-US" dirty="0"/>
+              <a:t/>
+            </a:r>
+            <a:endParaRPr lang="en-US" dirty="0"/>
+          </a:p>
+        </p:txBody>
+      </p:sp>
+      <p:sp>
+        <p:nvSpPr>
+          <p:cNvPr id="4" name="Slide Number Placeholder 3"/>
+          <p:cNvSpPr>
+            <a:spLocks noGrp="1"/>
+          </p:cNvSpPr>
+          <p:nvPr>
+            <p:ph type="sldNum" sz="quarter" idx="10"/>
+          </p:nvPr>
+        </p:nvSpPr>
+        <p:spPr/>
+        <p:txBody>
+          <a:bodyPr/>
+          <a:lstStyle/>
+          <a:p>
+            <a:fld id="{F7021451-1387-4CA6-816F-3879F97B5CBC}" type="slidenum">
+              <a:rPr lang="en-US"/>
+              <a:t>12</a:t>
+            </a:fld>
+            <a:endParaRPr lang="en-US"/>
+          </a:p>
+        </p:txBody>
+      </p:sp>
+    </p:spTree>
+    <p:extLst>
+      <p:ext uri="{BB962C8B-B14F-4D97-AF65-F5344CB8AC3E}">
+        <p14:creationId xmlns:p14="http://schemas.microsoft.com/office/powerpoint/2010/main" val="1024086991"/>
+      </p:ext>
+    </p:extLst>
+  </p:cSld>
+  <p:clrMapOvr>
+    <a:masterClrMapping/>
+  </p:clrMapOvr>
+</p:notes>
+</file>
+
+<file path=ppt/notesSlides/notesSlide13.xml><?xml version="1.0" encoding="utf-8"?>
+<p:notes xmlns:a="http://schemas.openxmlformats.org/drawingml/2006/main" xmlns:r="http://schemas.openxmlformats.org/officeDocument/2006/relationships" xmlns:p="http://schemas.openxmlformats.org/presentationml/2006/main">
+  <p:cSld>
+    <p:spTree>
+      <p:nvGrpSpPr>
+        <p:cNvPr id="1" name=""/>
+        <p:cNvGrpSpPr/>
+        <p:nvPr/>
+      </p:nvGrpSpPr>
+      <p:grpSpPr>
+        <a:xfrm>
+          <a:off x="0" y="0"/>
+          <a:ext cx="0" cy="0"/>
+          <a:chOff x="0" y="0"/>
+          <a:chExt cx="0" cy="0"/>
+        </a:xfrm>
+      </p:grpSpPr>
+      <p:sp>
+        <p:nvSpPr>
+          <p:cNvPr id="2" name="Slide Image Placeholder 1"/>
+          <p:cNvSpPr>
+            <a:spLocks noGrp="1" noRot="1" noChangeAspect="1"/>
+          </p:cNvSpPr>
+          <p:nvPr>
+            <p:ph type="sldImg"/>
+          </p:nvPr>
+        </p:nvSpPr>
+        <p:spPr/>
+      </p:sp>
+      <p:sp>
+        <p:nvSpPr>
+          <p:cNvPr id="3" name="Notes Placeholder 2"/>
+          <p:cNvSpPr>
+            <a:spLocks noGrp="1"/>
+          </p:cNvSpPr>
+          <p:nvPr>
+            <p:ph type="body" idx="1"/>
+          </p:nvPr>
+        </p:nvSpPr>
+        <p:spPr/>
+        <p:txBody>
+          <a:bodyPr/>
+          <a:lstStyle/>
+          <a:p>
+            <a:r>
+              <a:rPr lang="en-US" dirty="0"/>
+              <a:t/>
+            </a:r>
+            <a:endParaRPr lang="en-US" dirty="0"/>
+          </a:p>
+        </p:txBody>
+      </p:sp>
+      <p:sp>
+        <p:nvSpPr>
+          <p:cNvPr id="4" name="Slide Number Placeholder 3"/>
+          <p:cNvSpPr>
+            <a:spLocks noGrp="1"/>
+          </p:cNvSpPr>
+          <p:nvPr>
+            <p:ph type="sldNum" sz="quarter" idx="10"/>
+          </p:nvPr>
+        </p:nvSpPr>
+        <p:spPr/>
+        <p:txBody>
+          <a:bodyPr/>
+          <a:lstStyle/>
+          <a:p>
+            <a:fld id="{F7021451-1387-4CA6-816F-3879F97B5CBC}" type="slidenum">
+              <a:rPr lang="en-US"/>
+              <a:t>13</a:t>
             </a:fld>
             <a:endParaRPr lang="en-US"/>
           </a:p>
@@ -2072,6 +2339,2763 @@
       </p:grpSpPr>
       <p:sp>
         <p:nvSpPr>
+          <p:cNvPr id="2" name="Text 0"/>
+          <p:cNvSpPr/>
+          <p:nvPr/>
+        </p:nvSpPr>
+        <p:spPr>
+          <a:xfrm>
+            <a:off x="640080" y="502920"/>
+            <a:ext cx="7315200" cy="274320"/>
+          </a:xfrm>
+          <a:prstGeom prst="rect">
+            <a:avLst/>
+          </a:prstGeom>
+          <a:noFill/>
+          <a:ln/>
+        </p:spPr>
+        <p:txBody>
+          <a:bodyPr wrap="square" lIns="0" tIns="0" rIns="0" bIns="0" rtlCol="0" anchor="ctr"/>
+          <a:lstStyle/>
+          <a:p>
+            <a:pPr indent="0" marL="0">
+              <a:buNone/>
+            </a:pPr>
+            <a:r>
+              <a:rPr lang="en-US" sz="1200" spc="300" kern="0" dirty="0">
+                <a:solidFill>
+                  <a:srgbClr val="34D3BD"/>
+                </a:solidFill>
+                <a:latin typeface="Consolas" pitchFamily="34" charset="0"/>
+                <a:ea typeface="Consolas" pitchFamily="34" charset="-122"/>
+                <a:cs typeface="Consolas" pitchFamily="34" charset="-120"/>
+              </a:rPr>
+              <a:t>GO TO MARKET</a:t>
+            </a:r>
+            <a:endParaRPr lang="en-US" sz="1200" dirty="0"/>
+          </a:p>
+        </p:txBody>
+      </p:sp>
+      <p:sp>
+        <p:nvSpPr>
+          <p:cNvPr id="3" name="Text 1"/>
+          <p:cNvSpPr/>
+          <p:nvPr/>
+        </p:nvSpPr>
+        <p:spPr>
+          <a:xfrm>
+            <a:off x="640080" y="841248"/>
+            <a:ext cx="10972800" cy="822960"/>
+          </a:xfrm>
+          <a:prstGeom prst="rect">
+            <a:avLst/>
+          </a:prstGeom>
+          <a:noFill/>
+          <a:ln/>
+        </p:spPr>
+        <p:txBody>
+          <a:bodyPr wrap="square" lIns="0" tIns="0" rIns="0" bIns="0" rtlCol="0" anchor="ctr"/>
+          <a:lstStyle/>
+          <a:p>
+            <a:pPr indent="0" marL="0">
+              <a:buNone/>
+            </a:pPr>
+            <a:r>
+              <a:rPr lang="en-US" sz="3400" b="1" dirty="0">
+                <a:solidFill>
+                  <a:srgbClr val="EAF2FA"/>
+                </a:solidFill>
+                <a:latin typeface="Trebuchet MS" pitchFamily="34" charset="0"/>
+                <a:ea typeface="Trebuchet MS" pitchFamily="34" charset="-122"/>
+                <a:cs typeface="Trebuchet MS" pitchFamily="34" charset="-120"/>
+              </a:rPr>
+              <a:t>A wedge, a buyer, a trigger</a:t>
+            </a:r>
+            <a:endParaRPr lang="en-US" sz="3400" dirty="0"/>
+          </a:p>
+        </p:txBody>
+      </p:sp>
+      <p:sp>
+        <p:nvSpPr>
+          <p:cNvPr id="4" name="Shape 2"/>
+          <p:cNvSpPr/>
+          <p:nvPr/>
+        </p:nvSpPr>
+        <p:spPr>
+          <a:xfrm>
+            <a:off x="640080" y="2103120"/>
+            <a:ext cx="10908792" cy="841248"/>
+          </a:xfrm>
+          <a:prstGeom prst="roundRect">
+            <a:avLst>
+              <a:gd name="adj" fmla="val 9783"/>
+            </a:avLst>
+          </a:prstGeom>
+          <a:solidFill>
+            <a:srgbClr val="10161E"/>
+          </a:solidFill>
+          <a:ln w="12700">
+            <a:solidFill>
+              <a:srgbClr val="26313E"/>
+            </a:solidFill>
+            <a:prstDash val="solid"/>
+          </a:ln>
+        </p:spPr>
+      </p:sp>
+      <p:sp>
+        <p:nvSpPr>
+          <p:cNvPr id="5" name="Shape 3"/>
+          <p:cNvSpPr/>
+          <p:nvPr/>
+        </p:nvSpPr>
+        <p:spPr>
+          <a:xfrm>
+            <a:off x="640080" y="2103120"/>
+            <a:ext cx="64008" cy="841248"/>
+          </a:xfrm>
+          <a:prstGeom prst="rect">
+            <a:avLst/>
+          </a:prstGeom>
+          <a:solidFill>
+            <a:srgbClr val="34D3BD"/>
+          </a:solidFill>
+          <a:ln/>
+        </p:spPr>
+      </p:sp>
+      <p:sp>
+        <p:nvSpPr>
+          <p:cNvPr id="6" name="Text 4"/>
+          <p:cNvSpPr/>
+          <p:nvPr/>
+        </p:nvSpPr>
+        <p:spPr>
+          <a:xfrm>
+            <a:off x="914400" y="2212848"/>
+            <a:ext cx="1828800" cy="621792"/>
+          </a:xfrm>
+          <a:prstGeom prst="rect">
+            <a:avLst/>
+          </a:prstGeom>
+          <a:noFill/>
+          <a:ln/>
+        </p:spPr>
+        <p:txBody>
+          <a:bodyPr wrap="square" lIns="0" tIns="0" rIns="0" bIns="0" rtlCol="0" anchor="ctr"/>
+          <a:lstStyle/>
+          <a:p>
+            <a:pPr indent="0" marL="0">
+              <a:buNone/>
+            </a:pPr>
+            <a:r>
+              <a:rPr lang="en-US" sz="1700" b="1" dirty="0">
+                <a:solidFill>
+                  <a:srgbClr val="34D3BD"/>
+                </a:solidFill>
+                <a:latin typeface="Trebuchet MS" pitchFamily="34" charset="0"/>
+                <a:ea typeface="Trebuchet MS" pitchFamily="34" charset="-122"/>
+                <a:cs typeface="Trebuchet MS" pitchFamily="34" charset="-120"/>
+              </a:rPr>
+              <a:t>Buyer</a:t>
+            </a:r>
+            <a:endParaRPr lang="en-US" sz="1700" dirty="0"/>
+          </a:p>
+        </p:txBody>
+      </p:sp>
+      <p:sp>
+        <p:nvSpPr>
+          <p:cNvPr id="7" name="Text 5"/>
+          <p:cNvSpPr/>
+          <p:nvPr/>
+        </p:nvSpPr>
+        <p:spPr>
+          <a:xfrm>
+            <a:off x="2743200" y="2212848"/>
+            <a:ext cx="8595360" cy="621792"/>
+          </a:xfrm>
+          <a:prstGeom prst="rect">
+            <a:avLst/>
+          </a:prstGeom>
+          <a:noFill/>
+          <a:ln/>
+        </p:spPr>
+        <p:txBody>
+          <a:bodyPr wrap="square" lIns="0" tIns="0" rIns="0" bIns="0" rtlCol="0" anchor="ctr"/>
+          <a:lstStyle/>
+          <a:p>
+            <a:pPr indent="0" marL="0">
+              <a:buNone/>
+            </a:pPr>
+            <a:r>
+              <a:rPr lang="en-US" sz="1400" dirty="0">
+                <a:solidFill>
+                  <a:srgbClr val="C8D3DE"/>
+                </a:solidFill>
+                <a:latin typeface="Calibri" pitchFamily="34" charset="0"/>
+                <a:ea typeface="Calibri" pitchFamily="34" charset="-122"/>
+                <a:cs typeface="Calibri" pitchFamily="34" charset="-120"/>
+              </a:rPr>
+              <a:t>Plant process-safety head / safety officer — owns permit-to-work and statutory compliance, carries the fatality risk.</a:t>
+            </a:r>
+            <a:endParaRPr lang="en-US" sz="1400" dirty="0"/>
+          </a:p>
+        </p:txBody>
+      </p:sp>
+      <p:sp>
+        <p:nvSpPr>
+          <p:cNvPr id="8" name="Shape 6"/>
+          <p:cNvSpPr/>
+          <p:nvPr/>
+        </p:nvSpPr>
+        <p:spPr>
+          <a:xfrm>
+            <a:off x="640080" y="3054096"/>
+            <a:ext cx="10908792" cy="841248"/>
+          </a:xfrm>
+          <a:prstGeom prst="roundRect">
+            <a:avLst>
+              <a:gd name="adj" fmla="val 9783"/>
+            </a:avLst>
+          </a:prstGeom>
+          <a:solidFill>
+            <a:srgbClr val="10161E"/>
+          </a:solidFill>
+          <a:ln w="12700">
+            <a:solidFill>
+              <a:srgbClr val="26313E"/>
+            </a:solidFill>
+            <a:prstDash val="solid"/>
+          </a:ln>
+        </p:spPr>
+      </p:sp>
+      <p:sp>
+        <p:nvSpPr>
+          <p:cNvPr id="9" name="Shape 7"/>
+          <p:cNvSpPr/>
+          <p:nvPr/>
+        </p:nvSpPr>
+        <p:spPr>
+          <a:xfrm>
+            <a:off x="640080" y="3054096"/>
+            <a:ext cx="64008" cy="841248"/>
+          </a:xfrm>
+          <a:prstGeom prst="rect">
+            <a:avLst/>
+          </a:prstGeom>
+          <a:solidFill>
+            <a:srgbClr val="EAF2FA"/>
+          </a:solidFill>
+          <a:ln/>
+        </p:spPr>
+      </p:sp>
+      <p:sp>
+        <p:nvSpPr>
+          <p:cNvPr id="10" name="Text 8"/>
+          <p:cNvSpPr/>
+          <p:nvPr/>
+        </p:nvSpPr>
+        <p:spPr>
+          <a:xfrm>
+            <a:off x="914400" y="3163824"/>
+            <a:ext cx="1828800" cy="621792"/>
+          </a:xfrm>
+          <a:prstGeom prst="rect">
+            <a:avLst/>
+          </a:prstGeom>
+          <a:noFill/>
+          <a:ln/>
+        </p:spPr>
+        <p:txBody>
+          <a:bodyPr wrap="square" lIns="0" tIns="0" rIns="0" bIns="0" rtlCol="0" anchor="ctr"/>
+          <a:lstStyle/>
+          <a:p>
+            <a:pPr indent="0" marL="0">
+              <a:buNone/>
+            </a:pPr>
+            <a:r>
+              <a:rPr lang="en-US" sz="1700" b="1" dirty="0">
+                <a:solidFill>
+                  <a:srgbClr val="EAF2FA"/>
+                </a:solidFill>
+                <a:latin typeface="Trebuchet MS" pitchFamily="34" charset="0"/>
+                <a:ea typeface="Trebuchet MS" pitchFamily="34" charset="-122"/>
+                <a:cs typeface="Trebuchet MS" pitchFamily="34" charset="-120"/>
+              </a:rPr>
+              <a:t>Wedge</a:t>
+            </a:r>
+            <a:endParaRPr lang="en-US" sz="1700" dirty="0"/>
+          </a:p>
+        </p:txBody>
+      </p:sp>
+      <p:sp>
+        <p:nvSpPr>
+          <p:cNvPr id="11" name="Text 9"/>
+          <p:cNvSpPr/>
+          <p:nvPr/>
+        </p:nvSpPr>
+        <p:spPr>
+          <a:xfrm>
+            <a:off x="2743200" y="3163824"/>
+            <a:ext cx="8595360" cy="621792"/>
+          </a:xfrm>
+          <a:prstGeom prst="rect">
+            <a:avLst/>
+          </a:prstGeom>
+          <a:noFill/>
+          <a:ln/>
+        </p:spPr>
+        <p:txBody>
+          <a:bodyPr wrap="square" lIns="0" tIns="0" rIns="0" bIns="0" rtlCol="0" anchor="ctr"/>
+          <a:lstStyle/>
+          <a:p>
+            <a:pPr indent="0" marL="0">
+              <a:buNone/>
+            </a:pPr>
+            <a:r>
+              <a:rPr lang="en-US" sz="1400" dirty="0">
+                <a:solidFill>
+                  <a:srgbClr val="C8D3DE"/>
+                </a:solidFill>
+                <a:latin typeface="Calibri" pitchFamily="34" charset="0"/>
+                <a:ea typeface="Calibri" pitchFamily="34" charset="-122"/>
+                <a:cs typeface="Calibri" pitchFamily="34" charset="-120"/>
+              </a:rPr>
+              <a:t>Permit-to-work intelligence — one discrete, fundable pain — then expand to full gas + permit + CCTV + shift fusion.</a:t>
+            </a:r>
+            <a:endParaRPr lang="en-US" sz="1400" dirty="0"/>
+          </a:p>
+        </p:txBody>
+      </p:sp>
+      <p:sp>
+        <p:nvSpPr>
+          <p:cNvPr id="12" name="Shape 10"/>
+          <p:cNvSpPr/>
+          <p:nvPr/>
+        </p:nvSpPr>
+        <p:spPr>
+          <a:xfrm>
+            <a:off x="640080" y="4005072"/>
+            <a:ext cx="10908792" cy="841248"/>
+          </a:xfrm>
+          <a:prstGeom prst="roundRect">
+            <a:avLst>
+              <a:gd name="adj" fmla="val 9783"/>
+            </a:avLst>
+          </a:prstGeom>
+          <a:solidFill>
+            <a:srgbClr val="10161E"/>
+          </a:solidFill>
+          <a:ln w="12700">
+            <a:solidFill>
+              <a:srgbClr val="26313E"/>
+            </a:solidFill>
+            <a:prstDash val="solid"/>
+          </a:ln>
+        </p:spPr>
+      </p:sp>
+      <p:sp>
+        <p:nvSpPr>
+          <p:cNvPr id="13" name="Shape 11"/>
+          <p:cNvSpPr/>
+          <p:nvPr/>
+        </p:nvSpPr>
+        <p:spPr>
+          <a:xfrm>
+            <a:off x="640080" y="4005072"/>
+            <a:ext cx="64008" cy="841248"/>
+          </a:xfrm>
+          <a:prstGeom prst="rect">
+            <a:avLst/>
+          </a:prstGeom>
+          <a:solidFill>
+            <a:srgbClr val="EAF2FA"/>
+          </a:solidFill>
+          <a:ln/>
+        </p:spPr>
+      </p:sp>
+      <p:sp>
+        <p:nvSpPr>
+          <p:cNvPr id="14" name="Text 12"/>
+          <p:cNvSpPr/>
+          <p:nvPr/>
+        </p:nvSpPr>
+        <p:spPr>
+          <a:xfrm>
+            <a:off x="914400" y="4114800"/>
+            <a:ext cx="1828800" cy="621792"/>
+          </a:xfrm>
+          <a:prstGeom prst="rect">
+            <a:avLst/>
+          </a:prstGeom>
+          <a:noFill/>
+          <a:ln/>
+        </p:spPr>
+        <p:txBody>
+          <a:bodyPr wrap="square" lIns="0" tIns="0" rIns="0" bIns="0" rtlCol="0" anchor="ctr"/>
+          <a:lstStyle/>
+          <a:p>
+            <a:pPr indent="0" marL="0">
+              <a:buNone/>
+            </a:pPr>
+            <a:r>
+              <a:rPr lang="en-US" sz="1700" b="1" dirty="0">
+                <a:solidFill>
+                  <a:srgbClr val="EAF2FA"/>
+                </a:solidFill>
+                <a:latin typeface="Trebuchet MS" pitchFamily="34" charset="0"/>
+                <a:ea typeface="Trebuchet MS" pitchFamily="34" charset="-122"/>
+                <a:cs typeface="Trebuchet MS" pitchFamily="34" charset="-120"/>
+              </a:rPr>
+              <a:t>Pricing</a:t>
+            </a:r>
+            <a:endParaRPr lang="en-US" sz="1700" dirty="0"/>
+          </a:p>
+        </p:txBody>
+      </p:sp>
+      <p:sp>
+        <p:nvSpPr>
+          <p:cNvPr id="15" name="Text 13"/>
+          <p:cNvSpPr/>
+          <p:nvPr/>
+        </p:nvSpPr>
+        <p:spPr>
+          <a:xfrm>
+            <a:off x="2743200" y="4114800"/>
+            <a:ext cx="8595360" cy="621792"/>
+          </a:xfrm>
+          <a:prstGeom prst="rect">
+            <a:avLst/>
+          </a:prstGeom>
+          <a:noFill/>
+          <a:ln/>
+        </p:spPr>
+        <p:txBody>
+          <a:bodyPr wrap="square" lIns="0" tIns="0" rIns="0" bIns="0" rtlCol="0" anchor="ctr"/>
+          <a:lstStyle/>
+          <a:p>
+            <a:pPr indent="0" marL="0">
+              <a:buNone/>
+            </a:pPr>
+            <a:r>
+              <a:rPr lang="en-US" sz="1400" dirty="0">
+                <a:solidFill>
+                  <a:srgbClr val="C8D3DE"/>
+                </a:solidFill>
+                <a:latin typeface="Calibri" pitchFamily="34" charset="0"/>
+                <a:ea typeface="Calibri" pitchFamily="34" charset="-122"/>
+                <a:cs typeface="Calibri" pitchFamily="34" charset="-120"/>
+              </a:rPr>
+              <a:t>~₹1 Cr / plant / yr — justified against a single downtime-day (~₹3 Cr) or one OISD / NGT penalty.</a:t>
+            </a:r>
+            <a:endParaRPr lang="en-US" sz="1400" dirty="0"/>
+          </a:p>
+        </p:txBody>
+      </p:sp>
+      <p:sp>
+        <p:nvSpPr>
+          <p:cNvPr id="16" name="Shape 14"/>
+          <p:cNvSpPr/>
+          <p:nvPr/>
+        </p:nvSpPr>
+        <p:spPr>
+          <a:xfrm>
+            <a:off x="640080" y="4956048"/>
+            <a:ext cx="10908792" cy="841248"/>
+          </a:xfrm>
+          <a:prstGeom prst="roundRect">
+            <a:avLst>
+              <a:gd name="adj" fmla="val 9783"/>
+            </a:avLst>
+          </a:prstGeom>
+          <a:solidFill>
+            <a:srgbClr val="10161E"/>
+          </a:solidFill>
+          <a:ln w="12700">
+            <a:solidFill>
+              <a:srgbClr val="26313E"/>
+            </a:solidFill>
+            <a:prstDash val="solid"/>
+          </a:ln>
+        </p:spPr>
+      </p:sp>
+      <p:sp>
+        <p:nvSpPr>
+          <p:cNvPr id="17" name="Shape 15"/>
+          <p:cNvSpPr/>
+          <p:nvPr/>
+        </p:nvSpPr>
+        <p:spPr>
+          <a:xfrm>
+            <a:off x="640080" y="4956048"/>
+            <a:ext cx="64008" cy="841248"/>
+          </a:xfrm>
+          <a:prstGeom prst="rect">
+            <a:avLst/>
+          </a:prstGeom>
+          <a:solidFill>
+            <a:srgbClr val="E8862F"/>
+          </a:solidFill>
+          <a:ln/>
+        </p:spPr>
+      </p:sp>
+      <p:sp>
+        <p:nvSpPr>
+          <p:cNvPr id="18" name="Text 16"/>
+          <p:cNvSpPr/>
+          <p:nvPr/>
+        </p:nvSpPr>
+        <p:spPr>
+          <a:xfrm>
+            <a:off x="914400" y="5065776"/>
+            <a:ext cx="1828800" cy="621792"/>
+          </a:xfrm>
+          <a:prstGeom prst="rect">
+            <a:avLst/>
+          </a:prstGeom>
+          <a:noFill/>
+          <a:ln/>
+        </p:spPr>
+        <p:txBody>
+          <a:bodyPr wrap="square" lIns="0" tIns="0" rIns="0" bIns="0" rtlCol="0" anchor="ctr"/>
+          <a:lstStyle/>
+          <a:p>
+            <a:pPr indent="0" marL="0">
+              <a:buNone/>
+            </a:pPr>
+            <a:r>
+              <a:rPr lang="en-US" sz="1700" b="1" dirty="0">
+                <a:solidFill>
+                  <a:srgbClr val="E8862F"/>
+                </a:solidFill>
+                <a:latin typeface="Trebuchet MS" pitchFamily="34" charset="0"/>
+                <a:ea typeface="Trebuchet MS" pitchFamily="34" charset="-122"/>
+                <a:cs typeface="Trebuchet MS" pitchFamily="34" charset="-120"/>
+              </a:rPr>
+              <a:t>Trigger</a:t>
+            </a:r>
+            <a:endParaRPr lang="en-US" sz="1700" dirty="0"/>
+          </a:p>
+        </p:txBody>
+      </p:sp>
+      <p:sp>
+        <p:nvSpPr>
+          <p:cNvPr id="19" name="Text 17"/>
+          <p:cNvSpPr/>
+          <p:nvPr/>
+        </p:nvSpPr>
+        <p:spPr>
+          <a:xfrm>
+            <a:off x="2743200" y="5065776"/>
+            <a:ext cx="8595360" cy="621792"/>
+          </a:xfrm>
+          <a:prstGeom prst="rect">
+            <a:avLst/>
+          </a:prstGeom>
+          <a:noFill/>
+          <a:ln/>
+        </p:spPr>
+        <p:txBody>
+          <a:bodyPr wrap="square" lIns="0" tIns="0" rIns="0" bIns="0" rtlCol="0" anchor="ctr"/>
+          <a:lstStyle/>
+          <a:p>
+            <a:pPr indent="0" marL="0">
+              <a:buNone/>
+            </a:pPr>
+            <a:r>
+              <a:rPr lang="en-US" sz="1400" dirty="0">
+                <a:solidFill>
+                  <a:srgbClr val="C8D3DE"/>
+                </a:solidFill>
+                <a:latin typeface="Calibri" pitchFamily="34" charset="0"/>
+                <a:ea typeface="Calibri" pitchFamily="34" charset="-122"/>
+                <a:cs typeface="Calibri" pitchFamily="34" charset="-120"/>
+              </a:rPr>
+              <a:t>Post-LG-Polymers / Vizag regulatory pressure — DGMS scrutiny and mandatory near-miss reporting.</a:t>
+            </a:r>
+            <a:endParaRPr lang="en-US" sz="1400" dirty="0"/>
+          </a:p>
+        </p:txBody>
+      </p:sp>
+      <p:sp>
+        <p:nvSpPr>
+          <p:cNvPr id="20" name="Shape 18"/>
+          <p:cNvSpPr/>
+          <p:nvPr/>
+        </p:nvSpPr>
+        <p:spPr>
+          <a:xfrm>
+            <a:off x="640080" y="5943600"/>
+            <a:ext cx="10908792" cy="640080"/>
+          </a:xfrm>
+          <a:prstGeom prst="roundRect">
+            <a:avLst>
+              <a:gd name="adj" fmla="val 12857"/>
+            </a:avLst>
+          </a:prstGeom>
+          <a:solidFill>
+            <a:srgbClr val="0C1218"/>
+          </a:solidFill>
+          <a:ln w="12700">
+            <a:solidFill>
+              <a:srgbClr val="34D3BD"/>
+            </a:solidFill>
+            <a:prstDash val="solid"/>
+          </a:ln>
+        </p:spPr>
+      </p:sp>
+      <p:sp>
+        <p:nvSpPr>
+          <p:cNvPr id="21" name="Text 19"/>
+          <p:cNvSpPr/>
+          <p:nvPr/>
+        </p:nvSpPr>
+        <p:spPr>
+          <a:xfrm>
+            <a:off x="914400" y="5943600"/>
+            <a:ext cx="10332720" cy="640080"/>
+          </a:xfrm>
+          <a:prstGeom prst="rect">
+            <a:avLst/>
+          </a:prstGeom>
+          <a:noFill/>
+          <a:ln/>
+        </p:spPr>
+        <p:txBody>
+          <a:bodyPr wrap="square" lIns="0" tIns="0" rIns="0" bIns="0" rtlCol="0" anchor="ctr"/>
+          <a:lstStyle/>
+          <a:p>
+            <a:pPr indent="0" marL="0">
+              <a:buNone/>
+            </a:pPr>
+            <a:r>
+              <a:rPr lang="en-US" sz="1400" b="1" dirty="0">
+                <a:solidFill>
+                  <a:srgbClr val="34D3BD"/>
+                </a:solidFill>
+                <a:latin typeface="Calibri" pitchFamily="34" charset="0"/>
+                <a:ea typeface="Calibri" pitchFamily="34" charset="-122"/>
+                <a:cs typeface="Calibri" pitchFamily="34" charset="-120"/>
+              </a:rPr>
+              <a:t>The ask:  </a:t>
+            </a:r>
+            <a:pPr indent="0" marL="0">
+              <a:buNone/>
+            </a:pPr>
+            <a:r>
+              <a:rPr lang="en-US" sz="1400" dirty="0">
+                <a:solidFill>
+                  <a:srgbClr val="EAF2FA"/>
+                </a:solidFill>
+                <a:latin typeface="Calibri" pitchFamily="34" charset="0"/>
+                <a:ea typeface="Calibri" pitchFamily="34" charset="-122"/>
+                <a:cs typeface="Calibri" pitchFamily="34" charset="-120"/>
+              </a:rPr>
+              <a:t>1–2 design partners (steel / refining) for a 90-day pilot on a live permit-to-work + gas feed.</a:t>
+            </a:r>
+            <a:endParaRPr lang="en-US" sz="1400" dirty="0"/>
+          </a:p>
+        </p:txBody>
+      </p:sp>
+    </p:spTree>
+  </p:cSld>
+  <p:clrMapOvr>
+    <a:masterClrMapping/>
+  </p:clrMapOvr>
+</p:sld>
+</file>
+
+<file path=ppt/slides/slide11.xml><?xml version="1.0" encoding="utf-8"?>
+<p:sld xmlns:a="http://schemas.openxmlformats.org/drawingml/2006/main" xmlns:r="http://schemas.openxmlformats.org/officeDocument/2006/relationships" xmlns:p="http://schemas.openxmlformats.org/presentationml/2006/main">
+  <p:cSld name="Slide 11">
+    <p:bg>
+      <p:bgPr>
+        <a:solidFill>
+          <a:srgbClr val="0B0F14"/>
+        </a:solidFill>
+      </p:bgPr>
+    </p:bg>
+    <p:spTree>
+      <p:nvGrpSpPr>
+        <p:cNvPr id="1" name=""/>
+        <p:cNvGrpSpPr/>
+        <p:nvPr/>
+      </p:nvGrpSpPr>
+      <p:grpSpPr>
+        <a:xfrm>
+          <a:off x="0" y="0"/>
+          <a:ext cx="0" cy="0"/>
+          <a:chOff x="0" y="0"/>
+          <a:chExt cx="0" cy="0"/>
+        </a:xfrm>
+      </p:grpSpPr>
+      <p:sp>
+        <p:nvSpPr>
+          <p:cNvPr id="2" name="Text 0"/>
+          <p:cNvSpPr/>
+          <p:nvPr/>
+        </p:nvSpPr>
+        <p:spPr>
+          <a:xfrm>
+            <a:off x="640080" y="502920"/>
+            <a:ext cx="7315200" cy="274320"/>
+          </a:xfrm>
+          <a:prstGeom prst="rect">
+            <a:avLst/>
+          </a:prstGeom>
+          <a:noFill/>
+          <a:ln/>
+        </p:spPr>
+        <p:txBody>
+          <a:bodyPr wrap="square" lIns="0" tIns="0" rIns="0" bIns="0" rtlCol="0" anchor="ctr"/>
+          <a:lstStyle/>
+          <a:p>
+            <a:pPr indent="0" marL="0">
+              <a:buNone/>
+            </a:pPr>
+            <a:r>
+              <a:rPr lang="en-US" sz="1200" spc="300" kern="0" dirty="0">
+                <a:solidFill>
+                  <a:srgbClr val="34D3BD"/>
+                </a:solidFill>
+                <a:latin typeface="Consolas" pitchFamily="34" charset="0"/>
+                <a:ea typeface="Consolas" pitchFamily="34" charset="-122"/>
+                <a:cs typeface="Consolas" pitchFamily="34" charset="-120"/>
+              </a:rPr>
+              <a:t>SCALE &amp; DEPLOY</a:t>
+            </a:r>
+            <a:endParaRPr lang="en-US" sz="1200" dirty="0"/>
+          </a:p>
+        </p:txBody>
+      </p:sp>
+      <p:sp>
+        <p:nvSpPr>
+          <p:cNvPr id="3" name="Text 1"/>
+          <p:cNvSpPr/>
+          <p:nvPr/>
+        </p:nvSpPr>
+        <p:spPr>
+          <a:xfrm>
+            <a:off x="640080" y="841248"/>
+            <a:ext cx="10972800" cy="822960"/>
+          </a:xfrm>
+          <a:prstGeom prst="rect">
+            <a:avLst/>
+          </a:prstGeom>
+          <a:noFill/>
+          <a:ln/>
+        </p:spPr>
+        <p:txBody>
+          <a:bodyPr wrap="square" lIns="0" tIns="0" rIns="0" bIns="0" rtlCol="0" anchor="ctr"/>
+          <a:lstStyle/>
+          <a:p>
+            <a:pPr indent="0" marL="0">
+              <a:buNone/>
+            </a:pPr>
+            <a:r>
+              <a:rPr lang="en-US" sz="3400" b="1" dirty="0">
+                <a:solidFill>
+                  <a:srgbClr val="EAF2FA"/>
+                </a:solidFill>
+                <a:latin typeface="Trebuchet MS" pitchFamily="34" charset="0"/>
+                <a:ea typeface="Trebuchet MS" pitchFamily="34" charset="-122"/>
+                <a:cs typeface="Trebuchet MS" pitchFamily="34" charset="-120"/>
+              </a:rPr>
+              <a:t>Sits over the sensors you already have</a:t>
+            </a:r>
+            <a:endParaRPr lang="en-US" sz="3400" dirty="0"/>
+          </a:p>
+        </p:txBody>
+      </p:sp>
+      <p:sp>
+        <p:nvSpPr>
+          <p:cNvPr id="4" name="Shape 2"/>
+          <p:cNvSpPr/>
+          <p:nvPr/>
+        </p:nvSpPr>
+        <p:spPr>
+          <a:xfrm>
+            <a:off x="640080" y="2148840"/>
+            <a:ext cx="6217920" cy="1143000"/>
+          </a:xfrm>
+          <a:prstGeom prst="roundRect">
+            <a:avLst>
+              <a:gd name="adj" fmla="val 7200"/>
+            </a:avLst>
+          </a:prstGeom>
+          <a:solidFill>
+            <a:srgbClr val="10161E"/>
+          </a:solidFill>
+          <a:ln w="12700">
+            <a:solidFill>
+              <a:srgbClr val="26313E"/>
+            </a:solidFill>
+            <a:prstDash val="solid"/>
+          </a:ln>
+        </p:spPr>
+      </p:sp>
+      <p:sp>
+        <p:nvSpPr>
+          <p:cNvPr id="5" name="Shape 3"/>
+          <p:cNvSpPr/>
+          <p:nvPr/>
+        </p:nvSpPr>
+        <p:spPr>
+          <a:xfrm>
+            <a:off x="914400" y="2606040"/>
+            <a:ext cx="182880" cy="182880"/>
+          </a:xfrm>
+          <a:prstGeom prst="ellipse">
+            <a:avLst/>
+          </a:prstGeom>
+          <a:solidFill>
+            <a:srgbClr val="34D3BD"/>
+          </a:solidFill>
+          <a:ln/>
+        </p:spPr>
+      </p:sp>
+      <p:sp>
+        <p:nvSpPr>
+          <p:cNvPr id="6" name="Text 4"/>
+          <p:cNvSpPr/>
+          <p:nvPr/>
+        </p:nvSpPr>
+        <p:spPr>
+          <a:xfrm>
+            <a:off x="1280160" y="2313432"/>
+            <a:ext cx="5394960" cy="365760"/>
+          </a:xfrm>
+          <a:prstGeom prst="rect">
+            <a:avLst/>
+          </a:prstGeom>
+          <a:noFill/>
+          <a:ln/>
+        </p:spPr>
+        <p:txBody>
+          <a:bodyPr wrap="square" lIns="0" tIns="0" rIns="0" bIns="0" rtlCol="0" anchor="ctr"/>
+          <a:lstStyle/>
+          <a:p>
+            <a:pPr indent="0" marL="0">
+              <a:buNone/>
+            </a:pPr>
+            <a:r>
+              <a:rPr lang="en-US" sz="1800" b="1" dirty="0">
+                <a:solidFill>
+                  <a:srgbClr val="EAF2FA"/>
+                </a:solidFill>
+                <a:latin typeface="Trebuchet MS" pitchFamily="34" charset="0"/>
+                <a:ea typeface="Trebuchet MS" pitchFamily="34" charset="-122"/>
+                <a:cs typeface="Trebuchet MS" pitchFamily="34" charset="-120"/>
+              </a:rPr>
+              <a:t>Standard formats</a:t>
+            </a:r>
+            <a:endParaRPr lang="en-US" sz="1800" dirty="0"/>
+          </a:p>
+        </p:txBody>
+      </p:sp>
+      <p:sp>
+        <p:nvSpPr>
+          <p:cNvPr id="7" name="Text 5"/>
+          <p:cNvSpPr/>
+          <p:nvPr/>
+        </p:nvSpPr>
+        <p:spPr>
+          <a:xfrm>
+            <a:off x="1280160" y="2715768"/>
+            <a:ext cx="5394960" cy="457200"/>
+          </a:xfrm>
+          <a:prstGeom prst="rect">
+            <a:avLst/>
+          </a:prstGeom>
+          <a:noFill/>
+          <a:ln/>
+        </p:spPr>
+        <p:txBody>
+          <a:bodyPr wrap="square" lIns="0" tIns="0" rIns="0" bIns="0" rtlCol="0" anchor="ctr"/>
+          <a:lstStyle/>
+          <a:p>
+            <a:pPr indent="0" marL="0">
+              <a:buNone/>
+            </a:pPr>
+            <a:r>
+              <a:rPr lang="en-US" sz="1400" dirty="0">
+                <a:solidFill>
+                  <a:srgbClr val="6B7888"/>
+                </a:solidFill>
+                <a:latin typeface="Calibri" pitchFamily="34" charset="0"/>
+                <a:ea typeface="Calibri" pitchFamily="34" charset="-122"/>
+                <a:cs typeface="Calibri" pitchFamily="34" charset="-120"/>
+              </a:rPr>
+              <a:t>Ingests SCADA / IoT / permit-to-work data as-is</a:t>
+            </a:r>
+            <a:endParaRPr lang="en-US" sz="1400" dirty="0"/>
+          </a:p>
+        </p:txBody>
+      </p:sp>
+      <p:sp>
+        <p:nvSpPr>
+          <p:cNvPr id="8" name="Shape 6"/>
+          <p:cNvSpPr/>
+          <p:nvPr/>
+        </p:nvSpPr>
+        <p:spPr>
+          <a:xfrm>
+            <a:off x="640080" y="3447288"/>
+            <a:ext cx="6217920" cy="1143000"/>
+          </a:xfrm>
+          <a:prstGeom prst="roundRect">
+            <a:avLst>
+              <a:gd name="adj" fmla="val 7200"/>
+            </a:avLst>
+          </a:prstGeom>
+          <a:solidFill>
+            <a:srgbClr val="10161E"/>
+          </a:solidFill>
+          <a:ln w="12700">
+            <a:solidFill>
+              <a:srgbClr val="26313E"/>
+            </a:solidFill>
+            <a:prstDash val="solid"/>
+          </a:ln>
+        </p:spPr>
+      </p:sp>
+      <p:sp>
+        <p:nvSpPr>
+          <p:cNvPr id="9" name="Shape 7"/>
+          <p:cNvSpPr/>
+          <p:nvPr/>
+        </p:nvSpPr>
+        <p:spPr>
+          <a:xfrm>
+            <a:off x="914400" y="3904488"/>
+            <a:ext cx="182880" cy="182880"/>
+          </a:xfrm>
+          <a:prstGeom prst="ellipse">
+            <a:avLst/>
+          </a:prstGeom>
+          <a:solidFill>
+            <a:srgbClr val="34D3BD"/>
+          </a:solidFill>
+          <a:ln/>
+        </p:spPr>
+      </p:sp>
+      <p:sp>
+        <p:nvSpPr>
+          <p:cNvPr id="10" name="Text 8"/>
+          <p:cNvSpPr/>
+          <p:nvPr/>
+        </p:nvSpPr>
+        <p:spPr>
+          <a:xfrm>
+            <a:off x="1280160" y="3611880"/>
+            <a:ext cx="5394960" cy="365760"/>
+          </a:xfrm>
+          <a:prstGeom prst="rect">
+            <a:avLst/>
+          </a:prstGeom>
+          <a:noFill/>
+          <a:ln/>
+        </p:spPr>
+        <p:txBody>
+          <a:bodyPr wrap="square" lIns="0" tIns="0" rIns="0" bIns="0" rtlCol="0" anchor="ctr"/>
+          <a:lstStyle/>
+          <a:p>
+            <a:pPr indent="0" marL="0">
+              <a:buNone/>
+            </a:pPr>
+            <a:r>
+              <a:rPr lang="en-US" sz="1800" b="1" dirty="0">
+                <a:solidFill>
+                  <a:srgbClr val="EAF2FA"/>
+                </a:solidFill>
+                <a:latin typeface="Trebuchet MS" pitchFamily="34" charset="0"/>
+                <a:ea typeface="Trebuchet MS" pitchFamily="34" charset="-122"/>
+                <a:cs typeface="Trebuchet MS" pitchFamily="34" charset="-120"/>
+              </a:rPr>
+              <a:t>A connector, not a rewrite</a:t>
+            </a:r>
+            <a:endParaRPr lang="en-US" sz="1800" dirty="0"/>
+          </a:p>
+        </p:txBody>
+      </p:sp>
+      <p:sp>
+        <p:nvSpPr>
+          <p:cNvPr id="11" name="Text 9"/>
+          <p:cNvSpPr/>
+          <p:nvPr/>
+        </p:nvSpPr>
+        <p:spPr>
+          <a:xfrm>
+            <a:off x="1280160" y="4014216"/>
+            <a:ext cx="5394960" cy="457200"/>
+          </a:xfrm>
+          <a:prstGeom prst="rect">
+            <a:avLst/>
+          </a:prstGeom>
+          <a:noFill/>
+          <a:ln/>
+        </p:spPr>
+        <p:txBody>
+          <a:bodyPr wrap="square" lIns="0" tIns="0" rIns="0" bIns="0" rtlCol="0" anchor="ctr"/>
+          <a:lstStyle/>
+          <a:p>
+            <a:pPr indent="0" marL="0">
+              <a:buNone/>
+            </a:pPr>
+            <a:r>
+              <a:rPr lang="en-US" sz="1400" dirty="0">
+                <a:solidFill>
+                  <a:srgbClr val="6B7888"/>
+                </a:solidFill>
+                <a:latin typeface="Calibri" pitchFamily="34" charset="0"/>
+                <a:ea typeface="Calibri" pitchFamily="34" charset="-122"/>
+                <a:cs typeface="Calibri" pitchFamily="34" charset="-120"/>
+              </a:rPr>
+              <a:t>Digital twin → live plant swaps the data source, not the brain</a:t>
+            </a:r>
+            <a:endParaRPr lang="en-US" sz="1400" dirty="0"/>
+          </a:p>
+        </p:txBody>
+      </p:sp>
+      <p:sp>
+        <p:nvSpPr>
+          <p:cNvPr id="12" name="Shape 10"/>
+          <p:cNvSpPr/>
+          <p:nvPr/>
+        </p:nvSpPr>
+        <p:spPr>
+          <a:xfrm>
+            <a:off x="640080" y="4745736"/>
+            <a:ext cx="6217920" cy="1143000"/>
+          </a:xfrm>
+          <a:prstGeom prst="roundRect">
+            <a:avLst>
+              <a:gd name="adj" fmla="val 7200"/>
+            </a:avLst>
+          </a:prstGeom>
+          <a:solidFill>
+            <a:srgbClr val="10161E"/>
+          </a:solidFill>
+          <a:ln w="12700">
+            <a:solidFill>
+              <a:srgbClr val="26313E"/>
+            </a:solidFill>
+            <a:prstDash val="solid"/>
+          </a:ln>
+        </p:spPr>
+      </p:sp>
+      <p:sp>
+        <p:nvSpPr>
+          <p:cNvPr id="13" name="Shape 11"/>
+          <p:cNvSpPr/>
+          <p:nvPr/>
+        </p:nvSpPr>
+        <p:spPr>
+          <a:xfrm>
+            <a:off x="914400" y="5202936"/>
+            <a:ext cx="182880" cy="182880"/>
+          </a:xfrm>
+          <a:prstGeom prst="ellipse">
+            <a:avLst/>
+          </a:prstGeom>
+          <a:solidFill>
+            <a:srgbClr val="34D3BD"/>
+          </a:solidFill>
+          <a:ln/>
+        </p:spPr>
+      </p:sp>
+      <p:sp>
+        <p:nvSpPr>
+          <p:cNvPr id="14" name="Text 12"/>
+          <p:cNvSpPr/>
+          <p:nvPr/>
+        </p:nvSpPr>
+        <p:spPr>
+          <a:xfrm>
+            <a:off x="1280160" y="4910328"/>
+            <a:ext cx="5394960" cy="365760"/>
+          </a:xfrm>
+          <a:prstGeom prst="rect">
+            <a:avLst/>
+          </a:prstGeom>
+          <a:noFill/>
+          <a:ln/>
+        </p:spPr>
+        <p:txBody>
+          <a:bodyPr wrap="square" lIns="0" tIns="0" rIns="0" bIns="0" rtlCol="0" anchor="ctr"/>
+          <a:lstStyle/>
+          <a:p>
+            <a:pPr indent="0" marL="0">
+              <a:buNone/>
+            </a:pPr>
+            <a:r>
+              <a:rPr lang="en-US" sz="1800" b="1" dirty="0">
+                <a:solidFill>
+                  <a:srgbClr val="EAF2FA"/>
+                </a:solidFill>
+                <a:latin typeface="Trebuchet MS" pitchFamily="34" charset="0"/>
+                <a:ea typeface="Trebuchet MS" pitchFamily="34" charset="-122"/>
+                <a:cs typeface="Trebuchet MS" pitchFamily="34" charset="-120"/>
+              </a:rPr>
+              <a:t>Auditable &amp; hybrid</a:t>
+            </a:r>
+            <a:endParaRPr lang="en-US" sz="1800" dirty="0"/>
+          </a:p>
+        </p:txBody>
+      </p:sp>
+      <p:sp>
+        <p:nvSpPr>
+          <p:cNvPr id="15" name="Text 13"/>
+          <p:cNvSpPr/>
+          <p:nvPr/>
+        </p:nvSpPr>
+        <p:spPr>
+          <a:xfrm>
+            <a:off x="1280160" y="5312664"/>
+            <a:ext cx="5394960" cy="457200"/>
+          </a:xfrm>
+          <a:prstGeom prst="rect">
+            <a:avLst/>
+          </a:prstGeom>
+          <a:noFill/>
+          <a:ln/>
+        </p:spPr>
+        <p:txBody>
+          <a:bodyPr wrap="square" lIns="0" tIns="0" rIns="0" bIns="0" rtlCol="0" anchor="ctr"/>
+          <a:lstStyle/>
+          <a:p>
+            <a:pPr indent="0" marL="0">
+              <a:buNone/>
+            </a:pPr>
+            <a:r>
+              <a:rPr lang="en-US" sz="1400" dirty="0">
+                <a:solidFill>
+                  <a:srgbClr val="6B7888"/>
+                </a:solidFill>
+                <a:latin typeface="Calibri" pitchFamily="34" charset="0"/>
+                <a:ea typeface="Calibri" pitchFamily="34" charset="-122"/>
+                <a:cs typeface="Calibri" pitchFamily="34" charset="-120"/>
+              </a:rPr>
+              <a:t>Deterministic decisions a safety officer can defend in an audit</a:t>
+            </a:r>
+            <a:endParaRPr lang="en-US" sz="1400" dirty="0"/>
+          </a:p>
+        </p:txBody>
+      </p:sp>
+      <p:sp>
+        <p:nvSpPr>
+          <p:cNvPr id="16" name="Shape 14"/>
+          <p:cNvSpPr/>
+          <p:nvPr/>
+        </p:nvSpPr>
+        <p:spPr>
+          <a:xfrm>
+            <a:off x="7223760" y="2148840"/>
+            <a:ext cx="4325112" cy="3694176"/>
+          </a:xfrm>
+          <a:prstGeom prst="roundRect">
+            <a:avLst>
+              <a:gd name="adj" fmla="val 2228"/>
+            </a:avLst>
+          </a:prstGeom>
+          <a:solidFill>
+            <a:srgbClr val="0C1218"/>
+          </a:solidFill>
+          <a:ln w="12700">
+            <a:solidFill>
+              <a:srgbClr val="34D3BD"/>
+            </a:solidFill>
+            <a:prstDash val="solid"/>
+          </a:ln>
+        </p:spPr>
+      </p:sp>
+      <p:sp>
+        <p:nvSpPr>
+          <p:cNvPr id="17" name="Text 15"/>
+          <p:cNvSpPr/>
+          <p:nvPr/>
+        </p:nvSpPr>
+        <p:spPr>
+          <a:xfrm>
+            <a:off x="7498080" y="2377440"/>
+            <a:ext cx="3657600" cy="274320"/>
+          </a:xfrm>
+          <a:prstGeom prst="rect">
+            <a:avLst/>
+          </a:prstGeom>
+          <a:noFill/>
+          <a:ln/>
+        </p:spPr>
+        <p:txBody>
+          <a:bodyPr wrap="square" lIns="0" tIns="0" rIns="0" bIns="0" rtlCol="0" anchor="ctr"/>
+          <a:lstStyle/>
+          <a:p>
+            <a:pPr indent="0" marL="0">
+              <a:buNone/>
+            </a:pPr>
+            <a:r>
+              <a:rPr lang="en-US" sz="1100" spc="200" kern="0" dirty="0">
+                <a:solidFill>
+                  <a:srgbClr val="34D3BD"/>
+                </a:solidFill>
+                <a:latin typeface="Consolas" pitchFamily="34" charset="0"/>
+                <a:ea typeface="Consolas" pitchFamily="34" charset="-122"/>
+                <a:cs typeface="Consolas" pitchFamily="34" charset="-120"/>
+              </a:rPr>
+              <a:t>WHERE IT DEPLOYS</a:t>
+            </a:r>
+            <a:endParaRPr lang="en-US" sz="1100" dirty="0"/>
+          </a:p>
+        </p:txBody>
+      </p:sp>
+      <p:sp>
+        <p:nvSpPr>
+          <p:cNvPr id="18" name="Text 16"/>
+          <p:cNvSpPr/>
+          <p:nvPr/>
+        </p:nvSpPr>
+        <p:spPr>
+          <a:xfrm>
+            <a:off x="7498080" y="2834640"/>
+            <a:ext cx="3840480" cy="320040"/>
+          </a:xfrm>
+          <a:prstGeom prst="rect">
+            <a:avLst/>
+          </a:prstGeom>
+          <a:noFill/>
+          <a:ln/>
+        </p:spPr>
+        <p:txBody>
+          <a:bodyPr wrap="square" lIns="0" tIns="0" rIns="0" bIns="0" rtlCol="0" anchor="ctr"/>
+          <a:lstStyle/>
+          <a:p>
+            <a:pPr indent="0" marL="0">
+              <a:buNone/>
+            </a:pPr>
+            <a:r>
+              <a:rPr lang="en-US" sz="1600" b="1" dirty="0">
+                <a:solidFill>
+                  <a:srgbClr val="EAF2FA"/>
+                </a:solidFill>
+                <a:latin typeface="Trebuchet MS" pitchFamily="34" charset="0"/>
+                <a:ea typeface="Trebuchet MS" pitchFamily="34" charset="-122"/>
+                <a:cs typeface="Trebuchet MS" pitchFamily="34" charset="-120"/>
+              </a:rPr>
+              <a:t>Steel</a:t>
+            </a:r>
+            <a:endParaRPr lang="en-US" sz="1600" dirty="0"/>
+          </a:p>
+        </p:txBody>
+      </p:sp>
+      <p:sp>
+        <p:nvSpPr>
+          <p:cNvPr id="19" name="Text 17"/>
+          <p:cNvSpPr/>
+          <p:nvPr/>
+        </p:nvSpPr>
+        <p:spPr>
+          <a:xfrm>
+            <a:off x="7498080" y="3145536"/>
+            <a:ext cx="3840480" cy="320040"/>
+          </a:xfrm>
+          <a:prstGeom prst="rect">
+            <a:avLst/>
+          </a:prstGeom>
+          <a:noFill/>
+          <a:ln/>
+        </p:spPr>
+        <p:txBody>
+          <a:bodyPr wrap="square" lIns="0" tIns="0" rIns="0" bIns="0" rtlCol="0" anchor="ctr"/>
+          <a:lstStyle/>
+          <a:p>
+            <a:pPr indent="0" marL="0">
+              <a:buNone/>
+            </a:pPr>
+            <a:r>
+              <a:rPr lang="en-US" sz="1200" dirty="0">
+                <a:solidFill>
+                  <a:srgbClr val="6B7888"/>
+                </a:solidFill>
+                <a:latin typeface="Calibri" pitchFamily="34" charset="0"/>
+                <a:ea typeface="Calibri" pitchFamily="34" charset="-122"/>
+                <a:cs typeface="Calibri" pitchFamily="34" charset="-120"/>
+              </a:rPr>
+              <a:t>coke ovens, blast furnaces</a:t>
+            </a:r>
+            <a:endParaRPr lang="en-US" sz="1200" dirty="0"/>
+          </a:p>
+        </p:txBody>
+      </p:sp>
+      <p:sp>
+        <p:nvSpPr>
+          <p:cNvPr id="20" name="Text 18"/>
+          <p:cNvSpPr/>
+          <p:nvPr/>
+        </p:nvSpPr>
+        <p:spPr>
+          <a:xfrm>
+            <a:off x="7498080" y="3584448"/>
+            <a:ext cx="3840480" cy="320040"/>
+          </a:xfrm>
+          <a:prstGeom prst="rect">
+            <a:avLst/>
+          </a:prstGeom>
+          <a:noFill/>
+          <a:ln/>
+        </p:spPr>
+        <p:txBody>
+          <a:bodyPr wrap="square" lIns="0" tIns="0" rIns="0" bIns="0" rtlCol="0" anchor="ctr"/>
+          <a:lstStyle/>
+          <a:p>
+            <a:pPr indent="0" marL="0">
+              <a:buNone/>
+            </a:pPr>
+            <a:r>
+              <a:rPr lang="en-US" sz="1600" b="1" dirty="0">
+                <a:solidFill>
+                  <a:srgbClr val="EAF2FA"/>
+                </a:solidFill>
+                <a:latin typeface="Trebuchet MS" pitchFamily="34" charset="0"/>
+                <a:ea typeface="Trebuchet MS" pitchFamily="34" charset="-122"/>
+                <a:cs typeface="Trebuchet MS" pitchFamily="34" charset="-120"/>
+              </a:rPr>
+              <a:t>Refining &amp; Petrochem</a:t>
+            </a:r>
+            <a:endParaRPr lang="en-US" sz="1600" dirty="0"/>
+          </a:p>
+        </p:txBody>
+      </p:sp>
+      <p:sp>
+        <p:nvSpPr>
+          <p:cNvPr id="21" name="Text 19"/>
+          <p:cNvSpPr/>
+          <p:nvPr/>
+        </p:nvSpPr>
+        <p:spPr>
+          <a:xfrm>
+            <a:off x="7498080" y="3895344"/>
+            <a:ext cx="3840480" cy="320040"/>
+          </a:xfrm>
+          <a:prstGeom prst="rect">
+            <a:avLst/>
+          </a:prstGeom>
+          <a:noFill/>
+          <a:ln/>
+        </p:spPr>
+        <p:txBody>
+          <a:bodyPr wrap="square" lIns="0" tIns="0" rIns="0" bIns="0" rtlCol="0" anchor="ctr"/>
+          <a:lstStyle/>
+          <a:p>
+            <a:pPr indent="0" marL="0">
+              <a:buNone/>
+            </a:pPr>
+            <a:r>
+              <a:rPr lang="en-US" sz="1200" dirty="0">
+                <a:solidFill>
+                  <a:srgbClr val="6B7888"/>
+                </a:solidFill>
+                <a:latin typeface="Calibri" pitchFamily="34" charset="0"/>
+                <a:ea typeface="Calibri" pitchFamily="34" charset="-122"/>
+                <a:cs typeface="Calibri" pitchFamily="34" charset="-120"/>
+              </a:rPr>
+              <a:t>OISD permit-to-work regimes</a:t>
+            </a:r>
+            <a:endParaRPr lang="en-US" sz="1200" dirty="0"/>
+          </a:p>
+        </p:txBody>
+      </p:sp>
+      <p:sp>
+        <p:nvSpPr>
+          <p:cNvPr id="22" name="Text 20"/>
+          <p:cNvSpPr/>
+          <p:nvPr/>
+        </p:nvSpPr>
+        <p:spPr>
+          <a:xfrm>
+            <a:off x="7498080" y="4334256"/>
+            <a:ext cx="3840480" cy="320040"/>
+          </a:xfrm>
+          <a:prstGeom prst="rect">
+            <a:avLst/>
+          </a:prstGeom>
+          <a:noFill/>
+          <a:ln/>
+        </p:spPr>
+        <p:txBody>
+          <a:bodyPr wrap="square" lIns="0" tIns="0" rIns="0" bIns="0" rtlCol="0" anchor="ctr"/>
+          <a:lstStyle/>
+          <a:p>
+            <a:pPr indent="0" marL="0">
+              <a:buNone/>
+            </a:pPr>
+            <a:r>
+              <a:rPr lang="en-US" sz="1600" b="1" dirty="0">
+                <a:solidFill>
+                  <a:srgbClr val="EAF2FA"/>
+                </a:solidFill>
+                <a:latin typeface="Trebuchet MS" pitchFamily="34" charset="0"/>
+                <a:ea typeface="Trebuchet MS" pitchFamily="34" charset="-122"/>
+                <a:cs typeface="Trebuchet MS" pitchFamily="34" charset="-120"/>
+              </a:rPr>
+              <a:t>Mining</a:t>
+            </a:r>
+            <a:endParaRPr lang="en-US" sz="1600" dirty="0"/>
+          </a:p>
+        </p:txBody>
+      </p:sp>
+      <p:sp>
+        <p:nvSpPr>
+          <p:cNvPr id="23" name="Text 21"/>
+          <p:cNvSpPr/>
+          <p:nvPr/>
+        </p:nvSpPr>
+        <p:spPr>
+          <a:xfrm>
+            <a:off x="7498080" y="4645152"/>
+            <a:ext cx="3840480" cy="320040"/>
+          </a:xfrm>
+          <a:prstGeom prst="rect">
+            <a:avLst/>
+          </a:prstGeom>
+          <a:noFill/>
+          <a:ln/>
+        </p:spPr>
+        <p:txBody>
+          <a:bodyPr wrap="square" lIns="0" tIns="0" rIns="0" bIns="0" rtlCol="0" anchor="ctr"/>
+          <a:lstStyle/>
+          <a:p>
+            <a:pPr indent="0" marL="0">
+              <a:buNone/>
+            </a:pPr>
+            <a:r>
+              <a:rPr lang="en-US" sz="1200" dirty="0">
+                <a:solidFill>
+                  <a:srgbClr val="6B7888"/>
+                </a:solidFill>
+                <a:latin typeface="Calibri" pitchFamily="34" charset="0"/>
+                <a:ea typeface="Calibri" pitchFamily="34" charset="-122"/>
+                <a:cs typeface="Calibri" pitchFamily="34" charset="-120"/>
+              </a:rPr>
+              <a:t>confined-space &amp; gas hazards</a:t>
+            </a:r>
+            <a:endParaRPr lang="en-US" sz="1200" dirty="0"/>
+          </a:p>
+        </p:txBody>
+      </p:sp>
+      <p:sp>
+        <p:nvSpPr>
+          <p:cNvPr id="24" name="Text 22"/>
+          <p:cNvSpPr/>
+          <p:nvPr/>
+        </p:nvSpPr>
+        <p:spPr>
+          <a:xfrm>
+            <a:off x="7498080" y="5084064"/>
+            <a:ext cx="3840480" cy="320040"/>
+          </a:xfrm>
+          <a:prstGeom prst="rect">
+            <a:avLst/>
+          </a:prstGeom>
+          <a:noFill/>
+          <a:ln/>
+        </p:spPr>
+        <p:txBody>
+          <a:bodyPr wrap="square" lIns="0" tIns="0" rIns="0" bIns="0" rtlCol="0" anchor="ctr"/>
+          <a:lstStyle/>
+          <a:p>
+            <a:pPr indent="0" marL="0">
+              <a:buNone/>
+            </a:pPr>
+            <a:r>
+              <a:rPr lang="en-US" sz="1600" b="1" dirty="0">
+                <a:solidFill>
+                  <a:srgbClr val="EAF2FA"/>
+                </a:solidFill>
+                <a:latin typeface="Trebuchet MS" pitchFamily="34" charset="0"/>
+                <a:ea typeface="Trebuchet MS" pitchFamily="34" charset="-122"/>
+                <a:cs typeface="Trebuchet MS" pitchFamily="34" charset="-120"/>
+              </a:rPr>
+              <a:t>Power &amp; Chemicals</a:t>
+            </a:r>
+            <a:endParaRPr lang="en-US" sz="1600" dirty="0"/>
+          </a:p>
+        </p:txBody>
+      </p:sp>
+      <p:sp>
+        <p:nvSpPr>
+          <p:cNvPr id="25" name="Text 23"/>
+          <p:cNvSpPr/>
+          <p:nvPr/>
+        </p:nvSpPr>
+        <p:spPr>
+          <a:xfrm>
+            <a:off x="7498080" y="5394960"/>
+            <a:ext cx="3840480" cy="320040"/>
+          </a:xfrm>
+          <a:prstGeom prst="rect">
+            <a:avLst/>
+          </a:prstGeom>
+          <a:noFill/>
+          <a:ln/>
+        </p:spPr>
+        <p:txBody>
+          <a:bodyPr wrap="square" lIns="0" tIns="0" rIns="0" bIns="0" rtlCol="0" anchor="ctr"/>
+          <a:lstStyle/>
+          <a:p>
+            <a:pPr indent="0" marL="0">
+              <a:buNone/>
+            </a:pPr>
+            <a:r>
+              <a:rPr lang="en-US" sz="1200" dirty="0">
+                <a:solidFill>
+                  <a:srgbClr val="6B7888"/>
+                </a:solidFill>
+                <a:latin typeface="Calibri" pitchFamily="34" charset="0"/>
+                <a:ea typeface="Calibri" pitchFamily="34" charset="-122"/>
+                <a:cs typeface="Calibri" pitchFamily="34" charset="-120"/>
+              </a:rPr>
+              <a:t>asset-intensive operations</a:t>
+            </a:r>
+            <a:endParaRPr lang="en-US" sz="1200" dirty="0"/>
+          </a:p>
+        </p:txBody>
+      </p:sp>
+    </p:spTree>
+  </p:cSld>
+  <p:clrMapOvr>
+    <a:masterClrMapping/>
+  </p:clrMapOvr>
+</p:sld>
+</file>
+
+<file path=ppt/slides/slide12.xml><?xml version="1.0" encoding="utf-8"?>
+<p:sld xmlns:a="http://schemas.openxmlformats.org/drawingml/2006/main" xmlns:r="http://schemas.openxmlformats.org/officeDocument/2006/relationships" xmlns:p="http://schemas.openxmlformats.org/presentationml/2006/main">
+  <p:cSld name="Slide 12">
+    <p:bg>
+      <p:bgPr>
+        <a:solidFill>
+          <a:srgbClr val="0B0F14"/>
+        </a:solidFill>
+      </p:bgPr>
+    </p:bg>
+    <p:spTree>
+      <p:nvGrpSpPr>
+        <p:cNvPr id="1" name=""/>
+        <p:cNvGrpSpPr/>
+        <p:nvPr/>
+      </p:nvGrpSpPr>
+      <p:grpSpPr>
+        <a:xfrm>
+          <a:off x="0" y="0"/>
+          <a:ext cx="0" cy="0"/>
+          <a:chOff x="0" y="0"/>
+          <a:chExt cx="0" cy="0"/>
+        </a:xfrm>
+      </p:grpSpPr>
+      <p:sp>
+        <p:nvSpPr>
+          <p:cNvPr id="2" name="Text 0"/>
+          <p:cNvSpPr/>
+          <p:nvPr/>
+        </p:nvSpPr>
+        <p:spPr>
+          <a:xfrm>
+            <a:off x="640080" y="502920"/>
+            <a:ext cx="7315200" cy="274320"/>
+          </a:xfrm>
+          <a:prstGeom prst="rect">
+            <a:avLst/>
+          </a:prstGeom>
+          <a:noFill/>
+          <a:ln/>
+        </p:spPr>
+        <p:txBody>
+          <a:bodyPr wrap="square" lIns="0" tIns="0" rIns="0" bIns="0" rtlCol="0" anchor="ctr"/>
+          <a:lstStyle/>
+          <a:p>
+            <a:pPr indent="0" marL="0">
+              <a:buNone/>
+            </a:pPr>
+            <a:r>
+              <a:rPr lang="en-US" sz="1200" spc="300" kern="0" dirty="0">
+                <a:solidFill>
+                  <a:srgbClr val="34D3BD"/>
+                </a:solidFill>
+                <a:latin typeface="Consolas" pitchFamily="34" charset="0"/>
+                <a:ea typeface="Consolas" pitchFamily="34" charset="-122"/>
+                <a:cs typeface="Consolas" pitchFamily="34" charset="-120"/>
+              </a:rPr>
+              <a:t>DEPLOYS OVER YOUR STACK</a:t>
+            </a:r>
+            <a:endParaRPr lang="en-US" sz="1200" dirty="0"/>
+          </a:p>
+        </p:txBody>
+      </p:sp>
+      <p:sp>
+        <p:nvSpPr>
+          <p:cNvPr id="3" name="Text 1"/>
+          <p:cNvSpPr/>
+          <p:nvPr/>
+        </p:nvSpPr>
+        <p:spPr>
+          <a:xfrm>
+            <a:off x="640080" y="841248"/>
+            <a:ext cx="10972800" cy="822960"/>
+          </a:xfrm>
+          <a:prstGeom prst="rect">
+            <a:avLst/>
+          </a:prstGeom>
+          <a:noFill/>
+          <a:ln/>
+        </p:spPr>
+        <p:txBody>
+          <a:bodyPr wrap="square" lIns="0" tIns="0" rIns="0" bIns="0" rtlCol="0" anchor="ctr"/>
+          <a:lstStyle/>
+          <a:p>
+            <a:pPr indent="0" marL="0">
+              <a:buNone/>
+            </a:pPr>
+            <a:r>
+              <a:rPr lang="en-US" sz="3400" b="1" dirty="0">
+                <a:solidFill>
+                  <a:srgbClr val="EAF2FA"/>
+                </a:solidFill>
+                <a:latin typeface="Trebuchet MS" pitchFamily="34" charset="0"/>
+                <a:ea typeface="Trebuchet MS" pitchFamily="34" charset="-122"/>
+                <a:cs typeface="Trebuchet MS" pitchFamily="34" charset="-120"/>
+              </a:rPr>
+              <a:t>A connector, not a rewrite</a:t>
+            </a:r>
+            <a:endParaRPr lang="en-US" sz="3400" dirty="0"/>
+          </a:p>
+        </p:txBody>
+      </p:sp>
+      <p:sp>
+        <p:nvSpPr>
+          <p:cNvPr id="4" name="Shape 2"/>
+          <p:cNvSpPr/>
+          <p:nvPr/>
+        </p:nvSpPr>
+        <p:spPr>
+          <a:xfrm>
+            <a:off x="640080" y="2377440"/>
+            <a:ext cx="2505456" cy="1783080"/>
+          </a:xfrm>
+          <a:prstGeom prst="roundRect">
+            <a:avLst>
+              <a:gd name="adj" fmla="val 4615"/>
+            </a:avLst>
+          </a:prstGeom>
+          <a:solidFill>
+            <a:srgbClr val="10161E"/>
+          </a:solidFill>
+          <a:ln w="12700">
+            <a:solidFill>
+              <a:srgbClr val="26313E"/>
+            </a:solidFill>
+            <a:prstDash val="solid"/>
+          </a:ln>
+        </p:spPr>
+      </p:sp>
+      <p:sp>
+        <p:nvSpPr>
+          <p:cNvPr id="5" name="Text 3"/>
+          <p:cNvSpPr/>
+          <p:nvPr/>
+        </p:nvSpPr>
+        <p:spPr>
+          <a:xfrm>
+            <a:off x="822960" y="2578608"/>
+            <a:ext cx="2139696" cy="457200"/>
+          </a:xfrm>
+          <a:prstGeom prst="rect">
+            <a:avLst/>
+          </a:prstGeom>
+          <a:noFill/>
+          <a:ln/>
+        </p:spPr>
+        <p:txBody>
+          <a:bodyPr wrap="square" lIns="0" tIns="0" rIns="0" bIns="0" rtlCol="0" anchor="ctr"/>
+          <a:lstStyle/>
+          <a:p>
+            <a:pPr indent="0" marL="0">
+              <a:buNone/>
+            </a:pPr>
+            <a:r>
+              <a:rPr lang="en-US" sz="1500" b="1" dirty="0">
+                <a:solidFill>
+                  <a:srgbClr val="EAF2FA"/>
+                </a:solidFill>
+                <a:latin typeface="Trebuchet MS" pitchFamily="34" charset="0"/>
+                <a:ea typeface="Trebuchet MS" pitchFamily="34" charset="-122"/>
+                <a:cs typeface="Trebuchet MS" pitchFamily="34" charset="-120"/>
+              </a:rPr>
+              <a:t>Plant historian</a:t>
+            </a:r>
+            <a:endParaRPr lang="en-US" sz="1500" dirty="0"/>
+          </a:p>
+        </p:txBody>
+      </p:sp>
+      <p:sp>
+        <p:nvSpPr>
+          <p:cNvPr id="6" name="Text 4"/>
+          <p:cNvSpPr/>
+          <p:nvPr/>
+        </p:nvSpPr>
+        <p:spPr>
+          <a:xfrm>
+            <a:off x="822960" y="3090672"/>
+            <a:ext cx="2139696" cy="914400"/>
+          </a:xfrm>
+          <a:prstGeom prst="rect">
+            <a:avLst/>
+          </a:prstGeom>
+          <a:noFill/>
+          <a:ln/>
+        </p:spPr>
+        <p:txBody>
+          <a:bodyPr wrap="square" lIns="0" tIns="0" rIns="0" bIns="0" rtlCol="0" anchor="t"/>
+          <a:lstStyle/>
+          <a:p>
+            <a:pPr indent="0" marL="0">
+              <a:lnSpc>
+                <a:spcPct val="105000"/>
+              </a:lnSpc>
+              <a:buNone/>
+            </a:pPr>
+            <a:r>
+              <a:rPr lang="en-US" sz="1150" dirty="0">
+                <a:solidFill>
+                  <a:srgbClr val="6B7888"/>
+                </a:solidFill>
+                <a:latin typeface="Calibri" pitchFamily="34" charset="0"/>
+                <a:ea typeface="Calibri" pitchFamily="34" charset="-122"/>
+                <a:cs typeface="Calibri" pitchFamily="34" charset="-120"/>
+              </a:rPr>
+              <a:t>OPC-UA / MQTT / PI</a:t>
+            </a:r>
+            <a:endParaRPr lang="en-US" sz="1150" dirty="0"/>
+          </a:p>
+          <a:p>
+            <a:pPr indent="0" marL="0">
+              <a:lnSpc>
+                <a:spcPct val="105000"/>
+              </a:lnSpc>
+              <a:buNone/>
+            </a:pPr>
+            <a:r>
+              <a:rPr lang="en-US" sz="1150" dirty="0">
+                <a:solidFill>
+                  <a:srgbClr val="6B7888"/>
+                </a:solidFill>
+                <a:latin typeface="Calibri" pitchFamily="34" charset="0"/>
+                <a:ea typeface="Calibri" pitchFamily="34" charset="-122"/>
+                <a:cs typeface="Calibri" pitchFamily="34" charset="-120"/>
+              </a:rPr>
+              <a:t>permits · CCTV</a:t>
+            </a:r>
+            <a:endParaRPr lang="en-US" sz="1150" dirty="0"/>
+          </a:p>
+        </p:txBody>
+      </p:sp>
+      <p:sp>
+        <p:nvSpPr>
+          <p:cNvPr id="7" name="Text 5"/>
+          <p:cNvSpPr/>
+          <p:nvPr/>
+        </p:nvSpPr>
+        <p:spPr>
+          <a:xfrm>
+            <a:off x="3145536" y="2377440"/>
+            <a:ext cx="320040" cy="1783080"/>
+          </a:xfrm>
+          <a:prstGeom prst="rect">
+            <a:avLst/>
+          </a:prstGeom>
+          <a:noFill/>
+          <a:ln/>
+        </p:spPr>
+        <p:txBody>
+          <a:bodyPr wrap="square" lIns="0" tIns="0" rIns="0" bIns="0" rtlCol="0" anchor="ctr"/>
+          <a:lstStyle/>
+          <a:p>
+            <a:pPr algn="ctr" indent="0" marL="0">
+              <a:buNone/>
+            </a:pPr>
+            <a:r>
+              <a:rPr lang="en-US" sz="2000" dirty="0">
+                <a:solidFill>
+                  <a:srgbClr val="34D3BD"/>
+                </a:solidFill>
+                <a:latin typeface="Trebuchet MS" pitchFamily="34" charset="0"/>
+                <a:ea typeface="Trebuchet MS" pitchFamily="34" charset="-122"/>
+                <a:cs typeface="Trebuchet MS" pitchFamily="34" charset="-120"/>
+              </a:rPr>
+              <a:t>→</a:t>
+            </a:r>
+            <a:endParaRPr lang="en-US" sz="2000" dirty="0"/>
+          </a:p>
+        </p:txBody>
+      </p:sp>
+      <p:sp>
+        <p:nvSpPr>
+          <p:cNvPr id="8" name="Shape 6"/>
+          <p:cNvSpPr/>
+          <p:nvPr/>
+        </p:nvSpPr>
+        <p:spPr>
+          <a:xfrm>
+            <a:off x="3465576" y="2377440"/>
+            <a:ext cx="2505456" cy="1783080"/>
+          </a:xfrm>
+          <a:prstGeom prst="roundRect">
+            <a:avLst>
+              <a:gd name="adj" fmla="val 4615"/>
+            </a:avLst>
+          </a:prstGeom>
+          <a:solidFill>
+            <a:srgbClr val="10161E"/>
+          </a:solidFill>
+          <a:ln w="12700">
+            <a:solidFill>
+              <a:srgbClr val="26313E"/>
+            </a:solidFill>
+            <a:prstDash val="solid"/>
+          </a:ln>
+        </p:spPr>
+      </p:sp>
+      <p:sp>
+        <p:nvSpPr>
+          <p:cNvPr id="9" name="Text 7"/>
+          <p:cNvSpPr/>
+          <p:nvPr/>
+        </p:nvSpPr>
+        <p:spPr>
+          <a:xfrm>
+            <a:off x="3648456" y="2578608"/>
+            <a:ext cx="2139696" cy="457200"/>
+          </a:xfrm>
+          <a:prstGeom prst="rect">
+            <a:avLst/>
+          </a:prstGeom>
+          <a:noFill/>
+          <a:ln/>
+        </p:spPr>
+        <p:txBody>
+          <a:bodyPr wrap="square" lIns="0" tIns="0" rIns="0" bIns="0" rtlCol="0" anchor="ctr"/>
+          <a:lstStyle/>
+          <a:p>
+            <a:pPr indent="0" marL="0">
+              <a:buNone/>
+            </a:pPr>
+            <a:r>
+              <a:rPr lang="en-US" sz="1500" b="1" dirty="0">
+                <a:solidFill>
+                  <a:srgbClr val="EAF2FA"/>
+                </a:solidFill>
+                <a:latin typeface="Trebuchet MS" pitchFamily="34" charset="0"/>
+                <a:ea typeface="Trebuchet MS" pitchFamily="34" charset="-122"/>
+                <a:cs typeface="Trebuchet MS" pitchFamily="34" charset="-120"/>
+              </a:rPr>
+              <a:t>Edge pre-filter</a:t>
+            </a:r>
+            <a:endParaRPr lang="en-US" sz="1500" dirty="0"/>
+          </a:p>
+        </p:txBody>
+      </p:sp>
+      <p:sp>
+        <p:nvSpPr>
+          <p:cNvPr id="10" name="Text 8"/>
+          <p:cNvSpPr/>
+          <p:nvPr/>
+        </p:nvSpPr>
+        <p:spPr>
+          <a:xfrm>
+            <a:off x="3648456" y="3090672"/>
+            <a:ext cx="2139696" cy="914400"/>
+          </a:xfrm>
+          <a:prstGeom prst="rect">
+            <a:avLst/>
+          </a:prstGeom>
+          <a:noFill/>
+          <a:ln/>
+        </p:spPr>
+        <p:txBody>
+          <a:bodyPr wrap="square" lIns="0" tIns="0" rIns="0" bIns="0" rtlCol="0" anchor="t"/>
+          <a:lstStyle/>
+          <a:p>
+            <a:pPr indent="0" marL="0">
+              <a:lnSpc>
+                <a:spcPct val="105000"/>
+              </a:lnSpc>
+              <a:buNone/>
+            </a:pPr>
+            <a:r>
+              <a:rPr lang="en-US" sz="1150" dirty="0">
+                <a:solidFill>
+                  <a:srgbClr val="6B7888"/>
+                </a:solidFill>
+                <a:latin typeface="Calibri" pitchFamily="34" charset="0"/>
+                <a:ea typeface="Calibri" pitchFamily="34" charset="-122"/>
+                <a:cs typeface="Calibri" pitchFamily="34" charset="-120"/>
+              </a:rPr>
+              <a:t>debounce + normalise</a:t>
+            </a:r>
+            <a:endParaRPr lang="en-US" sz="1150" dirty="0"/>
+          </a:p>
+          <a:p>
+            <a:pPr indent="0" marL="0">
+              <a:lnSpc>
+                <a:spcPct val="105000"/>
+              </a:lnSpc>
+              <a:buNone/>
+            </a:pPr>
+            <a:r>
+              <a:rPr lang="en-US" sz="1150" dirty="0">
+                <a:solidFill>
+                  <a:srgbClr val="6B7888"/>
+                </a:solidFill>
+                <a:latin typeface="Calibri" pitchFamily="34" charset="0"/>
+                <a:ea typeface="Calibri" pitchFamily="34" charset="-122"/>
+                <a:cs typeface="Calibri" pitchFamily="34" charset="-120"/>
+              </a:rPr>
+              <a:t>at the plant edge</a:t>
+            </a:r>
+            <a:endParaRPr lang="en-US" sz="1150" dirty="0"/>
+          </a:p>
+        </p:txBody>
+      </p:sp>
+      <p:sp>
+        <p:nvSpPr>
+          <p:cNvPr id="11" name="Text 9"/>
+          <p:cNvSpPr/>
+          <p:nvPr/>
+        </p:nvSpPr>
+        <p:spPr>
+          <a:xfrm>
+            <a:off x="5971032" y="2377440"/>
+            <a:ext cx="320040" cy="1783080"/>
+          </a:xfrm>
+          <a:prstGeom prst="rect">
+            <a:avLst/>
+          </a:prstGeom>
+          <a:noFill/>
+          <a:ln/>
+        </p:spPr>
+        <p:txBody>
+          <a:bodyPr wrap="square" lIns="0" tIns="0" rIns="0" bIns="0" rtlCol="0" anchor="ctr"/>
+          <a:lstStyle/>
+          <a:p>
+            <a:pPr algn="ctr" indent="0" marL="0">
+              <a:buNone/>
+            </a:pPr>
+            <a:r>
+              <a:rPr lang="en-US" sz="2000" dirty="0">
+                <a:solidFill>
+                  <a:srgbClr val="34D3BD"/>
+                </a:solidFill>
+                <a:latin typeface="Trebuchet MS" pitchFamily="34" charset="0"/>
+                <a:ea typeface="Trebuchet MS" pitchFamily="34" charset="-122"/>
+                <a:cs typeface="Trebuchet MS" pitchFamily="34" charset="-120"/>
+              </a:rPr>
+              <a:t>→</a:t>
+            </a:r>
+            <a:endParaRPr lang="en-US" sz="2000" dirty="0"/>
+          </a:p>
+        </p:txBody>
+      </p:sp>
+      <p:sp>
+        <p:nvSpPr>
+          <p:cNvPr id="12" name="Shape 10"/>
+          <p:cNvSpPr/>
+          <p:nvPr/>
+        </p:nvSpPr>
+        <p:spPr>
+          <a:xfrm>
+            <a:off x="6291072" y="2377440"/>
+            <a:ext cx="2505456" cy="1783080"/>
+          </a:xfrm>
+          <a:prstGeom prst="roundRect">
+            <a:avLst>
+              <a:gd name="adj" fmla="val 4615"/>
+            </a:avLst>
+          </a:prstGeom>
+          <a:solidFill>
+            <a:srgbClr val="0C1218"/>
+          </a:solidFill>
+          <a:ln w="12700">
+            <a:solidFill>
+              <a:srgbClr val="34D3BD"/>
+            </a:solidFill>
+            <a:prstDash val="solid"/>
+          </a:ln>
+        </p:spPr>
+      </p:sp>
+      <p:sp>
+        <p:nvSpPr>
+          <p:cNvPr id="13" name="Text 11"/>
+          <p:cNvSpPr/>
+          <p:nvPr/>
+        </p:nvSpPr>
+        <p:spPr>
+          <a:xfrm>
+            <a:off x="6473952" y="2578608"/>
+            <a:ext cx="2139696" cy="457200"/>
+          </a:xfrm>
+          <a:prstGeom prst="rect">
+            <a:avLst/>
+          </a:prstGeom>
+          <a:noFill/>
+          <a:ln/>
+        </p:spPr>
+        <p:txBody>
+          <a:bodyPr wrap="square" lIns="0" tIns="0" rIns="0" bIns="0" rtlCol="0" anchor="ctr"/>
+          <a:lstStyle/>
+          <a:p>
+            <a:pPr indent="0" marL="0">
+              <a:buNone/>
+            </a:pPr>
+            <a:r>
+              <a:rPr lang="en-US" sz="1500" b="1" dirty="0">
+                <a:solidFill>
+                  <a:srgbClr val="34D3BD"/>
+                </a:solidFill>
+                <a:latin typeface="Trebuchet MS" pitchFamily="34" charset="0"/>
+                <a:ea typeface="Trebuchet MS" pitchFamily="34" charset="-122"/>
+                <a:cs typeface="Trebuchet MS" pitchFamily="34" charset="-120"/>
+              </a:rPr>
+              <a:t>Compound engine</a:t>
+            </a:r>
+            <a:endParaRPr lang="en-US" sz="1500" dirty="0"/>
+          </a:p>
+        </p:txBody>
+      </p:sp>
+      <p:sp>
+        <p:nvSpPr>
+          <p:cNvPr id="14" name="Text 12"/>
+          <p:cNvSpPr/>
+          <p:nvPr/>
+        </p:nvSpPr>
+        <p:spPr>
+          <a:xfrm>
+            <a:off x="6473952" y="3090672"/>
+            <a:ext cx="2139696" cy="914400"/>
+          </a:xfrm>
+          <a:prstGeom prst="rect">
+            <a:avLst/>
+          </a:prstGeom>
+          <a:noFill/>
+          <a:ln/>
+        </p:spPr>
+        <p:txBody>
+          <a:bodyPr wrap="square" lIns="0" tIns="0" rIns="0" bIns="0" rtlCol="0" anchor="t"/>
+          <a:lstStyle/>
+          <a:p>
+            <a:pPr indent="0" marL="0">
+              <a:lnSpc>
+                <a:spcPct val="105000"/>
+              </a:lnSpc>
+              <a:buNone/>
+            </a:pPr>
+            <a:r>
+              <a:rPr lang="en-US" sz="1150" dirty="0">
+                <a:solidFill>
+                  <a:srgbClr val="6B7888"/>
+                </a:solidFill>
+                <a:latin typeface="Calibri" pitchFamily="34" charset="0"/>
+                <a:ea typeface="Calibri" pitchFamily="34" charset="-122"/>
+                <a:cs typeface="Calibri" pitchFamily="34" charset="-120"/>
+              </a:rPr>
+              <a:t>deterministic, O(zones)</a:t>
+            </a:r>
+            <a:endParaRPr lang="en-US" sz="1150" dirty="0"/>
+          </a:p>
+          <a:p>
+            <a:pPr indent="0" marL="0">
+              <a:lnSpc>
+                <a:spcPct val="105000"/>
+              </a:lnSpc>
+              <a:buNone/>
+            </a:pPr>
+            <a:r>
+              <a:rPr lang="en-US" sz="1150" dirty="0">
+                <a:solidFill>
+                  <a:srgbClr val="6B7888"/>
+                </a:solidFill>
+                <a:latin typeface="Calibri" pitchFamily="34" charset="0"/>
+                <a:ea typeface="Calibri" pitchFamily="34" charset="-122"/>
+                <a:cs typeface="Calibri" pitchFamily="34" charset="-120"/>
+              </a:rPr>
+              <a:t>the safety decision</a:t>
+            </a:r>
+            <a:endParaRPr lang="en-US" sz="1150" dirty="0"/>
+          </a:p>
+        </p:txBody>
+      </p:sp>
+      <p:sp>
+        <p:nvSpPr>
+          <p:cNvPr id="15" name="Text 13"/>
+          <p:cNvSpPr/>
+          <p:nvPr/>
+        </p:nvSpPr>
+        <p:spPr>
+          <a:xfrm>
+            <a:off x="8796528" y="2377440"/>
+            <a:ext cx="320040" cy="1783080"/>
+          </a:xfrm>
+          <a:prstGeom prst="rect">
+            <a:avLst/>
+          </a:prstGeom>
+          <a:noFill/>
+          <a:ln/>
+        </p:spPr>
+        <p:txBody>
+          <a:bodyPr wrap="square" lIns="0" tIns="0" rIns="0" bIns="0" rtlCol="0" anchor="ctr"/>
+          <a:lstStyle/>
+          <a:p>
+            <a:pPr algn="ctr" indent="0" marL="0">
+              <a:buNone/>
+            </a:pPr>
+            <a:r>
+              <a:rPr lang="en-US" sz="2000" dirty="0">
+                <a:solidFill>
+                  <a:srgbClr val="34D3BD"/>
+                </a:solidFill>
+                <a:latin typeface="Trebuchet MS" pitchFamily="34" charset="0"/>
+                <a:ea typeface="Trebuchet MS" pitchFamily="34" charset="-122"/>
+                <a:cs typeface="Trebuchet MS" pitchFamily="34" charset="-120"/>
+              </a:rPr>
+              <a:t>→</a:t>
+            </a:r>
+            <a:endParaRPr lang="en-US" sz="2000" dirty="0"/>
+          </a:p>
+        </p:txBody>
+      </p:sp>
+      <p:sp>
+        <p:nvSpPr>
+          <p:cNvPr id="16" name="Shape 14"/>
+          <p:cNvSpPr/>
+          <p:nvPr/>
+        </p:nvSpPr>
+        <p:spPr>
+          <a:xfrm>
+            <a:off x="9116568" y="2377440"/>
+            <a:ext cx="2505456" cy="1783080"/>
+          </a:xfrm>
+          <a:prstGeom prst="roundRect">
+            <a:avLst>
+              <a:gd name="adj" fmla="val 4615"/>
+            </a:avLst>
+          </a:prstGeom>
+          <a:solidFill>
+            <a:srgbClr val="10161E"/>
+          </a:solidFill>
+          <a:ln w="12700">
+            <a:solidFill>
+              <a:srgbClr val="26313E"/>
+            </a:solidFill>
+            <a:prstDash val="solid"/>
+          </a:ln>
+        </p:spPr>
+      </p:sp>
+      <p:sp>
+        <p:nvSpPr>
+          <p:cNvPr id="17" name="Text 15"/>
+          <p:cNvSpPr/>
+          <p:nvPr/>
+        </p:nvSpPr>
+        <p:spPr>
+          <a:xfrm>
+            <a:off x="9299448" y="2578608"/>
+            <a:ext cx="2139696" cy="457200"/>
+          </a:xfrm>
+          <a:prstGeom prst="rect">
+            <a:avLst/>
+          </a:prstGeom>
+          <a:noFill/>
+          <a:ln/>
+        </p:spPr>
+        <p:txBody>
+          <a:bodyPr wrap="square" lIns="0" tIns="0" rIns="0" bIns="0" rtlCol="0" anchor="ctr"/>
+          <a:lstStyle/>
+          <a:p>
+            <a:pPr indent="0" marL="0">
+              <a:buNone/>
+            </a:pPr>
+            <a:r>
+              <a:rPr lang="en-US" sz="1500" b="1" dirty="0">
+                <a:solidFill>
+                  <a:srgbClr val="EAF2FA"/>
+                </a:solidFill>
+                <a:latin typeface="Trebuchet MS" pitchFamily="34" charset="0"/>
+                <a:ea typeface="Trebuchet MS" pitchFamily="34" charset="-122"/>
+                <a:cs typeface="Trebuchet MS" pitchFamily="34" charset="-120"/>
+              </a:rPr>
+              <a:t>Control-room HMI</a:t>
+            </a:r>
+            <a:endParaRPr lang="en-US" sz="1500" dirty="0"/>
+          </a:p>
+        </p:txBody>
+      </p:sp>
+      <p:sp>
+        <p:nvSpPr>
+          <p:cNvPr id="18" name="Text 16"/>
+          <p:cNvSpPr/>
+          <p:nvPr/>
+        </p:nvSpPr>
+        <p:spPr>
+          <a:xfrm>
+            <a:off x="9299448" y="3090672"/>
+            <a:ext cx="2139696" cy="914400"/>
+          </a:xfrm>
+          <a:prstGeom prst="rect">
+            <a:avLst/>
+          </a:prstGeom>
+          <a:noFill/>
+          <a:ln/>
+        </p:spPr>
+        <p:txBody>
+          <a:bodyPr wrap="square" lIns="0" tIns="0" rIns="0" bIns="0" rtlCol="0" anchor="t"/>
+          <a:lstStyle/>
+          <a:p>
+            <a:pPr indent="0" marL="0">
+              <a:lnSpc>
+                <a:spcPct val="105000"/>
+              </a:lnSpc>
+              <a:buNone/>
+            </a:pPr>
+            <a:r>
+              <a:rPr lang="en-US" sz="1150" dirty="0">
+                <a:solidFill>
+                  <a:srgbClr val="6B7888"/>
+                </a:solidFill>
+                <a:latin typeface="Calibri" pitchFamily="34" charset="0"/>
+                <a:ea typeface="Calibri" pitchFamily="34" charset="-122"/>
+                <a:cs typeface="Calibri" pitchFamily="34" charset="-120"/>
+              </a:rPr>
+              <a:t>split-reality view +</a:t>
+            </a:r>
+            <a:endParaRPr lang="en-US" sz="1150" dirty="0"/>
+          </a:p>
+          <a:p>
+            <a:pPr indent="0" marL="0">
+              <a:lnSpc>
+                <a:spcPct val="105000"/>
+              </a:lnSpc>
+              <a:buNone/>
+            </a:pPr>
+            <a:r>
+              <a:rPr lang="en-US" sz="1150" dirty="0">
+                <a:solidFill>
+                  <a:srgbClr val="6B7888"/>
+                </a:solidFill>
+                <a:latin typeface="Calibri" pitchFamily="34" charset="0"/>
+                <a:ea typeface="Calibri" pitchFamily="34" charset="-122"/>
+                <a:cs typeface="Calibri" pitchFamily="34" charset="-120"/>
+              </a:rPr>
+              <a:t>autonomous response</a:t>
+            </a:r>
+            <a:endParaRPr lang="en-US" sz="1150" dirty="0"/>
+          </a:p>
+        </p:txBody>
+      </p:sp>
+      <p:sp>
+        <p:nvSpPr>
+          <p:cNvPr id="19" name="Shape 17"/>
+          <p:cNvSpPr/>
+          <p:nvPr/>
+        </p:nvSpPr>
+        <p:spPr>
+          <a:xfrm>
+            <a:off x="640080" y="4526280"/>
+            <a:ext cx="5394960" cy="1508760"/>
+          </a:xfrm>
+          <a:prstGeom prst="roundRect">
+            <a:avLst>
+              <a:gd name="adj" fmla="val 5455"/>
+            </a:avLst>
+          </a:prstGeom>
+          <a:solidFill>
+            <a:srgbClr val="0C1218"/>
+          </a:solidFill>
+          <a:ln w="12700">
+            <a:solidFill>
+              <a:srgbClr val="34D3BD"/>
+            </a:solidFill>
+            <a:prstDash val="solid"/>
+          </a:ln>
+        </p:spPr>
+      </p:sp>
+      <p:sp>
+        <p:nvSpPr>
+          <p:cNvPr id="20" name="Text 18"/>
+          <p:cNvSpPr/>
+          <p:nvPr/>
+        </p:nvSpPr>
+        <p:spPr>
+          <a:xfrm>
+            <a:off x="914400" y="4690872"/>
+            <a:ext cx="4572000" cy="274320"/>
+          </a:xfrm>
+          <a:prstGeom prst="rect">
+            <a:avLst/>
+          </a:prstGeom>
+          <a:noFill/>
+          <a:ln/>
+        </p:spPr>
+        <p:txBody>
+          <a:bodyPr wrap="square" lIns="0" tIns="0" rIns="0" bIns="0" rtlCol="0" anchor="ctr"/>
+          <a:lstStyle/>
+          <a:p>
+            <a:pPr indent="0" marL="0">
+              <a:buNone/>
+            </a:pPr>
+            <a:r>
+              <a:rPr lang="en-US" sz="1100" spc="200" kern="0" dirty="0">
+                <a:solidFill>
+                  <a:srgbClr val="34D3BD"/>
+                </a:solidFill>
+                <a:latin typeface="Consolas" pitchFamily="34" charset="0"/>
+                <a:ea typeface="Consolas" pitchFamily="34" charset="-122"/>
+                <a:cs typeface="Consolas" pitchFamily="34" charset="-120"/>
+              </a:rPr>
+              <a:t>THROUGHPUT</a:t>
+            </a:r>
+            <a:endParaRPr lang="en-US" sz="1100" dirty="0"/>
+          </a:p>
+        </p:txBody>
+      </p:sp>
+      <p:sp>
+        <p:nvSpPr>
+          <p:cNvPr id="21" name="Text 19"/>
+          <p:cNvSpPr/>
+          <p:nvPr/>
+        </p:nvSpPr>
+        <p:spPr>
+          <a:xfrm>
+            <a:off x="914400" y="4983480"/>
+            <a:ext cx="4937760" cy="457200"/>
+          </a:xfrm>
+          <a:prstGeom prst="rect">
+            <a:avLst/>
+          </a:prstGeom>
+          <a:noFill/>
+          <a:ln/>
+        </p:spPr>
+        <p:txBody>
+          <a:bodyPr wrap="square" lIns="0" tIns="0" rIns="0" bIns="0" rtlCol="0" anchor="ctr"/>
+          <a:lstStyle/>
+          <a:p>
+            <a:pPr indent="0" marL="0">
+              <a:buNone/>
+            </a:pPr>
+            <a:r>
+              <a:rPr lang="en-US" sz="2400" b="1" dirty="0">
+                <a:solidFill>
+                  <a:srgbClr val="EAF2FA"/>
+                </a:solidFill>
+                <a:latin typeface="Trebuchet MS" pitchFamily="34" charset="0"/>
+                <a:ea typeface="Trebuchet MS" pitchFamily="34" charset="-122"/>
+                <a:cs typeface="Trebuchet MS" pitchFamily="34" charset="-120"/>
+              </a:rPr>
+              <a:t>~10,000 tags @ 1 Hz</a:t>
+            </a:r>
+            <a:endParaRPr lang="en-US" sz="2400" dirty="0"/>
+          </a:p>
+        </p:txBody>
+      </p:sp>
+      <p:sp>
+        <p:nvSpPr>
+          <p:cNvPr id="22" name="Text 20"/>
+          <p:cNvSpPr/>
+          <p:nvPr/>
+        </p:nvSpPr>
+        <p:spPr>
+          <a:xfrm>
+            <a:off x="914400" y="5468112"/>
+            <a:ext cx="4937760" cy="548640"/>
+          </a:xfrm>
+          <a:prstGeom prst="rect">
+            <a:avLst/>
+          </a:prstGeom>
+          <a:noFill/>
+          <a:ln/>
+        </p:spPr>
+        <p:txBody>
+          <a:bodyPr wrap="square" lIns="0" tIns="0" rIns="0" bIns="0" rtlCol="0" anchor="t"/>
+          <a:lstStyle/>
+          <a:p>
+            <a:pPr indent="0" marL="0">
+              <a:buNone/>
+            </a:pPr>
+            <a:r>
+              <a:rPr lang="en-US" sz="1150" dirty="0">
+                <a:solidFill>
+                  <a:srgbClr val="6B7888"/>
+                </a:solidFill>
+                <a:latin typeface="Calibri" pitchFamily="34" charset="0"/>
+                <a:ea typeface="Calibri" pitchFamily="34" charset="-122"/>
+                <a:cs typeface="Calibri" pitchFamily="34" charset="-120"/>
+              </a:rPr>
+              <a:t>on a single node — the engine is O(zones) per frame, one instance per plant (fleet view above). No GPU in the life-safety path.</a:t>
+            </a:r>
+            <a:endParaRPr lang="en-US" sz="1150" dirty="0"/>
+          </a:p>
+        </p:txBody>
+      </p:sp>
+      <p:sp>
+        <p:nvSpPr>
+          <p:cNvPr id="23" name="Shape 21"/>
+          <p:cNvSpPr/>
+          <p:nvPr/>
+        </p:nvSpPr>
+        <p:spPr>
+          <a:xfrm>
+            <a:off x="6309360" y="4526280"/>
+            <a:ext cx="5239512" cy="1508760"/>
+          </a:xfrm>
+          <a:prstGeom prst="roundRect">
+            <a:avLst>
+              <a:gd name="adj" fmla="val 5455"/>
+            </a:avLst>
+          </a:prstGeom>
+          <a:solidFill>
+            <a:srgbClr val="10161E"/>
+          </a:solidFill>
+          <a:ln w="12700">
+            <a:solidFill>
+              <a:srgbClr val="26313E"/>
+            </a:solidFill>
+            <a:prstDash val="solid"/>
+          </a:ln>
+        </p:spPr>
+      </p:sp>
+      <p:sp>
+        <p:nvSpPr>
+          <p:cNvPr id="24" name="Shape 22"/>
+          <p:cNvSpPr/>
+          <p:nvPr/>
+        </p:nvSpPr>
+        <p:spPr>
+          <a:xfrm>
+            <a:off x="6565392" y="4782312"/>
+            <a:ext cx="128016" cy="128016"/>
+          </a:xfrm>
+          <a:prstGeom prst="ellipse">
+            <a:avLst/>
+          </a:prstGeom>
+          <a:solidFill>
+            <a:srgbClr val="34D3BD"/>
+          </a:solidFill>
+          <a:ln/>
+        </p:spPr>
+      </p:sp>
+      <p:sp>
+        <p:nvSpPr>
+          <p:cNvPr id="25" name="Text 23"/>
+          <p:cNvSpPr/>
+          <p:nvPr/>
+        </p:nvSpPr>
+        <p:spPr>
+          <a:xfrm>
+            <a:off x="6812280" y="4681728"/>
+            <a:ext cx="4572000" cy="256032"/>
+          </a:xfrm>
+          <a:prstGeom prst="rect">
+            <a:avLst/>
+          </a:prstGeom>
+          <a:noFill/>
+          <a:ln/>
+        </p:spPr>
+        <p:txBody>
+          <a:bodyPr wrap="square" lIns="0" tIns="0" rIns="0" bIns="0" rtlCol="0" anchor="ctr"/>
+          <a:lstStyle/>
+          <a:p>
+            <a:pPr indent="0" marL="0">
+              <a:buNone/>
+            </a:pPr>
+            <a:r>
+              <a:rPr lang="en-US" sz="1300" b="1" dirty="0">
+                <a:solidFill>
+                  <a:srgbClr val="EAF2FA"/>
+                </a:solidFill>
+                <a:latin typeface="Trebuchet MS" pitchFamily="34" charset="0"/>
+                <a:ea typeface="Trebuchet MS" pitchFamily="34" charset="-122"/>
+                <a:cs typeface="Trebuchet MS" pitchFamily="34" charset="-120"/>
+              </a:rPr>
+              <a:t>Standard formats</a:t>
+            </a:r>
+            <a:endParaRPr lang="en-US" sz="1300" dirty="0"/>
+          </a:p>
+        </p:txBody>
+      </p:sp>
+      <p:sp>
+        <p:nvSpPr>
+          <p:cNvPr id="26" name="Text 24"/>
+          <p:cNvSpPr/>
+          <p:nvPr/>
+        </p:nvSpPr>
+        <p:spPr>
+          <a:xfrm>
+            <a:off x="6812280" y="4901184"/>
+            <a:ext cx="4572000" cy="237744"/>
+          </a:xfrm>
+          <a:prstGeom prst="rect">
+            <a:avLst/>
+          </a:prstGeom>
+          <a:noFill/>
+          <a:ln/>
+        </p:spPr>
+        <p:txBody>
+          <a:bodyPr wrap="square" lIns="0" tIns="0" rIns="0" bIns="0" rtlCol="0" anchor="ctr"/>
+          <a:lstStyle/>
+          <a:p>
+            <a:pPr indent="0" marL="0">
+              <a:buNone/>
+            </a:pPr>
+            <a:r>
+              <a:rPr lang="en-US" sz="1050" dirty="0">
+                <a:solidFill>
+                  <a:srgbClr val="6B7888"/>
+                </a:solidFill>
+                <a:latin typeface="Calibri" pitchFamily="34" charset="0"/>
+                <a:ea typeface="Calibri" pitchFamily="34" charset="-122"/>
+                <a:cs typeface="Calibri" pitchFamily="34" charset="-120"/>
+              </a:rPr>
+              <a:t>ingests SCADA / IoT / permit data as-is</a:t>
+            </a:r>
+            <a:endParaRPr lang="en-US" sz="1050" dirty="0"/>
+          </a:p>
+        </p:txBody>
+      </p:sp>
+      <p:sp>
+        <p:nvSpPr>
+          <p:cNvPr id="27" name="Shape 25"/>
+          <p:cNvSpPr/>
+          <p:nvPr/>
+        </p:nvSpPr>
+        <p:spPr>
+          <a:xfrm>
+            <a:off x="6565392" y="5239512"/>
+            <a:ext cx="128016" cy="128016"/>
+          </a:xfrm>
+          <a:prstGeom prst="ellipse">
+            <a:avLst/>
+          </a:prstGeom>
+          <a:solidFill>
+            <a:srgbClr val="34D3BD"/>
+          </a:solidFill>
+          <a:ln/>
+        </p:spPr>
+      </p:sp>
+      <p:sp>
+        <p:nvSpPr>
+          <p:cNvPr id="28" name="Text 26"/>
+          <p:cNvSpPr/>
+          <p:nvPr/>
+        </p:nvSpPr>
+        <p:spPr>
+          <a:xfrm>
+            <a:off x="6812280" y="5138928"/>
+            <a:ext cx="4572000" cy="256032"/>
+          </a:xfrm>
+          <a:prstGeom prst="rect">
+            <a:avLst/>
+          </a:prstGeom>
+          <a:noFill/>
+          <a:ln/>
+        </p:spPr>
+        <p:txBody>
+          <a:bodyPr wrap="square" lIns="0" tIns="0" rIns="0" bIns="0" rtlCol="0" anchor="ctr"/>
+          <a:lstStyle/>
+          <a:p>
+            <a:pPr indent="0" marL="0">
+              <a:buNone/>
+            </a:pPr>
+            <a:r>
+              <a:rPr lang="en-US" sz="1300" b="1" dirty="0">
+                <a:solidFill>
+                  <a:srgbClr val="EAF2FA"/>
+                </a:solidFill>
+                <a:latin typeface="Trebuchet MS" pitchFamily="34" charset="0"/>
+                <a:ea typeface="Trebuchet MS" pitchFamily="34" charset="-122"/>
+                <a:cs typeface="Trebuchet MS" pitchFamily="34" charset="-120"/>
+              </a:rPr>
+              <a:t>Edge or on-prem</a:t>
+            </a:r>
+            <a:endParaRPr lang="en-US" sz="1300" dirty="0"/>
+          </a:p>
+        </p:txBody>
+      </p:sp>
+      <p:sp>
+        <p:nvSpPr>
+          <p:cNvPr id="29" name="Text 27"/>
+          <p:cNvSpPr/>
+          <p:nvPr/>
+        </p:nvSpPr>
+        <p:spPr>
+          <a:xfrm>
+            <a:off x="6812280" y="5358384"/>
+            <a:ext cx="4572000" cy="237744"/>
+          </a:xfrm>
+          <a:prstGeom prst="rect">
+            <a:avLst/>
+          </a:prstGeom>
+          <a:noFill/>
+          <a:ln/>
+        </p:spPr>
+        <p:txBody>
+          <a:bodyPr wrap="square" lIns="0" tIns="0" rIns="0" bIns="0" rtlCol="0" anchor="ctr"/>
+          <a:lstStyle/>
+          <a:p>
+            <a:pPr indent="0" marL="0">
+              <a:buNone/>
+            </a:pPr>
+            <a:r>
+              <a:rPr lang="en-US" sz="1050" dirty="0">
+                <a:solidFill>
+                  <a:srgbClr val="6B7888"/>
+                </a:solidFill>
+                <a:latin typeface="Calibri" pitchFamily="34" charset="0"/>
+                <a:ea typeface="Calibri" pitchFamily="34" charset="-122"/>
+                <a:cs typeface="Calibri" pitchFamily="34" charset="-120"/>
+              </a:rPr>
+              <a:t>data never has to leave the plant</a:t>
+            </a:r>
+            <a:endParaRPr lang="en-US" sz="1050" dirty="0"/>
+          </a:p>
+        </p:txBody>
+      </p:sp>
+      <p:sp>
+        <p:nvSpPr>
+          <p:cNvPr id="30" name="Shape 28"/>
+          <p:cNvSpPr/>
+          <p:nvPr/>
+        </p:nvSpPr>
+        <p:spPr>
+          <a:xfrm>
+            <a:off x="6565392" y="5696712"/>
+            <a:ext cx="128016" cy="128016"/>
+          </a:xfrm>
+          <a:prstGeom prst="ellipse">
+            <a:avLst/>
+          </a:prstGeom>
+          <a:solidFill>
+            <a:srgbClr val="34D3BD"/>
+          </a:solidFill>
+          <a:ln/>
+        </p:spPr>
+      </p:sp>
+      <p:sp>
+        <p:nvSpPr>
+          <p:cNvPr id="31" name="Text 29"/>
+          <p:cNvSpPr/>
+          <p:nvPr/>
+        </p:nvSpPr>
+        <p:spPr>
+          <a:xfrm>
+            <a:off x="6812280" y="5596128"/>
+            <a:ext cx="4572000" cy="256032"/>
+          </a:xfrm>
+          <a:prstGeom prst="rect">
+            <a:avLst/>
+          </a:prstGeom>
+          <a:noFill/>
+          <a:ln/>
+        </p:spPr>
+        <p:txBody>
+          <a:bodyPr wrap="square" lIns="0" tIns="0" rIns="0" bIns="0" rtlCol="0" anchor="ctr"/>
+          <a:lstStyle/>
+          <a:p>
+            <a:pPr indent="0" marL="0">
+              <a:buNone/>
+            </a:pPr>
+            <a:r>
+              <a:rPr lang="en-US" sz="1300" b="1" dirty="0">
+                <a:solidFill>
+                  <a:srgbClr val="EAF2FA"/>
+                </a:solidFill>
+                <a:latin typeface="Trebuchet MS" pitchFamily="34" charset="0"/>
+                <a:ea typeface="Trebuchet MS" pitchFamily="34" charset="-122"/>
+                <a:cs typeface="Trebuchet MS" pitchFamily="34" charset="-120"/>
+              </a:rPr>
+              <a:t>Deterministic core</a:t>
+            </a:r>
+            <a:endParaRPr lang="en-US" sz="1300" dirty="0"/>
+          </a:p>
+        </p:txBody>
+      </p:sp>
+      <p:sp>
+        <p:nvSpPr>
+          <p:cNvPr id="32" name="Text 30"/>
+          <p:cNvSpPr/>
+          <p:nvPr/>
+        </p:nvSpPr>
+        <p:spPr>
+          <a:xfrm>
+            <a:off x="6812280" y="5815584"/>
+            <a:ext cx="4572000" cy="237744"/>
+          </a:xfrm>
+          <a:prstGeom prst="rect">
+            <a:avLst/>
+          </a:prstGeom>
+          <a:noFill/>
+          <a:ln/>
+        </p:spPr>
+        <p:txBody>
+          <a:bodyPr wrap="square" lIns="0" tIns="0" rIns="0" bIns="0" rtlCol="0" anchor="ctr"/>
+          <a:lstStyle/>
+          <a:p>
+            <a:pPr indent="0" marL="0">
+              <a:buNone/>
+            </a:pPr>
+            <a:r>
+              <a:rPr lang="en-US" sz="1050" dirty="0">
+                <a:solidFill>
+                  <a:srgbClr val="6B7888"/>
+                </a:solidFill>
+                <a:latin typeface="Calibri" pitchFamily="34" charset="0"/>
+                <a:ea typeface="Calibri" pitchFamily="34" charset="-122"/>
+                <a:cs typeface="Calibri" pitchFamily="34" charset="-120"/>
+              </a:rPr>
+              <a:t>an auditable decision a safety officer can defend</a:t>
+            </a:r>
+            <a:endParaRPr lang="en-US" sz="1050" dirty="0"/>
+          </a:p>
+        </p:txBody>
+      </p:sp>
+    </p:spTree>
+  </p:cSld>
+  <p:clrMapOvr>
+    <a:masterClrMapping/>
+  </p:clrMapOvr>
+</p:sld>
+</file>
+
+<file path=ppt/slides/slide13.xml><?xml version="1.0" encoding="utf-8"?>
+<p:sld xmlns:a="http://schemas.openxmlformats.org/drawingml/2006/main" xmlns:r="http://schemas.openxmlformats.org/officeDocument/2006/relationships" xmlns:p="http://schemas.openxmlformats.org/presentationml/2006/main">
+  <p:cSld name="Slide 13">
+    <p:bg>
+      <p:bgPr>
+        <a:solidFill>
+          <a:srgbClr val="0B0F14"/>
+        </a:solidFill>
+      </p:bgPr>
+    </p:bg>
+    <p:spTree>
+      <p:nvGrpSpPr>
+        <p:cNvPr id="1" name=""/>
+        <p:cNvGrpSpPr/>
+        <p:nvPr/>
+      </p:nvGrpSpPr>
+      <p:grpSpPr>
+        <a:xfrm>
+          <a:off x="0" y="0"/>
+          <a:ext cx="0" cy="0"/>
+          <a:chOff x="0" y="0"/>
+          <a:chExt cx="0" cy="0"/>
+        </a:xfrm>
+      </p:grpSpPr>
+      <p:sp>
+        <p:nvSpPr>
           <p:cNvPr id="2" name="Shape 0"/>
           <p:cNvSpPr/>
           <p:nvPr/>
@@ -7828,7 +10852,7 @@
                 <a:ea typeface="Consolas" pitchFamily="34" charset="-122"/>
                 <a:cs typeface="Consolas" pitchFamily="34" charset="-120"/>
               </a:rPr>
-              <a:t>SCALE &amp; DEPLOY</a:t>
+              <a:t>BUSINESS IMPACT</a:t>
             </a:r>
             <a:endParaRPr lang="en-US" sz="1200" dirty="0"/>
           </a:p>
@@ -7867,7 +10891,7 @@
                 <a:ea typeface="Trebuchet MS" pitchFamily="34" charset="-122"/>
                 <a:cs typeface="Trebuchet MS" pitchFamily="34" charset="-120"/>
               </a:rPr>
-              <a:t>Sits over the sensors you already have</a:t>
+              <a:t>The math a buyer underwrites</a:t>
             </a:r>
             <a:endParaRPr lang="en-US" sz="3400" dirty="0"/>
           </a:p>
@@ -7881,12 +10905,12 @@
         </p:nvSpPr>
         <p:spPr>
           <a:xfrm>
-            <a:off x="640080" y="2148840"/>
-            <a:ext cx="6217920" cy="1143000"/>
+            <a:off x="640080" y="2011680"/>
+            <a:ext cx="4937760" cy="3840480"/>
           </a:xfrm>
           <a:prstGeom prst="roundRect">
             <a:avLst>
-              <a:gd name="adj" fmla="val 7200"/>
+              <a:gd name="adj" fmla="val 2143"/>
             </a:avLst>
           </a:prstGeom>
           <a:solidFill>
@@ -7902,23 +10926,42 @@
       </p:sp>
       <p:sp>
         <p:nvSpPr>
-          <p:cNvPr id="5" name="Shape 3"/>
-          <p:cNvSpPr/>
-          <p:nvPr/>
-        </p:nvSpPr>
-        <p:spPr>
-          <a:xfrm>
-            <a:off x="914400" y="2606040"/>
-            <a:ext cx="182880" cy="182880"/>
-          </a:xfrm>
-          <a:prstGeom prst="ellipse">
-            <a:avLst/>
-          </a:prstGeom>
-          <a:solidFill>
-            <a:srgbClr val="34D3BD"/>
-          </a:solidFill>
-          <a:ln/>
-        </p:spPr>
+          <p:cNvPr id="5" name="Text 3"/>
+          <p:cNvSpPr/>
+          <p:nvPr/>
+        </p:nvSpPr>
+        <p:spPr>
+          <a:xfrm>
+            <a:off x="914400" y="2240280"/>
+            <a:ext cx="4389120" cy="274320"/>
+          </a:xfrm>
+          <a:prstGeom prst="rect">
+            <a:avLst/>
+          </a:prstGeom>
+          <a:noFill/>
+          <a:ln/>
+        </p:spPr>
+        <p:txBody>
+          <a:bodyPr wrap="square" lIns="0" tIns="0" rIns="0" bIns="0" rtlCol="0" anchor="ctr"/>
+          <a:lstStyle/>
+          <a:p>
+            <a:pPr indent="0" marL="0">
+              <a:buNone/>
+            </a:pPr>
+            <a:r>
+              <a:rPr lang="en-US" sz="1100" spc="100" kern="0" dirty="0">
+                <a:solidFill>
+                  <a:srgbClr val="6B7888"/>
+                </a:solidFill>
+                <a:latin typeface="Consolas" pitchFamily="34" charset="0"/>
+                <a:ea typeface="Consolas" pitchFamily="34" charset="-122"/>
+                <a:cs typeface="Consolas" pitchFamily="34" charset="-120"/>
+              </a:rPr>
+              <a:t>PER PREVENTED INCIDENT</a:t>
+            </a:r>
+            <a:endParaRPr lang="en-US" sz="1100" dirty="0"/>
+          </a:p>
+        </p:txBody>
       </p:sp>
       <p:sp>
         <p:nvSpPr>
@@ -7928,24 +10971,24 @@
         </p:nvSpPr>
         <p:spPr>
           <a:xfrm>
-            <a:off x="1280160" y="2313432"/>
-            <a:ext cx="5394960" cy="365760"/>
-          </a:xfrm>
-          <a:prstGeom prst="rect">
-            <a:avLst/>
-          </a:prstGeom>
-          <a:noFill/>
-          <a:ln/>
-        </p:spPr>
-        <p:txBody>
-          <a:bodyPr wrap="square" lIns="0" tIns="0" rIns="0" bIns="0" rtlCol="0" anchor="ctr"/>
-          <a:lstStyle/>
-          <a:p>
-            <a:pPr indent="0" marL="0">
-              <a:buNone/>
-            </a:pPr>
-            <a:r>
-              <a:rPr lang="en-US" sz="1800" b="1" dirty="0">
+            <a:off x="914400" y="2560320"/>
+            <a:ext cx="4389120" cy="868680"/>
+          </a:xfrm>
+          <a:prstGeom prst="rect">
+            <a:avLst/>
+          </a:prstGeom>
+          <a:noFill/>
+          <a:ln/>
+        </p:spPr>
+        <p:txBody>
+          <a:bodyPr wrap="square" lIns="0" tIns="0" rIns="0" bIns="0" rtlCol="0" anchor="ctr"/>
+          <a:lstStyle/>
+          <a:p>
+            <a:pPr indent="0" marL="0">
+              <a:buNone/>
+            </a:pPr>
+            <a:r>
+              <a:rPr lang="en-US" sz="4600" b="1" dirty="0">
                 <a:solidFill>
                   <a:srgbClr val="EAF2FA"/>
                 </a:solidFill>
@@ -7953,9 +10996,9 @@
                 <a:ea typeface="Trebuchet MS" pitchFamily="34" charset="-122"/>
                 <a:cs typeface="Trebuchet MS" pitchFamily="34" charset="-120"/>
               </a:rPr>
-              <a:t>Standard formats</a:t>
-            </a:r>
-            <a:endParaRPr lang="en-US" sz="1800" dirty="0"/>
+              <a:t>₹115.5 Cr</a:t>
+            </a:r>
+            <a:endParaRPr lang="en-US" sz="4600" dirty="0"/>
           </a:p>
         </p:txBody>
       </p:sp>
@@ -7967,24 +11010,24 @@
         </p:nvSpPr>
         <p:spPr>
           <a:xfrm>
-            <a:off x="1280160" y="2715768"/>
-            <a:ext cx="5394960" cy="457200"/>
-          </a:xfrm>
-          <a:prstGeom prst="rect">
-            <a:avLst/>
-          </a:prstGeom>
-          <a:noFill/>
-          <a:ln/>
-        </p:spPr>
-        <p:txBody>
-          <a:bodyPr wrap="square" lIns="0" tIns="0" rIns="0" bIns="0" rtlCol="0" anchor="ctr"/>
-          <a:lstStyle/>
-          <a:p>
-            <a:pPr indent="0" marL="0">
-              <a:buNone/>
-            </a:pPr>
-            <a:r>
-              <a:rPr lang="en-US" sz="1400" dirty="0">
+            <a:off x="914400" y="3401568"/>
+            <a:ext cx="4389120" cy="274320"/>
+          </a:xfrm>
+          <a:prstGeom prst="rect">
+            <a:avLst/>
+          </a:prstGeom>
+          <a:noFill/>
+          <a:ln/>
+        </p:spPr>
+        <p:txBody>
+          <a:bodyPr wrap="square" lIns="0" tIns="0" rIns="0" bIns="0" rtlCol="0" anchor="ctr"/>
+          <a:lstStyle/>
+          <a:p>
+            <a:pPr indent="0" marL="0">
+              <a:buNone/>
+            </a:pPr>
+            <a:r>
+              <a:rPr lang="en-US" sz="1300" dirty="0">
                 <a:solidFill>
                   <a:srgbClr val="6B7888"/>
                 </a:solidFill>
@@ -7992,26 +11035,482 @@
                 <a:ea typeface="Calibri" pitchFamily="34" charset="-122"/>
                 <a:cs typeface="Calibri" pitchFamily="34" charset="-120"/>
               </a:rPr>
-              <a:t>Ingests SCADA / IoT / permit-to-work data as-is</a:t>
-            </a:r>
-            <a:endParaRPr lang="en-US" sz="1400" dirty="0"/>
-          </a:p>
-        </p:txBody>
-      </p:sp>
-      <p:sp>
-        <p:nvSpPr>
-          <p:cNvPr id="8" name="Shape 6"/>
-          <p:cNvSpPr/>
-          <p:nvPr/>
-        </p:nvSpPr>
-        <p:spPr>
-          <a:xfrm>
-            <a:off x="640080" y="3447288"/>
-            <a:ext cx="6217920" cy="1143000"/>
+              <a:t>avoided loss — Vizag-class event</a:t>
+            </a:r>
+            <a:endParaRPr lang="en-US" sz="1300" dirty="0"/>
+          </a:p>
+        </p:txBody>
+      </p:sp>
+      <p:sp>
+        <p:nvSpPr>
+          <p:cNvPr id="8" name="Text 6"/>
+          <p:cNvSpPr/>
+          <p:nvPr/>
+        </p:nvSpPr>
+        <p:spPr>
+          <a:xfrm>
+            <a:off x="914400" y="3977640"/>
+            <a:ext cx="2926080" cy="310896"/>
+          </a:xfrm>
+          <a:prstGeom prst="rect">
+            <a:avLst/>
+          </a:prstGeom>
+          <a:noFill/>
+          <a:ln/>
+        </p:spPr>
+        <p:txBody>
+          <a:bodyPr wrap="square" lIns="0" tIns="0" rIns="0" bIns="0" rtlCol="0" anchor="ctr"/>
+          <a:lstStyle/>
+          <a:p>
+            <a:pPr indent="0" marL="0">
+              <a:buNone/>
+            </a:pPr>
+            <a:r>
+              <a:rPr lang="en-US" sz="1300" dirty="0">
+                <a:solidFill>
+                  <a:srgbClr val="C8D3DE"/>
+                </a:solidFill>
+                <a:latin typeface="Calibri" pitchFamily="34" charset="0"/>
+                <a:ea typeface="Calibri" pitchFamily="34" charset="-122"/>
+                <a:cs typeface="Calibri" pitchFamily="34" charset="-120"/>
+              </a:rPr>
+              <a:t>Lives protected</a:t>
+            </a:r>
+            <a:endParaRPr lang="en-US" sz="1300" dirty="0"/>
+          </a:p>
+        </p:txBody>
+      </p:sp>
+      <p:sp>
+        <p:nvSpPr>
+          <p:cNvPr id="9" name="Text 7"/>
+          <p:cNvSpPr/>
+          <p:nvPr/>
+        </p:nvSpPr>
+        <p:spPr>
+          <a:xfrm>
+            <a:off x="3657600" y="3977640"/>
+            <a:ext cx="1645920" cy="310896"/>
+          </a:xfrm>
+          <a:prstGeom prst="rect">
+            <a:avLst/>
+          </a:prstGeom>
+          <a:noFill/>
+          <a:ln/>
+        </p:spPr>
+        <p:txBody>
+          <a:bodyPr wrap="square" lIns="0" tIns="0" rIns="0" bIns="0" rtlCol="0" anchor="ctr"/>
+          <a:lstStyle/>
+          <a:p>
+            <a:pPr algn="r" indent="0" marL="0">
+              <a:buNone/>
+            </a:pPr>
+            <a:r>
+              <a:rPr lang="en-US" sz="1300" dirty="0">
+                <a:solidFill>
+                  <a:srgbClr val="34D3BD"/>
+                </a:solidFill>
+                <a:latin typeface="Consolas" pitchFamily="34" charset="0"/>
+                <a:ea typeface="Consolas" pitchFamily="34" charset="-122"/>
+                <a:cs typeface="Consolas" pitchFamily="34" charset="-120"/>
+              </a:rPr>
+              <a:t>₹7.5 Cr</a:t>
+            </a:r>
+            <a:endParaRPr lang="en-US" sz="1300" dirty="0"/>
+          </a:p>
+        </p:txBody>
+      </p:sp>
+      <p:sp>
+        <p:nvSpPr>
+          <p:cNvPr id="10" name="Text 8"/>
+          <p:cNvSpPr/>
+          <p:nvPr/>
+        </p:nvSpPr>
+        <p:spPr>
+          <a:xfrm>
+            <a:off x="914400" y="4398264"/>
+            <a:ext cx="2926080" cy="310896"/>
+          </a:xfrm>
+          <a:prstGeom prst="rect">
+            <a:avLst/>
+          </a:prstGeom>
+          <a:noFill/>
+          <a:ln/>
+        </p:spPr>
+        <p:txBody>
+          <a:bodyPr wrap="square" lIns="0" tIns="0" rIns="0" bIns="0" rtlCol="0" anchor="ctr"/>
+          <a:lstStyle/>
+          <a:p>
+            <a:pPr indent="0" marL="0">
+              <a:buNone/>
+            </a:pPr>
+            <a:r>
+              <a:rPr lang="en-US" sz="1300" dirty="0">
+                <a:solidFill>
+                  <a:srgbClr val="C8D3DE"/>
+                </a:solidFill>
+                <a:latin typeface="Calibri" pitchFamily="34" charset="0"/>
+                <a:ea typeface="Calibri" pitchFamily="34" charset="-122"/>
+                <a:cs typeface="Calibri" pitchFamily="34" charset="-120"/>
+              </a:rPr>
+              <a:t>Asset damage</a:t>
+            </a:r>
+            <a:endParaRPr lang="en-US" sz="1300" dirty="0"/>
+          </a:p>
+        </p:txBody>
+      </p:sp>
+      <p:sp>
+        <p:nvSpPr>
+          <p:cNvPr id="11" name="Text 9"/>
+          <p:cNvSpPr/>
+          <p:nvPr/>
+        </p:nvSpPr>
+        <p:spPr>
+          <a:xfrm>
+            <a:off x="3657600" y="4398264"/>
+            <a:ext cx="1645920" cy="310896"/>
+          </a:xfrm>
+          <a:prstGeom prst="rect">
+            <a:avLst/>
+          </a:prstGeom>
+          <a:noFill/>
+          <a:ln/>
+        </p:spPr>
+        <p:txBody>
+          <a:bodyPr wrap="square" lIns="0" tIns="0" rIns="0" bIns="0" rtlCol="0" anchor="ctr"/>
+          <a:lstStyle/>
+          <a:p>
+            <a:pPr algn="r" indent="0" marL="0">
+              <a:buNone/>
+            </a:pPr>
+            <a:r>
+              <a:rPr lang="en-US" sz="1300" dirty="0">
+                <a:solidFill>
+                  <a:srgbClr val="34D3BD"/>
+                </a:solidFill>
+                <a:latin typeface="Consolas" pitchFamily="34" charset="0"/>
+                <a:ea typeface="Consolas" pitchFamily="34" charset="-122"/>
+                <a:cs typeface="Consolas" pitchFamily="34" charset="-120"/>
+              </a:rPr>
+              <a:t>₹40 Cr</a:t>
+            </a:r>
+            <a:endParaRPr lang="en-US" sz="1300" dirty="0"/>
+          </a:p>
+        </p:txBody>
+      </p:sp>
+      <p:sp>
+        <p:nvSpPr>
+          <p:cNvPr id="12" name="Text 10"/>
+          <p:cNvSpPr/>
+          <p:nvPr/>
+        </p:nvSpPr>
+        <p:spPr>
+          <a:xfrm>
+            <a:off x="914400" y="4818888"/>
+            <a:ext cx="2926080" cy="310896"/>
+          </a:xfrm>
+          <a:prstGeom prst="rect">
+            <a:avLst/>
+          </a:prstGeom>
+          <a:noFill/>
+          <a:ln/>
+        </p:spPr>
+        <p:txBody>
+          <a:bodyPr wrap="square" lIns="0" tIns="0" rIns="0" bIns="0" rtlCol="0" anchor="ctr"/>
+          <a:lstStyle/>
+          <a:p>
+            <a:pPr indent="0" marL="0">
+              <a:buNone/>
+            </a:pPr>
+            <a:r>
+              <a:rPr lang="en-US" sz="1300" dirty="0">
+                <a:solidFill>
+                  <a:srgbClr val="C8D3DE"/>
+                </a:solidFill>
+                <a:latin typeface="Calibri" pitchFamily="34" charset="0"/>
+                <a:ea typeface="Calibri" pitchFamily="34" charset="-122"/>
+                <a:cs typeface="Calibri" pitchFamily="34" charset="-120"/>
+              </a:rPr>
+              <a:t>Downtime (21 d)</a:t>
+            </a:r>
+            <a:endParaRPr lang="en-US" sz="1300" dirty="0"/>
+          </a:p>
+        </p:txBody>
+      </p:sp>
+      <p:sp>
+        <p:nvSpPr>
+          <p:cNvPr id="13" name="Text 11"/>
+          <p:cNvSpPr/>
+          <p:nvPr/>
+        </p:nvSpPr>
+        <p:spPr>
+          <a:xfrm>
+            <a:off x="3657600" y="4818888"/>
+            <a:ext cx="1645920" cy="310896"/>
+          </a:xfrm>
+          <a:prstGeom prst="rect">
+            <a:avLst/>
+          </a:prstGeom>
+          <a:noFill/>
+          <a:ln/>
+        </p:spPr>
+        <p:txBody>
+          <a:bodyPr wrap="square" lIns="0" tIns="0" rIns="0" bIns="0" rtlCol="0" anchor="ctr"/>
+          <a:lstStyle/>
+          <a:p>
+            <a:pPr algn="r" indent="0" marL="0">
+              <a:buNone/>
+            </a:pPr>
+            <a:r>
+              <a:rPr lang="en-US" sz="1300" dirty="0">
+                <a:solidFill>
+                  <a:srgbClr val="34D3BD"/>
+                </a:solidFill>
+                <a:latin typeface="Consolas" pitchFamily="34" charset="0"/>
+                <a:ea typeface="Consolas" pitchFamily="34" charset="-122"/>
+                <a:cs typeface="Consolas" pitchFamily="34" charset="-120"/>
+              </a:rPr>
+              <a:t>₹63 Cr</a:t>
+            </a:r>
+            <a:endParaRPr lang="en-US" sz="1300" dirty="0"/>
+          </a:p>
+        </p:txBody>
+      </p:sp>
+      <p:sp>
+        <p:nvSpPr>
+          <p:cNvPr id="14" name="Text 12"/>
+          <p:cNvSpPr/>
+          <p:nvPr/>
+        </p:nvSpPr>
+        <p:spPr>
+          <a:xfrm>
+            <a:off x="914400" y="5239512"/>
+            <a:ext cx="2926080" cy="310896"/>
+          </a:xfrm>
+          <a:prstGeom prst="rect">
+            <a:avLst/>
+          </a:prstGeom>
+          <a:noFill/>
+          <a:ln/>
+        </p:spPr>
+        <p:txBody>
+          <a:bodyPr wrap="square" lIns="0" tIns="0" rIns="0" bIns="0" rtlCol="0" anchor="ctr"/>
+          <a:lstStyle/>
+          <a:p>
+            <a:pPr indent="0" marL="0">
+              <a:buNone/>
+            </a:pPr>
+            <a:r>
+              <a:rPr lang="en-US" sz="1300" dirty="0">
+                <a:solidFill>
+                  <a:srgbClr val="C8D3DE"/>
+                </a:solidFill>
+                <a:latin typeface="Calibri" pitchFamily="34" charset="0"/>
+                <a:ea typeface="Calibri" pitchFamily="34" charset="-122"/>
+                <a:cs typeface="Calibri" pitchFamily="34" charset="-120"/>
+              </a:rPr>
+              <a:t>Regulatory penalty</a:t>
+            </a:r>
+            <a:endParaRPr lang="en-US" sz="1300" dirty="0"/>
+          </a:p>
+        </p:txBody>
+      </p:sp>
+      <p:sp>
+        <p:nvSpPr>
+          <p:cNvPr id="15" name="Text 13"/>
+          <p:cNvSpPr/>
+          <p:nvPr/>
+        </p:nvSpPr>
+        <p:spPr>
+          <a:xfrm>
+            <a:off x="3657600" y="5239512"/>
+            <a:ext cx="1645920" cy="310896"/>
+          </a:xfrm>
+          <a:prstGeom prst="rect">
+            <a:avLst/>
+          </a:prstGeom>
+          <a:noFill/>
+          <a:ln/>
+        </p:spPr>
+        <p:txBody>
+          <a:bodyPr wrap="square" lIns="0" tIns="0" rIns="0" bIns="0" rtlCol="0" anchor="ctr"/>
+          <a:lstStyle/>
+          <a:p>
+            <a:pPr algn="r" indent="0" marL="0">
+              <a:buNone/>
+            </a:pPr>
+            <a:r>
+              <a:rPr lang="en-US" sz="1300" dirty="0">
+                <a:solidFill>
+                  <a:srgbClr val="34D3BD"/>
+                </a:solidFill>
+                <a:latin typeface="Consolas" pitchFamily="34" charset="0"/>
+                <a:ea typeface="Consolas" pitchFamily="34" charset="-122"/>
+                <a:cs typeface="Consolas" pitchFamily="34" charset="-120"/>
+              </a:rPr>
+              <a:t>₹5 Cr</a:t>
+            </a:r>
+            <a:endParaRPr lang="en-US" sz="1300" dirty="0"/>
+          </a:p>
+        </p:txBody>
+      </p:sp>
+      <p:sp>
+        <p:nvSpPr>
+          <p:cNvPr id="16" name="Shape 14"/>
+          <p:cNvSpPr/>
+          <p:nvPr/>
+        </p:nvSpPr>
+        <p:spPr>
+          <a:xfrm>
+            <a:off x="5852160" y="2011680"/>
+            <a:ext cx="5696712" cy="2514600"/>
           </a:xfrm>
           <a:prstGeom prst="roundRect">
             <a:avLst>
-              <a:gd name="adj" fmla="val 7200"/>
+              <a:gd name="adj" fmla="val 3273"/>
+            </a:avLst>
+          </a:prstGeom>
+          <a:solidFill>
+            <a:srgbClr val="0C1218"/>
+          </a:solidFill>
+          <a:ln w="12700">
+            <a:solidFill>
+              <a:srgbClr val="34D3BD"/>
+            </a:solidFill>
+            <a:prstDash val="solid"/>
+          </a:ln>
+        </p:spPr>
+      </p:sp>
+      <p:sp>
+        <p:nvSpPr>
+          <p:cNvPr id="17" name="Text 15"/>
+          <p:cNvSpPr/>
+          <p:nvPr/>
+        </p:nvSpPr>
+        <p:spPr>
+          <a:xfrm>
+            <a:off x="6126480" y="2212848"/>
+            <a:ext cx="5120640" cy="274320"/>
+          </a:xfrm>
+          <a:prstGeom prst="rect">
+            <a:avLst/>
+          </a:prstGeom>
+          <a:noFill/>
+          <a:ln/>
+        </p:spPr>
+        <p:txBody>
+          <a:bodyPr wrap="square" lIns="0" tIns="0" rIns="0" bIns="0" rtlCol="0" anchor="ctr"/>
+          <a:lstStyle/>
+          <a:p>
+            <a:pPr indent="0" marL="0">
+              <a:buNone/>
+            </a:pPr>
+            <a:r>
+              <a:rPr lang="en-US" sz="1100" spc="100" kern="0" dirty="0">
+                <a:solidFill>
+                  <a:srgbClr val="34D3BD"/>
+                </a:solidFill>
+                <a:latin typeface="Consolas" pitchFamily="34" charset="0"/>
+                <a:ea typeface="Consolas" pitchFamily="34" charset="-122"/>
+                <a:cs typeface="Consolas" pitchFamily="34" charset="-120"/>
+              </a:rPr>
+              <a:t>EXPECTED ANNUAL RETURN</a:t>
+            </a:r>
+            <a:endParaRPr lang="en-US" sz="1100" dirty="0"/>
+          </a:p>
+        </p:txBody>
+      </p:sp>
+      <p:sp>
+        <p:nvSpPr>
+          <p:cNvPr id="18" name="Text 16"/>
+          <p:cNvSpPr/>
+          <p:nvPr/>
+        </p:nvSpPr>
+        <p:spPr>
+          <a:xfrm>
+            <a:off x="6126480" y="2542032"/>
+            <a:ext cx="1554480" cy="868680"/>
+          </a:xfrm>
+          <a:prstGeom prst="rect">
+            <a:avLst/>
+          </a:prstGeom>
+          <a:noFill/>
+          <a:ln/>
+        </p:spPr>
+        <p:txBody>
+          <a:bodyPr wrap="square" lIns="0" tIns="0" rIns="0" bIns="0" rtlCol="0" anchor="ctr"/>
+          <a:lstStyle/>
+          <a:p>
+            <a:pPr indent="0" marL="0">
+              <a:buNone/>
+            </a:pPr>
+            <a:r>
+              <a:rPr lang="en-US" sz="4400" b="1" dirty="0">
+                <a:solidFill>
+                  <a:srgbClr val="EAF2FA"/>
+                </a:solidFill>
+                <a:latin typeface="Trebuchet MS" pitchFamily="34" charset="0"/>
+                <a:ea typeface="Trebuchet MS" pitchFamily="34" charset="-122"/>
+                <a:cs typeface="Trebuchet MS" pitchFamily="34" charset="-120"/>
+              </a:rPr>
+              <a:t>≈8×</a:t>
+            </a:r>
+            <a:endParaRPr lang="en-US" sz="4400" dirty="0"/>
+          </a:p>
+        </p:txBody>
+      </p:sp>
+      <p:sp>
+        <p:nvSpPr>
+          <p:cNvPr id="19" name="Text 17"/>
+          <p:cNvSpPr/>
+          <p:nvPr/>
+        </p:nvSpPr>
+        <p:spPr>
+          <a:xfrm>
+            <a:off x="7726680" y="2542032"/>
+            <a:ext cx="3611880" cy="868680"/>
+          </a:xfrm>
+          <a:prstGeom prst="rect">
+            <a:avLst/>
+          </a:prstGeom>
+          <a:noFill/>
+          <a:ln/>
+        </p:spPr>
+        <p:txBody>
+          <a:bodyPr wrap="square" lIns="0" tIns="0" rIns="0" bIns="0" rtlCol="0" anchor="ctr"/>
+          <a:lstStyle/>
+          <a:p>
+            <a:pPr indent="0" marL="0">
+              <a:buNone/>
+            </a:pPr>
+            <a:r>
+              <a:rPr lang="en-US" sz="1300" dirty="0">
+                <a:solidFill>
+                  <a:srgbClr val="C8D3DE"/>
+                </a:solidFill>
+                <a:latin typeface="Calibri" pitchFamily="34" charset="0"/>
+                <a:ea typeface="Calibri" pitchFamily="34" charset="-122"/>
+                <a:cs typeface="Calibri" pitchFamily="34" charset="-120"/>
+              </a:rPr>
+              <a:t>expected annual return on the ₹1 Cr/plant/yr platform — even at a conservative 1-in-15-year event</a:t>
+            </a:r>
+            <a:endParaRPr lang="en-US" sz="1300" dirty="0"/>
+          </a:p>
+        </p:txBody>
+      </p:sp>
+      <p:sp>
+        <p:nvSpPr>
+          <p:cNvPr id="20" name="Shape 18"/>
+          <p:cNvSpPr/>
+          <p:nvPr/>
+        </p:nvSpPr>
+        <p:spPr>
+          <a:xfrm>
+            <a:off x="6126480" y="3566160"/>
+            <a:ext cx="1737360" cy="804672"/>
+          </a:xfrm>
+          <a:prstGeom prst="roundRect">
+            <a:avLst>
+              <a:gd name="adj" fmla="val 10227"/>
             </a:avLst>
           </a:prstGeom>
           <a:solidFill>
@@ -8027,116 +11526,96 @@
       </p:sp>
       <p:sp>
         <p:nvSpPr>
-          <p:cNvPr id="9" name="Shape 7"/>
-          <p:cNvSpPr/>
-          <p:nvPr/>
-        </p:nvSpPr>
-        <p:spPr>
-          <a:xfrm>
-            <a:off x="914400" y="3904488"/>
-            <a:ext cx="182880" cy="182880"/>
-          </a:xfrm>
-          <a:prstGeom prst="ellipse">
-            <a:avLst/>
-          </a:prstGeom>
-          <a:solidFill>
-            <a:srgbClr val="34D3BD"/>
-          </a:solidFill>
-          <a:ln/>
-        </p:spPr>
-      </p:sp>
-      <p:sp>
-        <p:nvSpPr>
-          <p:cNvPr id="10" name="Text 8"/>
-          <p:cNvSpPr/>
-          <p:nvPr/>
-        </p:nvSpPr>
-        <p:spPr>
-          <a:xfrm>
-            <a:off x="1280160" y="3611880"/>
-            <a:ext cx="5394960" cy="365760"/>
-          </a:xfrm>
-          <a:prstGeom prst="rect">
-            <a:avLst/>
-          </a:prstGeom>
-          <a:noFill/>
-          <a:ln/>
-        </p:spPr>
-        <p:txBody>
-          <a:bodyPr wrap="square" lIns="0" tIns="0" rIns="0" bIns="0" rtlCol="0" anchor="ctr"/>
-          <a:lstStyle/>
-          <a:p>
-            <a:pPr indent="0" marL="0">
-              <a:buNone/>
-            </a:pPr>
-            <a:r>
-              <a:rPr lang="en-US" sz="1800" b="1" dirty="0">
-                <a:solidFill>
-                  <a:srgbClr val="EAF2FA"/>
+          <p:cNvPr id="21" name="Text 19"/>
+          <p:cNvSpPr/>
+          <p:nvPr/>
+        </p:nvSpPr>
+        <p:spPr>
+          <a:xfrm>
+            <a:off x="6126480" y="3657600"/>
+            <a:ext cx="1737360" cy="411480"/>
+          </a:xfrm>
+          <a:prstGeom prst="rect">
+            <a:avLst/>
+          </a:prstGeom>
+          <a:noFill/>
+          <a:ln/>
+        </p:spPr>
+        <p:txBody>
+          <a:bodyPr wrap="square" lIns="0" tIns="0" rIns="0" bIns="0" rtlCol="0" anchor="ctr"/>
+          <a:lstStyle/>
+          <a:p>
+            <a:pPr algn="ctr" indent="0" marL="0">
+              <a:buNone/>
+            </a:pPr>
+            <a:r>
+              <a:rPr lang="en-US" sz="2000" b="1" dirty="0">
+                <a:solidFill>
+                  <a:srgbClr val="34D3BD"/>
                 </a:solidFill>
                 <a:latin typeface="Trebuchet MS" pitchFamily="34" charset="0"/>
                 <a:ea typeface="Trebuchet MS" pitchFamily="34" charset="-122"/>
                 <a:cs typeface="Trebuchet MS" pitchFamily="34" charset="-120"/>
               </a:rPr>
-              <a:t>A connector, not a rewrite</a:t>
-            </a:r>
-            <a:endParaRPr lang="en-US" sz="1800" dirty="0"/>
-          </a:p>
-        </p:txBody>
-      </p:sp>
-      <p:sp>
-        <p:nvSpPr>
-          <p:cNvPr id="11" name="Text 9"/>
-          <p:cNvSpPr/>
-          <p:nvPr/>
-        </p:nvSpPr>
-        <p:spPr>
-          <a:xfrm>
-            <a:off x="1280160" y="4014216"/>
-            <a:ext cx="5394960" cy="457200"/>
-          </a:xfrm>
-          <a:prstGeom prst="rect">
-            <a:avLst/>
-          </a:prstGeom>
-          <a:noFill/>
-          <a:ln/>
-        </p:spPr>
-        <p:txBody>
-          <a:bodyPr wrap="square" lIns="0" tIns="0" rIns="0" bIns="0" rtlCol="0" anchor="ctr"/>
-          <a:lstStyle/>
-          <a:p>
-            <a:pPr indent="0" marL="0">
-              <a:buNone/>
-            </a:pPr>
-            <a:r>
-              <a:rPr lang="en-US" sz="1400" dirty="0">
+              <a:t>3.9×</a:t>
+            </a:r>
+            <a:endParaRPr lang="en-US" sz="2000" dirty="0"/>
+          </a:p>
+        </p:txBody>
+      </p:sp>
+      <p:sp>
+        <p:nvSpPr>
+          <p:cNvPr id="22" name="Text 20"/>
+          <p:cNvSpPr/>
+          <p:nvPr/>
+        </p:nvSpPr>
+        <p:spPr>
+          <a:xfrm>
+            <a:off x="6126480" y="4078224"/>
+            <a:ext cx="1737360" cy="228600"/>
+          </a:xfrm>
+          <a:prstGeom prst="rect">
+            <a:avLst/>
+          </a:prstGeom>
+          <a:noFill/>
+          <a:ln/>
+        </p:spPr>
+        <p:txBody>
+          <a:bodyPr wrap="square" lIns="0" tIns="0" rIns="0" bIns="0" rtlCol="0" anchor="ctr"/>
+          <a:lstStyle/>
+          <a:p>
+            <a:pPr algn="ctr" indent="0" marL="0">
+              <a:buNone/>
+            </a:pPr>
+            <a:r>
+              <a:rPr lang="en-US" sz="950" dirty="0">
                 <a:solidFill>
                   <a:srgbClr val="6B7888"/>
                 </a:solidFill>
-                <a:latin typeface="Calibri" pitchFamily="34" charset="0"/>
-                <a:ea typeface="Calibri" pitchFamily="34" charset="-122"/>
-                <a:cs typeface="Calibri" pitchFamily="34" charset="-120"/>
-              </a:rPr>
-              <a:t>Digital twin → live plant swaps the data source, not the brain</a:t>
-            </a:r>
-            <a:endParaRPr lang="en-US" sz="1400" dirty="0"/>
-          </a:p>
-        </p:txBody>
-      </p:sp>
-      <p:sp>
-        <p:nvSpPr>
-          <p:cNvPr id="12" name="Shape 10"/>
-          <p:cNvSpPr/>
-          <p:nvPr/>
-        </p:nvSpPr>
-        <p:spPr>
-          <a:xfrm>
-            <a:off x="640080" y="4745736"/>
-            <a:ext cx="6217920" cy="1143000"/>
+                <a:latin typeface="Consolas" pitchFamily="34" charset="0"/>
+                <a:ea typeface="Consolas" pitchFamily="34" charset="-122"/>
+                <a:cs typeface="Consolas" pitchFamily="34" charset="-120"/>
+              </a:rPr>
+              <a:t>1-in-30 yr</a:t>
+            </a:r>
+            <a:endParaRPr lang="en-US" sz="950" dirty="0"/>
+          </a:p>
+        </p:txBody>
+      </p:sp>
+      <p:sp>
+        <p:nvSpPr>
+          <p:cNvPr id="23" name="Shape 21"/>
+          <p:cNvSpPr/>
+          <p:nvPr/>
+        </p:nvSpPr>
+        <p:spPr>
+          <a:xfrm>
+            <a:off x="7955280" y="3566160"/>
+            <a:ext cx="1737360" cy="804672"/>
           </a:xfrm>
           <a:prstGeom prst="roundRect">
             <a:avLst>
-              <a:gd name="adj" fmla="val 7200"/>
+              <a:gd name="adj" fmla="val 10227"/>
             </a:avLst>
           </a:prstGeom>
           <a:solidFill>
@@ -8152,233 +11631,318 @@
       </p:sp>
       <p:sp>
         <p:nvSpPr>
-          <p:cNvPr id="13" name="Shape 11"/>
-          <p:cNvSpPr/>
-          <p:nvPr/>
-        </p:nvSpPr>
-        <p:spPr>
-          <a:xfrm>
-            <a:off x="914400" y="5202936"/>
-            <a:ext cx="182880" cy="182880"/>
-          </a:xfrm>
-          <a:prstGeom prst="ellipse">
-            <a:avLst/>
-          </a:prstGeom>
-          <a:solidFill>
-            <a:srgbClr val="34D3BD"/>
-          </a:solidFill>
-          <a:ln/>
-        </p:spPr>
-      </p:sp>
-      <p:sp>
-        <p:nvSpPr>
-          <p:cNvPr id="14" name="Text 12"/>
-          <p:cNvSpPr/>
-          <p:nvPr/>
-        </p:nvSpPr>
-        <p:spPr>
-          <a:xfrm>
-            <a:off x="1280160" y="4910328"/>
-            <a:ext cx="5394960" cy="365760"/>
-          </a:xfrm>
-          <a:prstGeom prst="rect">
-            <a:avLst/>
-          </a:prstGeom>
-          <a:noFill/>
-          <a:ln/>
-        </p:spPr>
-        <p:txBody>
-          <a:bodyPr wrap="square" lIns="0" tIns="0" rIns="0" bIns="0" rtlCol="0" anchor="ctr"/>
-          <a:lstStyle/>
-          <a:p>
-            <a:pPr indent="0" marL="0">
-              <a:buNone/>
-            </a:pPr>
-            <a:r>
-              <a:rPr lang="en-US" sz="1800" b="1" dirty="0">
-                <a:solidFill>
-                  <a:srgbClr val="EAF2FA"/>
+          <p:cNvPr id="24" name="Text 22"/>
+          <p:cNvSpPr/>
+          <p:nvPr/>
+        </p:nvSpPr>
+        <p:spPr>
+          <a:xfrm>
+            <a:off x="7955280" y="3657600"/>
+            <a:ext cx="1737360" cy="411480"/>
+          </a:xfrm>
+          <a:prstGeom prst="rect">
+            <a:avLst/>
+          </a:prstGeom>
+          <a:noFill/>
+          <a:ln/>
+        </p:spPr>
+        <p:txBody>
+          <a:bodyPr wrap="square" lIns="0" tIns="0" rIns="0" bIns="0" rtlCol="0" anchor="ctr"/>
+          <a:lstStyle/>
+          <a:p>
+            <a:pPr algn="ctr" indent="0" marL="0">
+              <a:buNone/>
+            </a:pPr>
+            <a:r>
+              <a:rPr lang="en-US" sz="2000" b="1" dirty="0">
+                <a:solidFill>
+                  <a:srgbClr val="34D3BD"/>
                 </a:solidFill>
                 <a:latin typeface="Trebuchet MS" pitchFamily="34" charset="0"/>
                 <a:ea typeface="Trebuchet MS" pitchFamily="34" charset="-122"/>
                 <a:cs typeface="Trebuchet MS" pitchFamily="34" charset="-120"/>
               </a:rPr>
-              <a:t>Auditable &amp; hybrid</a:t>
-            </a:r>
-            <a:endParaRPr lang="en-US" sz="1800" dirty="0"/>
-          </a:p>
-        </p:txBody>
-      </p:sp>
-      <p:sp>
-        <p:nvSpPr>
-          <p:cNvPr id="15" name="Text 13"/>
-          <p:cNvSpPr/>
-          <p:nvPr/>
-        </p:nvSpPr>
-        <p:spPr>
-          <a:xfrm>
-            <a:off x="1280160" y="5312664"/>
-            <a:ext cx="5394960" cy="457200"/>
-          </a:xfrm>
-          <a:prstGeom prst="rect">
-            <a:avLst/>
-          </a:prstGeom>
-          <a:noFill/>
-          <a:ln/>
-        </p:spPr>
-        <p:txBody>
-          <a:bodyPr wrap="square" lIns="0" tIns="0" rIns="0" bIns="0" rtlCol="0" anchor="ctr"/>
-          <a:lstStyle/>
-          <a:p>
-            <a:pPr indent="0" marL="0">
-              <a:buNone/>
-            </a:pPr>
-            <a:r>
-              <a:rPr lang="en-US" sz="1400" dirty="0">
+              <a:t>7.7×</a:t>
+            </a:r>
+            <a:endParaRPr lang="en-US" sz="2000" dirty="0"/>
+          </a:p>
+        </p:txBody>
+      </p:sp>
+      <p:sp>
+        <p:nvSpPr>
+          <p:cNvPr id="25" name="Text 23"/>
+          <p:cNvSpPr/>
+          <p:nvPr/>
+        </p:nvSpPr>
+        <p:spPr>
+          <a:xfrm>
+            <a:off x="7955280" y="4078224"/>
+            <a:ext cx="1737360" cy="228600"/>
+          </a:xfrm>
+          <a:prstGeom prst="rect">
+            <a:avLst/>
+          </a:prstGeom>
+          <a:noFill/>
+          <a:ln/>
+        </p:spPr>
+        <p:txBody>
+          <a:bodyPr wrap="square" lIns="0" tIns="0" rIns="0" bIns="0" rtlCol="0" anchor="ctr"/>
+          <a:lstStyle/>
+          <a:p>
+            <a:pPr algn="ctr" indent="0" marL="0">
+              <a:buNone/>
+            </a:pPr>
+            <a:r>
+              <a:rPr lang="en-US" sz="950" dirty="0">
                 <a:solidFill>
                   <a:srgbClr val="6B7888"/>
+                </a:solidFill>
+                <a:latin typeface="Consolas" pitchFamily="34" charset="0"/>
+                <a:ea typeface="Consolas" pitchFamily="34" charset="-122"/>
+                <a:cs typeface="Consolas" pitchFamily="34" charset="-120"/>
+              </a:rPr>
+              <a:t>1-in-15 yr</a:t>
+            </a:r>
+            <a:endParaRPr lang="en-US" sz="950" dirty="0"/>
+          </a:p>
+        </p:txBody>
+      </p:sp>
+      <p:sp>
+        <p:nvSpPr>
+          <p:cNvPr id="26" name="Shape 24"/>
+          <p:cNvSpPr/>
+          <p:nvPr/>
+        </p:nvSpPr>
+        <p:spPr>
+          <a:xfrm>
+            <a:off x="9784080" y="3566160"/>
+            <a:ext cx="1737360" cy="804672"/>
+          </a:xfrm>
+          <a:prstGeom prst="roundRect">
+            <a:avLst>
+              <a:gd name="adj" fmla="val 10227"/>
+            </a:avLst>
+          </a:prstGeom>
+          <a:solidFill>
+            <a:srgbClr val="10161E"/>
+          </a:solidFill>
+          <a:ln w="12700">
+            <a:solidFill>
+              <a:srgbClr val="26313E"/>
+            </a:solidFill>
+            <a:prstDash val="solid"/>
+          </a:ln>
+        </p:spPr>
+      </p:sp>
+      <p:sp>
+        <p:nvSpPr>
+          <p:cNvPr id="27" name="Text 25"/>
+          <p:cNvSpPr/>
+          <p:nvPr/>
+        </p:nvSpPr>
+        <p:spPr>
+          <a:xfrm>
+            <a:off x="9784080" y="3657600"/>
+            <a:ext cx="1737360" cy="411480"/>
+          </a:xfrm>
+          <a:prstGeom prst="rect">
+            <a:avLst/>
+          </a:prstGeom>
+          <a:noFill/>
+          <a:ln/>
+        </p:spPr>
+        <p:txBody>
+          <a:bodyPr wrap="square" lIns="0" tIns="0" rIns="0" bIns="0" rtlCol="0" anchor="ctr"/>
+          <a:lstStyle/>
+          <a:p>
+            <a:pPr algn="ctr" indent="0" marL="0">
+              <a:buNone/>
+            </a:pPr>
+            <a:r>
+              <a:rPr lang="en-US" sz="2000" b="1" dirty="0">
+                <a:solidFill>
+                  <a:srgbClr val="34D3BD"/>
+                </a:solidFill>
+                <a:latin typeface="Trebuchet MS" pitchFamily="34" charset="0"/>
+                <a:ea typeface="Trebuchet MS" pitchFamily="34" charset="-122"/>
+                <a:cs typeface="Trebuchet MS" pitchFamily="34" charset="-120"/>
+              </a:rPr>
+              <a:t>14.4×</a:t>
+            </a:r>
+            <a:endParaRPr lang="en-US" sz="2000" dirty="0"/>
+          </a:p>
+        </p:txBody>
+      </p:sp>
+      <p:sp>
+        <p:nvSpPr>
+          <p:cNvPr id="28" name="Text 26"/>
+          <p:cNvSpPr/>
+          <p:nvPr/>
+        </p:nvSpPr>
+        <p:spPr>
+          <a:xfrm>
+            <a:off x="9784080" y="4078224"/>
+            <a:ext cx="1737360" cy="228600"/>
+          </a:xfrm>
+          <a:prstGeom prst="rect">
+            <a:avLst/>
+          </a:prstGeom>
+          <a:noFill/>
+          <a:ln/>
+        </p:spPr>
+        <p:txBody>
+          <a:bodyPr wrap="square" lIns="0" tIns="0" rIns="0" bIns="0" rtlCol="0" anchor="ctr"/>
+          <a:lstStyle/>
+          <a:p>
+            <a:pPr algn="ctr" indent="0" marL="0">
+              <a:buNone/>
+            </a:pPr>
+            <a:r>
+              <a:rPr lang="en-US" sz="950" dirty="0">
+                <a:solidFill>
+                  <a:srgbClr val="6B7888"/>
+                </a:solidFill>
+                <a:latin typeface="Consolas" pitchFamily="34" charset="0"/>
+                <a:ea typeface="Consolas" pitchFamily="34" charset="-122"/>
+                <a:cs typeface="Consolas" pitchFamily="34" charset="-120"/>
+              </a:rPr>
+              <a:t>1-in-8 yr</a:t>
+            </a:r>
+            <a:endParaRPr lang="en-US" sz="950" dirty="0"/>
+          </a:p>
+        </p:txBody>
+      </p:sp>
+      <p:sp>
+        <p:nvSpPr>
+          <p:cNvPr id="29" name="Shape 27"/>
+          <p:cNvSpPr/>
+          <p:nvPr/>
+        </p:nvSpPr>
+        <p:spPr>
+          <a:xfrm>
+            <a:off x="5852160" y="4663440"/>
+            <a:ext cx="5696712" cy="1188720"/>
+          </a:xfrm>
+          <a:prstGeom prst="roundRect">
+            <a:avLst>
+              <a:gd name="adj" fmla="val 6923"/>
+            </a:avLst>
+          </a:prstGeom>
+          <a:solidFill>
+            <a:srgbClr val="0C1612"/>
+          </a:solidFill>
+          <a:ln w="12700">
+            <a:solidFill>
+              <a:srgbClr val="3A9D8C"/>
+            </a:solidFill>
+            <a:prstDash val="solid"/>
+          </a:ln>
+        </p:spPr>
+      </p:sp>
+      <p:sp>
+        <p:nvSpPr>
+          <p:cNvPr id="30" name="Text 28"/>
+          <p:cNvSpPr/>
+          <p:nvPr/>
+        </p:nvSpPr>
+        <p:spPr>
+          <a:xfrm>
+            <a:off x="6126480" y="4828032"/>
+            <a:ext cx="5120640" cy="274320"/>
+          </a:xfrm>
+          <a:prstGeom prst="rect">
+            <a:avLst/>
+          </a:prstGeom>
+          <a:noFill/>
+          <a:ln/>
+        </p:spPr>
+        <p:txBody>
+          <a:bodyPr wrap="square" lIns="0" tIns="0" rIns="0" bIns="0" rtlCol="0" anchor="ctr"/>
+          <a:lstStyle/>
+          <a:p>
+            <a:pPr indent="0" marL="0">
+              <a:buNone/>
+            </a:pPr>
+            <a:r>
+              <a:rPr lang="en-US" sz="1100" spc="100" kern="0" dirty="0">
+                <a:solidFill>
+                  <a:srgbClr val="3A9D8C"/>
+                </a:solidFill>
+                <a:latin typeface="Consolas" pitchFamily="34" charset="0"/>
+                <a:ea typeface="Consolas" pitchFamily="34" charset="-122"/>
+                <a:cs typeface="Consolas" pitchFamily="34" charset="-120"/>
+              </a:rPr>
+              <a:t>+ INSURANCE LEVER</a:t>
+            </a:r>
+            <a:endParaRPr lang="en-US" sz="1100" dirty="0"/>
+          </a:p>
+        </p:txBody>
+      </p:sp>
+      <p:sp>
+        <p:nvSpPr>
+          <p:cNvPr id="31" name="Text 29"/>
+          <p:cNvSpPr/>
+          <p:nvPr/>
+        </p:nvSpPr>
+        <p:spPr>
+          <a:xfrm>
+            <a:off x="6126480" y="5102352"/>
+            <a:ext cx="5212080" cy="713232"/>
+          </a:xfrm>
+          <a:prstGeom prst="rect">
+            <a:avLst/>
+          </a:prstGeom>
+          <a:noFill/>
+          <a:ln/>
+        </p:spPr>
+        <p:txBody>
+          <a:bodyPr wrap="square" lIns="0" tIns="0" rIns="0" bIns="0" rtlCol="0" anchor="t"/>
+          <a:lstStyle/>
+          <a:p>
+            <a:pPr indent="0" marL="0">
+              <a:buNone/>
+            </a:pPr>
+            <a:r>
+              <a:rPr lang="en-US" sz="1250" dirty="0">
+                <a:solidFill>
+                  <a:srgbClr val="C8D3DE"/>
                 </a:solidFill>
                 <a:latin typeface="Calibri" pitchFamily="34" charset="0"/>
                 <a:ea typeface="Calibri" pitchFamily="34" charset="-122"/>
                 <a:cs typeface="Calibri" pitchFamily="34" charset="-120"/>
               </a:rPr>
-              <a:t>Deterministic decisions a safety officer can defend in an audit</a:t>
-            </a:r>
-            <a:endParaRPr lang="en-US" sz="1400" dirty="0"/>
-          </a:p>
-        </p:txBody>
-      </p:sp>
-      <p:sp>
-        <p:nvSpPr>
-          <p:cNvPr id="16" name="Shape 14"/>
-          <p:cNvSpPr/>
-          <p:nvPr/>
-        </p:nvSpPr>
-        <p:spPr>
-          <a:xfrm>
-            <a:off x="7223760" y="2148840"/>
-            <a:ext cx="4325112" cy="3694176"/>
-          </a:xfrm>
-          <a:prstGeom prst="roundRect">
-            <a:avLst>
-              <a:gd name="adj" fmla="val 2228"/>
-            </a:avLst>
-          </a:prstGeom>
-          <a:solidFill>
-            <a:srgbClr val="0C1218"/>
-          </a:solidFill>
-          <a:ln w="12700">
-            <a:solidFill>
-              <a:srgbClr val="34D3BD"/>
-            </a:solidFill>
-            <a:prstDash val="solid"/>
-          </a:ln>
-        </p:spPr>
-      </p:sp>
-      <p:sp>
-        <p:nvSpPr>
-          <p:cNvPr id="17" name="Text 15"/>
-          <p:cNvSpPr/>
-          <p:nvPr/>
-        </p:nvSpPr>
-        <p:spPr>
-          <a:xfrm>
-            <a:off x="7498080" y="2377440"/>
-            <a:ext cx="3657600" cy="274320"/>
-          </a:xfrm>
-          <a:prstGeom prst="rect">
-            <a:avLst/>
-          </a:prstGeom>
-          <a:noFill/>
-          <a:ln/>
-        </p:spPr>
-        <p:txBody>
-          <a:bodyPr wrap="square" lIns="0" tIns="0" rIns="0" bIns="0" rtlCol="0" anchor="ctr"/>
-          <a:lstStyle/>
-          <a:p>
-            <a:pPr indent="0" marL="0">
-              <a:buNone/>
-            </a:pPr>
-            <a:r>
-              <a:rPr lang="en-US" sz="1100" spc="200" kern="0" dirty="0">
-                <a:solidFill>
-                  <a:srgbClr val="34D3BD"/>
-                </a:solidFill>
-                <a:latin typeface="Consolas" pitchFamily="34" charset="0"/>
-                <a:ea typeface="Consolas" pitchFamily="34" charset="-122"/>
-                <a:cs typeface="Consolas" pitchFamily="34" charset="-120"/>
-              </a:rPr>
-              <a:t>WHERE IT DEPLOYS</a:t>
-            </a:r>
-            <a:endParaRPr lang="en-US" sz="1100" dirty="0"/>
-          </a:p>
-        </p:txBody>
-      </p:sp>
-      <p:sp>
-        <p:nvSpPr>
-          <p:cNvPr id="18" name="Text 16"/>
-          <p:cNvSpPr/>
-          <p:nvPr/>
-        </p:nvSpPr>
-        <p:spPr>
-          <a:xfrm>
-            <a:off x="7498080" y="2834640"/>
-            <a:ext cx="3840480" cy="320040"/>
-          </a:xfrm>
-          <a:prstGeom prst="rect">
-            <a:avLst/>
-          </a:prstGeom>
-          <a:noFill/>
-          <a:ln/>
-        </p:spPr>
-        <p:txBody>
-          <a:bodyPr wrap="square" lIns="0" tIns="0" rIns="0" bIns="0" rtlCol="0" anchor="ctr"/>
-          <a:lstStyle/>
-          <a:p>
-            <a:pPr indent="0" marL="0">
-              <a:buNone/>
-            </a:pPr>
-            <a:r>
-              <a:rPr lang="en-US" sz="1600" b="1" dirty="0">
-                <a:solidFill>
-                  <a:srgbClr val="EAF2FA"/>
-                </a:solidFill>
-                <a:latin typeface="Trebuchet MS" pitchFamily="34" charset="0"/>
-                <a:ea typeface="Trebuchet MS" pitchFamily="34" charset="-122"/>
-                <a:cs typeface="Trebuchet MS" pitchFamily="34" charset="-120"/>
-              </a:rPr>
-              <a:t>Steel</a:t>
-            </a:r>
-            <a:endParaRPr lang="en-US" sz="1600" dirty="0"/>
-          </a:p>
-        </p:txBody>
-      </p:sp>
-      <p:sp>
-        <p:nvSpPr>
-          <p:cNvPr id="19" name="Text 17"/>
-          <p:cNvSpPr/>
-          <p:nvPr/>
-        </p:nvSpPr>
-        <p:spPr>
-          <a:xfrm>
-            <a:off x="7498080" y="3145536"/>
-            <a:ext cx="3840480" cy="320040"/>
-          </a:xfrm>
-          <a:prstGeom prst="rect">
-            <a:avLst/>
-          </a:prstGeom>
-          <a:noFill/>
-          <a:ln/>
-        </p:spPr>
-        <p:txBody>
-          <a:bodyPr wrap="square" lIns="0" tIns="0" rIns="0" bIns="0" rtlCol="0" anchor="ctr"/>
-          <a:lstStyle/>
-          <a:p>
-            <a:pPr indent="0" marL="0">
-              <a:buNone/>
-            </a:pPr>
-            <a:r>
-              <a:rPr lang="en-US" sz="1200" dirty="0">
+              <a:t>Recurring premium reduction of ₹0.4–1.2 Cr/yr (5–15% for continuous monitoring) — it offsets the platform cost whether or not an incident ever occurs.</a:t>
+            </a:r>
+            <a:endParaRPr lang="en-US" sz="1250" dirty="0"/>
+          </a:p>
+        </p:txBody>
+      </p:sp>
+      <p:sp>
+        <p:nvSpPr>
+          <p:cNvPr id="32" name="Text 30"/>
+          <p:cNvSpPr/>
+          <p:nvPr/>
+        </p:nvSpPr>
+        <p:spPr>
+          <a:xfrm>
+            <a:off x="640080" y="6035040"/>
+            <a:ext cx="10972800" cy="274320"/>
+          </a:xfrm>
+          <a:prstGeom prst="rect">
+            <a:avLst/>
+          </a:prstGeom>
+          <a:noFill/>
+          <a:ln/>
+        </p:spPr>
+        <p:txBody>
+          <a:bodyPr wrap="square" lIns="0" tIns="0" rIns="0" bIns="0" rtlCol="0" anchor="ctr"/>
+          <a:lstStyle/>
+          <a:p>
+            <a:pPr indent="0" marL="0">
+              <a:buNone/>
+            </a:pPr>
+            <a:r>
+              <a:rPr lang="en-US" sz="1100" i="1" dirty="0">
                 <a:solidFill>
                   <a:srgbClr val="6B7888"/>
                 </a:solidFill>
@@ -8386,243 +11950,9 @@
                 <a:ea typeface="Calibri" pitchFamily="34" charset="-122"/>
                 <a:cs typeface="Calibri" pitchFamily="34" charset="-120"/>
               </a:rPr>
-              <a:t>coke ovens, blast furnaces</a:t>
-            </a:r>
-            <a:endParaRPr lang="en-US" sz="1200" dirty="0"/>
-          </a:p>
-        </p:txBody>
-      </p:sp>
-      <p:sp>
-        <p:nvSpPr>
-          <p:cNvPr id="20" name="Text 18"/>
-          <p:cNvSpPr/>
-          <p:nvPr/>
-        </p:nvSpPr>
-        <p:spPr>
-          <a:xfrm>
-            <a:off x="7498080" y="3584448"/>
-            <a:ext cx="3840480" cy="320040"/>
-          </a:xfrm>
-          <a:prstGeom prst="rect">
-            <a:avLst/>
-          </a:prstGeom>
-          <a:noFill/>
-          <a:ln/>
-        </p:spPr>
-        <p:txBody>
-          <a:bodyPr wrap="square" lIns="0" tIns="0" rIns="0" bIns="0" rtlCol="0" anchor="ctr"/>
-          <a:lstStyle/>
-          <a:p>
-            <a:pPr indent="0" marL="0">
-              <a:buNone/>
-            </a:pPr>
-            <a:r>
-              <a:rPr lang="en-US" sz="1600" b="1" dirty="0">
-                <a:solidFill>
-                  <a:srgbClr val="EAF2FA"/>
-                </a:solidFill>
-                <a:latin typeface="Trebuchet MS" pitchFamily="34" charset="0"/>
-                <a:ea typeface="Trebuchet MS" pitchFamily="34" charset="-122"/>
-                <a:cs typeface="Trebuchet MS" pitchFamily="34" charset="-120"/>
-              </a:rPr>
-              <a:t>Refining &amp; Petrochem</a:t>
-            </a:r>
-            <a:endParaRPr lang="en-US" sz="1600" dirty="0"/>
-          </a:p>
-        </p:txBody>
-      </p:sp>
-      <p:sp>
-        <p:nvSpPr>
-          <p:cNvPr id="21" name="Text 19"/>
-          <p:cNvSpPr/>
-          <p:nvPr/>
-        </p:nvSpPr>
-        <p:spPr>
-          <a:xfrm>
-            <a:off x="7498080" y="3895344"/>
-            <a:ext cx="3840480" cy="320040"/>
-          </a:xfrm>
-          <a:prstGeom prst="rect">
-            <a:avLst/>
-          </a:prstGeom>
-          <a:noFill/>
-          <a:ln/>
-        </p:spPr>
-        <p:txBody>
-          <a:bodyPr wrap="square" lIns="0" tIns="0" rIns="0" bIns="0" rtlCol="0" anchor="ctr"/>
-          <a:lstStyle/>
-          <a:p>
-            <a:pPr indent="0" marL="0">
-              <a:buNone/>
-            </a:pPr>
-            <a:r>
-              <a:rPr lang="en-US" sz="1200" dirty="0">
-                <a:solidFill>
-                  <a:srgbClr val="6B7888"/>
-                </a:solidFill>
-                <a:latin typeface="Calibri" pitchFamily="34" charset="0"/>
-                <a:ea typeface="Calibri" pitchFamily="34" charset="-122"/>
-                <a:cs typeface="Calibri" pitchFamily="34" charset="-120"/>
-              </a:rPr>
-              <a:t>OISD permit-to-work regimes</a:t>
-            </a:r>
-            <a:endParaRPr lang="en-US" sz="1200" dirty="0"/>
-          </a:p>
-        </p:txBody>
-      </p:sp>
-      <p:sp>
-        <p:nvSpPr>
-          <p:cNvPr id="22" name="Text 20"/>
-          <p:cNvSpPr/>
-          <p:nvPr/>
-        </p:nvSpPr>
-        <p:spPr>
-          <a:xfrm>
-            <a:off x="7498080" y="4334256"/>
-            <a:ext cx="3840480" cy="320040"/>
-          </a:xfrm>
-          <a:prstGeom prst="rect">
-            <a:avLst/>
-          </a:prstGeom>
-          <a:noFill/>
-          <a:ln/>
-        </p:spPr>
-        <p:txBody>
-          <a:bodyPr wrap="square" lIns="0" tIns="0" rIns="0" bIns="0" rtlCol="0" anchor="ctr"/>
-          <a:lstStyle/>
-          <a:p>
-            <a:pPr indent="0" marL="0">
-              <a:buNone/>
-            </a:pPr>
-            <a:r>
-              <a:rPr lang="en-US" sz="1600" b="1" dirty="0">
-                <a:solidFill>
-                  <a:srgbClr val="EAF2FA"/>
-                </a:solidFill>
-                <a:latin typeface="Trebuchet MS" pitchFamily="34" charset="0"/>
-                <a:ea typeface="Trebuchet MS" pitchFamily="34" charset="-122"/>
-                <a:cs typeface="Trebuchet MS" pitchFamily="34" charset="-120"/>
-              </a:rPr>
-              <a:t>Mining</a:t>
-            </a:r>
-            <a:endParaRPr lang="en-US" sz="1600" dirty="0"/>
-          </a:p>
-        </p:txBody>
-      </p:sp>
-      <p:sp>
-        <p:nvSpPr>
-          <p:cNvPr id="23" name="Text 21"/>
-          <p:cNvSpPr/>
-          <p:nvPr/>
-        </p:nvSpPr>
-        <p:spPr>
-          <a:xfrm>
-            <a:off x="7498080" y="4645152"/>
-            <a:ext cx="3840480" cy="320040"/>
-          </a:xfrm>
-          <a:prstGeom prst="rect">
-            <a:avLst/>
-          </a:prstGeom>
-          <a:noFill/>
-          <a:ln/>
-        </p:spPr>
-        <p:txBody>
-          <a:bodyPr wrap="square" lIns="0" tIns="0" rIns="0" bIns="0" rtlCol="0" anchor="ctr"/>
-          <a:lstStyle/>
-          <a:p>
-            <a:pPr indent="0" marL="0">
-              <a:buNone/>
-            </a:pPr>
-            <a:r>
-              <a:rPr lang="en-US" sz="1200" dirty="0">
-                <a:solidFill>
-                  <a:srgbClr val="6B7888"/>
-                </a:solidFill>
-                <a:latin typeface="Calibri" pitchFamily="34" charset="0"/>
-                <a:ea typeface="Calibri" pitchFamily="34" charset="-122"/>
-                <a:cs typeface="Calibri" pitchFamily="34" charset="-120"/>
-              </a:rPr>
-              <a:t>confined-space &amp; gas hazards</a:t>
-            </a:r>
-            <a:endParaRPr lang="en-US" sz="1200" dirty="0"/>
-          </a:p>
-        </p:txBody>
-      </p:sp>
-      <p:sp>
-        <p:nvSpPr>
-          <p:cNvPr id="24" name="Text 22"/>
-          <p:cNvSpPr/>
-          <p:nvPr/>
-        </p:nvSpPr>
-        <p:spPr>
-          <a:xfrm>
-            <a:off x="7498080" y="5084064"/>
-            <a:ext cx="3840480" cy="320040"/>
-          </a:xfrm>
-          <a:prstGeom prst="rect">
-            <a:avLst/>
-          </a:prstGeom>
-          <a:noFill/>
-          <a:ln/>
-        </p:spPr>
-        <p:txBody>
-          <a:bodyPr wrap="square" lIns="0" tIns="0" rIns="0" bIns="0" rtlCol="0" anchor="ctr"/>
-          <a:lstStyle/>
-          <a:p>
-            <a:pPr indent="0" marL="0">
-              <a:buNone/>
-            </a:pPr>
-            <a:r>
-              <a:rPr lang="en-US" sz="1600" b="1" dirty="0">
-                <a:solidFill>
-                  <a:srgbClr val="EAF2FA"/>
-                </a:solidFill>
-                <a:latin typeface="Trebuchet MS" pitchFamily="34" charset="0"/>
-                <a:ea typeface="Trebuchet MS" pitchFamily="34" charset="-122"/>
-                <a:cs typeface="Trebuchet MS" pitchFamily="34" charset="-120"/>
-              </a:rPr>
-              <a:t>Power &amp; Chemicals</a:t>
-            </a:r>
-            <a:endParaRPr lang="en-US" sz="1600" dirty="0"/>
-          </a:p>
-        </p:txBody>
-      </p:sp>
-      <p:sp>
-        <p:nvSpPr>
-          <p:cNvPr id="25" name="Text 23"/>
-          <p:cNvSpPr/>
-          <p:nvPr/>
-        </p:nvSpPr>
-        <p:spPr>
-          <a:xfrm>
-            <a:off x="7498080" y="5394960"/>
-            <a:ext cx="3840480" cy="320040"/>
-          </a:xfrm>
-          <a:prstGeom prst="rect">
-            <a:avLst/>
-          </a:prstGeom>
-          <a:noFill/>
-          <a:ln/>
-        </p:spPr>
-        <p:txBody>
-          <a:bodyPr wrap="square" lIns="0" tIns="0" rIns="0" bIns="0" rtlCol="0" anchor="ctr"/>
-          <a:lstStyle/>
-          <a:p>
-            <a:pPr indent="0" marL="0">
-              <a:buNone/>
-            </a:pPr>
-            <a:r>
-              <a:rPr lang="en-US" sz="1200" dirty="0">
-                <a:solidFill>
-                  <a:srgbClr val="6B7888"/>
-                </a:solidFill>
-                <a:latin typeface="Calibri" pitchFamily="34" charset="0"/>
-                <a:ea typeface="Calibri" pitchFamily="34" charset="-122"/>
-                <a:cs typeface="Calibri" pitchFamily="34" charset="-120"/>
-              </a:rPr>
-              <a:t>asset-intensive operations</a:t>
-            </a:r>
-            <a:endParaRPr lang="en-US" sz="1200" dirty="0"/>
+              <a:t>Per-incident loss (lives + asset + downtime + penalty), every figure sourced, × a conservative event frequency — not a 116×-per-incident headline.</a:t>
+            </a:r>
+            <a:endParaRPr lang="en-US" sz="1100" dirty="0"/>
           </a:p>
         </p:txBody>
       </p:sp>

</xml_diff>

<commit_message>
Make the precedent match live and consistent across cached/live
Gemini embeddings run on a separate quota and are working, so the disaster-memory
match is computed live: Vizag 81%, Texas City 73%, hot-work 71%. The cached
fallback ranking only engages if the embedding quota is down, so align it to the
live ranking - the precedents now read identically whether or not the API is up
(previously the fallback showed a different secondary order than live).

- disaster_memory.py: _HERO fallback aligned to the live embedding ranking
  (vizag 0.808, texas-city 0.726, hotwork 0.714)
- deck + demo script: secondary precedents = Texas City 73%, hot-work 71%,
  matching what the screen actually shows

The autonomous text still degrades to vetted cached briefings/reports under burst
load by design - the safety call never depends on a model being up.
</commit_message>
<xml_diff>
--- a/docs/Trinetra_Deck.pptx
+++ b/docs/Trinetra_Deck.pptx
@@ -10016,7 +10016,7 @@
                 <a:ea typeface="Calibri" pitchFamily="34" charset="-122"/>
                 <a:cs typeface="Calibri" pitchFamily="34" charset="-120"/>
               </a:rPr>
-              <a:t>Hot-work ignition</a:t>
+              <a:t>Texas City refinery</a:t>
             </a:r>
             <a:endParaRPr lang="en-US" sz="1200" dirty="0"/>
           </a:p>
@@ -10121,7 +10121,7 @@
                 <a:ea typeface="Calibri" pitchFamily="34" charset="-122"/>
                 <a:cs typeface="Calibri" pitchFamily="34" charset="-120"/>
               </a:rPr>
-              <a:t>Confined-space H2S</a:t>
+              <a:t>Hot-work ignition</a:t>
             </a:r>
             <a:endParaRPr lang="en-US" sz="1200" dirty="0"/>
           </a:p>

</xml_diff>

<commit_message>
Align the deck and demo script to the live ROI and fleet figures
The business slide led with ~8x expected annual ROI while the running app
reports 7.7x at the same 1-in-15-year anchor. The deck and the demo script
now both say 7.7x (and 3.9x at 1-in-30) so the pitch matches the engine.

The fleet command slide claimed six plants but listed only five — added the
sixth site (Ennore Terminal, a watch-level reading) so the board matches its
own aggregate, with a dedicated watch colour.

Demo script: scoped the CCTV narration to a sample feed (a live camera is a
connector) and added a booth / attract-mode beat for the exhibition floor.
</commit_message>
<xml_diff>
--- a/docs/Trinetra_Deck.pptx
+++ b/docs/Trinetra_Deck.pptx
@@ -4282,7 +4282,7 @@
               <a:buNone/>
             </a:pPr>
             <a:r>
-              <a:rPr lang="en-US" sz="4400" b="1" dirty="0">
+              <a:rPr lang="en-US" sz="3800" b="1" dirty="0">
                 <a:solidFill>
                   <a:srgbClr val="F7EFE1"/>
                 </a:solidFill>
@@ -4290,9 +4290,9 @@
                 <a:ea typeface="Trebuchet MS" pitchFamily="34" charset="-122"/>
                 <a:cs typeface="Trebuchet MS" pitchFamily="34" charset="-120"/>
               </a:rPr>
-              <a:t>≈8×</a:t>
-            </a:r>
-            <a:endParaRPr lang="en-US" sz="4400" dirty="0"/>
+              <a:t>≈7.7×</a:t>
+            </a:r>
+            <a:endParaRPr lang="en-US" sz="3800" dirty="0"/>
           </a:p>
         </p:txBody>
       </p:sp>
@@ -6127,12 +6127,12 @@
         </p:nvSpPr>
         <p:spPr>
           <a:xfrm>
-            <a:off x="640080" y="3429000"/>
-            <a:ext cx="10908792" cy="457200"/>
+            <a:off x="640080" y="3273552"/>
+            <a:ext cx="10908792" cy="402336"/>
           </a:xfrm>
           <a:prstGeom prst="roundRect">
             <a:avLst>
-              <a:gd name="adj" fmla="val 18000"/>
+              <a:gd name="adj" fmla="val 20455"/>
             </a:avLst>
           </a:prstGeom>
           <a:solidFill>
@@ -6154,8 +6154,8 @@
         </p:nvSpPr>
         <p:spPr>
           <a:xfrm>
-            <a:off x="640080" y="3429000"/>
-            <a:ext cx="54864" cy="457200"/>
+            <a:off x="640080" y="3273552"/>
+            <a:ext cx="54864" cy="402336"/>
           </a:xfrm>
           <a:prstGeom prst="rect">
             <a:avLst/>
@@ -6174,24 +6174,24 @@
         </p:nvSpPr>
         <p:spPr>
           <a:xfrm>
-            <a:off x="868680" y="3429000"/>
-            <a:ext cx="5760720" cy="457200"/>
-          </a:xfrm>
-          <a:prstGeom prst="rect">
-            <a:avLst/>
-          </a:prstGeom>
-          <a:noFill/>
-          <a:ln/>
-        </p:spPr>
-        <p:txBody>
-          <a:bodyPr wrap="square" lIns="0" tIns="0" rIns="0" bIns="0" rtlCol="0" anchor="ctr"/>
-          <a:lstStyle/>
-          <a:p>
-            <a:pPr indent="0" marL="0">
-              <a:buNone/>
-            </a:pPr>
-            <a:r>
-              <a:rPr lang="en-US" sz="1300" b="1" dirty="0">
+            <a:off x="868680" y="3273552"/>
+            <a:ext cx="5760720" cy="402336"/>
+          </a:xfrm>
+          <a:prstGeom prst="rect">
+            <a:avLst/>
+          </a:prstGeom>
+          <a:noFill/>
+          <a:ln/>
+        </p:spPr>
+        <p:txBody>
+          <a:bodyPr wrap="square" lIns="0" tIns="0" rIns="0" bIns="0" rtlCol="0" anchor="ctr"/>
+          <a:lstStyle/>
+          <a:p>
+            <a:pPr indent="0" marL="0">
+              <a:buNone/>
+            </a:pPr>
+            <a:r>
+              <a:rPr lang="en-US" sz="1250" b="1" dirty="0">
                 <a:solidFill>
                   <a:srgbClr val="F7EFE1"/>
                 </a:solidFill>
@@ -6201,7 +6201,7 @@
               </a:rPr>
               <a:t>Visakhapatnam Steel — Coke Ovens</a:t>
             </a:r>
-            <a:endParaRPr lang="en-US" sz="1300" dirty="0"/>
+            <a:endParaRPr lang="en-US" sz="1250" dirty="0"/>
           </a:p>
         </p:txBody>
       </p:sp>
@@ -6213,24 +6213,24 @@
         </p:nvSpPr>
         <p:spPr>
           <a:xfrm>
-            <a:off x="6675120" y="3429000"/>
-            <a:ext cx="3566160" cy="457200"/>
-          </a:xfrm>
-          <a:prstGeom prst="rect">
-            <a:avLst/>
-          </a:prstGeom>
-          <a:noFill/>
-          <a:ln/>
-        </p:spPr>
-        <p:txBody>
-          <a:bodyPr wrap="square" lIns="0" tIns="0" rIns="0" bIns="0" rtlCol="0" anchor="ctr"/>
-          <a:lstStyle/>
-          <a:p>
-            <a:pPr indent="0" marL="0">
-              <a:buNone/>
-            </a:pPr>
-            <a:r>
-              <a:rPr lang="en-US" sz="1100" dirty="0">
+            <a:off x="6675120" y="3273552"/>
+            <a:ext cx="3566160" cy="402336"/>
+          </a:xfrm>
+          <a:prstGeom prst="rect">
+            <a:avLst/>
+          </a:prstGeom>
+          <a:noFill/>
+          <a:ln/>
+        </p:spPr>
+        <p:txBody>
+          <a:bodyPr wrap="square" lIns="0" tIns="0" rIns="0" bIns="0" rtlCol="0" anchor="ctr"/>
+          <a:lstStyle/>
+          <a:p>
+            <a:pPr indent="0" marL="0">
+              <a:buNone/>
+            </a:pPr>
+            <a:r>
+              <a:rPr lang="en-US" sz="1050" dirty="0">
                 <a:solidFill>
                   <a:srgbClr val="FF2B4E"/>
                 </a:solidFill>
@@ -6240,7 +6240,7 @@
               </a:rPr>
               <a:t>CRITICAL · COMPOUND</a:t>
             </a:r>
-            <a:endParaRPr lang="en-US" sz="1100" dirty="0"/>
+            <a:endParaRPr lang="en-US" sz="1050" dirty="0"/>
           </a:p>
         </p:txBody>
       </p:sp>
@@ -6252,8 +6252,8 @@
         </p:nvSpPr>
         <p:spPr>
           <a:xfrm>
-            <a:off x="10149840" y="3429000"/>
-            <a:ext cx="1280160" cy="457200"/>
+            <a:off x="10149840" y="3273552"/>
+            <a:ext cx="1280160" cy="402336"/>
           </a:xfrm>
           <a:prstGeom prst="rect">
             <a:avLst/>
@@ -6269,7 +6269,7 @@
               <a:buNone/>
             </a:pPr>
             <a:r>
-              <a:rPr lang="en-US" sz="1100" b="1" dirty="0">
+              <a:rPr lang="en-US" sz="1050" b="1" dirty="0">
                 <a:solidFill>
                   <a:srgbClr val="FF6A1A"/>
                 </a:solidFill>
@@ -6279,7 +6279,7 @@
               </a:rPr>
               <a:t>+6m lead</a:t>
             </a:r>
-            <a:endParaRPr lang="en-US" sz="1100" dirty="0"/>
+            <a:endParaRPr lang="en-US" sz="1050" dirty="0"/>
           </a:p>
         </p:txBody>
       </p:sp>
@@ -6291,12 +6291,12 @@
         </p:nvSpPr>
         <p:spPr>
           <a:xfrm>
-            <a:off x="640080" y="3941064"/>
-            <a:ext cx="10908792" cy="457200"/>
+            <a:off x="640080" y="3721608"/>
+            <a:ext cx="10908792" cy="402336"/>
           </a:xfrm>
           <a:prstGeom prst="roundRect">
             <a:avLst>
-              <a:gd name="adj" fmla="val 18000"/>
+              <a:gd name="adj" fmla="val 20455"/>
             </a:avLst>
           </a:prstGeom>
           <a:solidFill>
@@ -6318,8 +6318,8 @@
         </p:nvSpPr>
         <p:spPr>
           <a:xfrm>
-            <a:off x="640080" y="3941064"/>
-            <a:ext cx="54864" cy="457200"/>
+            <a:off x="640080" y="3721608"/>
+            <a:ext cx="54864" cy="402336"/>
           </a:xfrm>
           <a:prstGeom prst="rect">
             <a:avLst/>
@@ -6338,24 +6338,24 @@
         </p:nvSpPr>
         <p:spPr>
           <a:xfrm>
-            <a:off x="868680" y="3941064"/>
-            <a:ext cx="5760720" cy="457200"/>
-          </a:xfrm>
-          <a:prstGeom prst="rect">
-            <a:avLst/>
-          </a:prstGeom>
-          <a:noFill/>
-          <a:ln/>
-        </p:spPr>
-        <p:txBody>
-          <a:bodyPr wrap="square" lIns="0" tIns="0" rIns="0" bIns="0" rtlCol="0" anchor="ctr"/>
-          <a:lstStyle/>
-          <a:p>
-            <a:pPr indent="0" marL="0">
-              <a:buNone/>
-            </a:pPr>
-            <a:r>
-              <a:rPr lang="en-US" sz="1300" b="1" dirty="0">
+            <a:off x="868680" y="3721608"/>
+            <a:ext cx="5760720" cy="402336"/>
+          </a:xfrm>
+          <a:prstGeom prst="rect">
+            <a:avLst/>
+          </a:prstGeom>
+          <a:noFill/>
+          <a:ln/>
+        </p:spPr>
+        <p:txBody>
+          <a:bodyPr wrap="square" lIns="0" tIns="0" rIns="0" bIns="0" rtlCol="0" anchor="ctr"/>
+          <a:lstStyle/>
+          <a:p>
+            <a:pPr indent="0" marL="0">
+              <a:buNone/>
+            </a:pPr>
+            <a:r>
+              <a:rPr lang="en-US" sz="1250" b="1" dirty="0">
                 <a:solidFill>
                   <a:srgbClr val="F7EFE1"/>
                 </a:solidFill>
@@ -6365,7 +6365,7 @@
               </a:rPr>
               <a:t>Paradip Refinery — Coker Unit</a:t>
             </a:r>
-            <a:endParaRPr lang="en-US" sz="1300" dirty="0"/>
+            <a:endParaRPr lang="en-US" sz="1250" dirty="0"/>
           </a:p>
         </p:txBody>
       </p:sp>
@@ -6377,24 +6377,24 @@
         </p:nvSpPr>
         <p:spPr>
           <a:xfrm>
-            <a:off x="6675120" y="3941064"/>
-            <a:ext cx="3566160" cy="457200"/>
-          </a:xfrm>
-          <a:prstGeom prst="rect">
-            <a:avLst/>
-          </a:prstGeom>
-          <a:noFill/>
-          <a:ln/>
-        </p:spPr>
-        <p:txBody>
-          <a:bodyPr wrap="square" lIns="0" tIns="0" rIns="0" bIns="0" rtlCol="0" anchor="ctr"/>
-          <a:lstStyle/>
-          <a:p>
-            <a:pPr indent="0" marL="0">
-              <a:buNone/>
-            </a:pPr>
-            <a:r>
-              <a:rPr lang="en-US" sz="1100" dirty="0">
+            <a:off x="6675120" y="3721608"/>
+            <a:ext cx="3566160" cy="402336"/>
+          </a:xfrm>
+          <a:prstGeom prst="rect">
+            <a:avLst/>
+          </a:prstGeom>
+          <a:noFill/>
+          <a:ln/>
+        </p:spPr>
+        <p:txBody>
+          <a:bodyPr wrap="square" lIns="0" tIns="0" rIns="0" bIns="0" rtlCol="0" anchor="ctr"/>
+          <a:lstStyle/>
+          <a:p>
+            <a:pPr indent="0" marL="0">
+              <a:buNone/>
+            </a:pPr>
+            <a:r>
+              <a:rPr lang="en-US" sz="1050" dirty="0">
                 <a:solidFill>
                   <a:srgbClr val="FF2B4E"/>
                 </a:solidFill>
@@ -6404,7 +6404,7 @@
               </a:rPr>
               <a:t>HIGH · COMPOUND</a:t>
             </a:r>
-            <a:endParaRPr lang="en-US" sz="1100" dirty="0"/>
+            <a:endParaRPr lang="en-US" sz="1050" dirty="0"/>
           </a:p>
         </p:txBody>
       </p:sp>
@@ -6416,8 +6416,8 @@
         </p:nvSpPr>
         <p:spPr>
           <a:xfrm>
-            <a:off x="10149840" y="3941064"/>
-            <a:ext cx="1280160" cy="457200"/>
+            <a:off x="10149840" y="3721608"/>
+            <a:ext cx="1280160" cy="402336"/>
           </a:xfrm>
           <a:prstGeom prst="rect">
             <a:avLst/>
@@ -6433,7 +6433,7 @@
               <a:buNone/>
             </a:pPr>
             <a:r>
-              <a:rPr lang="en-US" sz="1100" b="1" dirty="0">
+              <a:rPr lang="en-US" sz="1050" b="1" dirty="0">
                 <a:solidFill>
                   <a:srgbClr val="FF6A1A"/>
                 </a:solidFill>
@@ -6443,7 +6443,7 @@
               </a:rPr>
               <a:t>+4m lead</a:t>
             </a:r>
-            <a:endParaRPr lang="en-US" sz="1100" dirty="0"/>
+            <a:endParaRPr lang="en-US" sz="1050" dirty="0"/>
           </a:p>
         </p:txBody>
       </p:sp>
@@ -6455,12 +6455,12 @@
         </p:nvSpPr>
         <p:spPr>
           <a:xfrm>
-            <a:off x="640080" y="4453128"/>
-            <a:ext cx="10908792" cy="457200"/>
+            <a:off x="640080" y="4169664"/>
+            <a:ext cx="10908792" cy="402336"/>
           </a:xfrm>
           <a:prstGeom prst="roundRect">
             <a:avLst>
-              <a:gd name="adj" fmla="val 18000"/>
+              <a:gd name="adj" fmla="val 20455"/>
             </a:avLst>
           </a:prstGeom>
           <a:solidFill>
@@ -6482,8 +6482,8 @@
         </p:nvSpPr>
         <p:spPr>
           <a:xfrm>
-            <a:off x="640080" y="4453128"/>
-            <a:ext cx="54864" cy="457200"/>
+            <a:off x="640080" y="4169664"/>
+            <a:ext cx="54864" cy="402336"/>
           </a:xfrm>
           <a:prstGeom prst="rect">
             <a:avLst/>
@@ -6502,24 +6502,24 @@
         </p:nvSpPr>
         <p:spPr>
           <a:xfrm>
-            <a:off x="868680" y="4453128"/>
-            <a:ext cx="5760720" cy="457200"/>
-          </a:xfrm>
-          <a:prstGeom prst="rect">
-            <a:avLst/>
-          </a:prstGeom>
-          <a:noFill/>
-          <a:ln/>
-        </p:spPr>
-        <p:txBody>
-          <a:bodyPr wrap="square" lIns="0" tIns="0" rIns="0" bIns="0" rtlCol="0" anchor="ctr"/>
-          <a:lstStyle/>
-          <a:p>
-            <a:pPr indent="0" marL="0">
-              <a:buNone/>
-            </a:pPr>
-            <a:r>
-              <a:rPr lang="en-US" sz="1300" b="1" dirty="0">
+            <a:off x="868680" y="4169664"/>
+            <a:ext cx="5760720" cy="402336"/>
+          </a:xfrm>
+          <a:prstGeom prst="rect">
+            <a:avLst/>
+          </a:prstGeom>
+          <a:noFill/>
+          <a:ln/>
+        </p:spPr>
+        <p:txBody>
+          <a:bodyPr wrap="square" lIns="0" tIns="0" rIns="0" bIns="0" rtlCol="0" anchor="ctr"/>
+          <a:lstStyle/>
+          <a:p>
+            <a:pPr indent="0" marL="0">
+              <a:buNone/>
+            </a:pPr>
+            <a:r>
+              <a:rPr lang="en-US" sz="1250" b="1" dirty="0">
                 <a:solidFill>
                   <a:srgbClr val="F7EFE1"/>
                 </a:solidFill>
@@ -6529,7 +6529,7 @@
               </a:rPr>
               <a:t>Dahej Petrochemicals — Gas Cleaning</a:t>
             </a:r>
-            <a:endParaRPr lang="en-US" sz="1300" dirty="0"/>
+            <a:endParaRPr lang="en-US" sz="1250" dirty="0"/>
           </a:p>
         </p:txBody>
       </p:sp>
@@ -6541,24 +6541,24 @@
         </p:nvSpPr>
         <p:spPr>
           <a:xfrm>
-            <a:off x="6675120" y="4453128"/>
-            <a:ext cx="3566160" cy="457200"/>
-          </a:xfrm>
-          <a:prstGeom prst="rect">
-            <a:avLst/>
-          </a:prstGeom>
-          <a:noFill/>
-          <a:ln/>
-        </p:spPr>
-        <p:txBody>
-          <a:bodyPr wrap="square" lIns="0" tIns="0" rIns="0" bIns="0" rtlCol="0" anchor="ctr"/>
-          <a:lstStyle/>
-          <a:p>
-            <a:pPr indent="0" marL="0">
-              <a:buNone/>
-            </a:pPr>
-            <a:r>
-              <a:rPr lang="en-US" sz="1100" dirty="0">
+            <a:off x="6675120" y="4169664"/>
+            <a:ext cx="3566160" cy="402336"/>
+          </a:xfrm>
+          <a:prstGeom prst="rect">
+            <a:avLst/>
+          </a:prstGeom>
+          <a:noFill/>
+          <a:ln/>
+        </p:spPr>
+        <p:txBody>
+          <a:bodyPr wrap="square" lIns="0" tIns="0" rIns="0" bIns="0" rtlCol="0" anchor="ctr"/>
+          <a:lstStyle/>
+          <a:p>
+            <a:pPr indent="0" marL="0">
+              <a:buNone/>
+            </a:pPr>
+            <a:r>
+              <a:rPr lang="en-US" sz="1050" dirty="0">
                 <a:solidFill>
                   <a:srgbClr val="F5902B"/>
                 </a:solidFill>
@@ -6568,7 +6568,7 @@
               </a:rPr>
               <a:t>HIGH · gas, no compound</a:t>
             </a:r>
-            <a:endParaRPr lang="en-US" sz="1100" dirty="0"/>
+            <a:endParaRPr lang="en-US" sz="1050" dirty="0"/>
           </a:p>
         </p:txBody>
       </p:sp>
@@ -6580,12 +6580,12 @@
         </p:nvSpPr>
         <p:spPr>
           <a:xfrm>
-            <a:off x="640080" y="4965192"/>
-            <a:ext cx="10908792" cy="457200"/>
+            <a:off x="640080" y="4617720"/>
+            <a:ext cx="10908792" cy="402336"/>
           </a:xfrm>
           <a:prstGeom prst="roundRect">
             <a:avLst>
-              <a:gd name="adj" fmla="val 18000"/>
+              <a:gd name="adj" fmla="val 20455"/>
             </a:avLst>
           </a:prstGeom>
           <a:solidFill>
@@ -6607,14 +6607,14 @@
         </p:nvSpPr>
         <p:spPr>
           <a:xfrm>
-            <a:off x="640080" y="4965192"/>
-            <a:ext cx="54864" cy="457200"/>
+            <a:off x="640080" y="4617720"/>
+            <a:ext cx="54864" cy="402336"/>
           </a:xfrm>
           <a:prstGeom prst="rect">
             <a:avLst/>
           </a:prstGeom>
           <a:solidFill>
-            <a:srgbClr val="6B7886"/>
+            <a:srgbClr val="EFC23C"/>
           </a:solidFill>
           <a:ln/>
         </p:spPr>
@@ -6627,24 +6627,24 @@
         </p:nvSpPr>
         <p:spPr>
           <a:xfrm>
-            <a:off x="868680" y="4965192"/>
-            <a:ext cx="5760720" cy="457200"/>
-          </a:xfrm>
-          <a:prstGeom prst="rect">
-            <a:avLst/>
-          </a:prstGeom>
-          <a:noFill/>
-          <a:ln/>
-        </p:spPr>
-        <p:txBody>
-          <a:bodyPr wrap="square" lIns="0" tIns="0" rIns="0" bIns="0" rtlCol="0" anchor="ctr"/>
-          <a:lstStyle/>
-          <a:p>
-            <a:pPr indent="0" marL="0">
-              <a:buNone/>
-            </a:pPr>
-            <a:r>
-              <a:rPr lang="en-US" sz="1300" b="1" dirty="0">
+            <a:off x="868680" y="4617720"/>
+            <a:ext cx="5760720" cy="402336"/>
+          </a:xfrm>
+          <a:prstGeom prst="rect">
+            <a:avLst/>
+          </a:prstGeom>
+          <a:noFill/>
+          <a:ln/>
+        </p:spPr>
+        <p:txBody>
+          <a:bodyPr wrap="square" lIns="0" tIns="0" rIns="0" bIns="0" rtlCol="0" anchor="ctr"/>
+          <a:lstStyle/>
+          <a:p>
+            <a:pPr indent="0" marL="0">
+              <a:buNone/>
+            </a:pPr>
+            <a:r>
+              <a:rPr lang="en-US" sz="1250" b="1" dirty="0">
                 <a:solidFill>
                   <a:srgbClr val="F7EFE1"/>
                 </a:solidFill>
@@ -6652,9 +6652,9 @@
                 <a:ea typeface="Trebuchet MS" pitchFamily="34" charset="-122"/>
                 <a:cs typeface="Trebuchet MS" pitchFamily="34" charset="-120"/>
               </a:rPr>
-              <a:t>Bhilai Steel — Blast Furnace</a:t>
-            </a:r>
-            <a:endParaRPr lang="en-US" sz="1300" dirty="0"/>
+              <a:t>Ennore Terminal — Utilities</a:t>
+            </a:r>
+            <a:endParaRPr lang="en-US" sz="1250" dirty="0"/>
           </a:p>
         </p:txBody>
       </p:sp>
@@ -6666,34 +6666,34 @@
         </p:nvSpPr>
         <p:spPr>
           <a:xfrm>
-            <a:off x="6675120" y="4965192"/>
-            <a:ext cx="3566160" cy="457200"/>
-          </a:xfrm>
-          <a:prstGeom prst="rect">
-            <a:avLst/>
-          </a:prstGeom>
-          <a:noFill/>
-          <a:ln/>
-        </p:spPr>
-        <p:txBody>
-          <a:bodyPr wrap="square" lIns="0" tIns="0" rIns="0" bIns="0" rtlCol="0" anchor="ctr"/>
-          <a:lstStyle/>
-          <a:p>
-            <a:pPr indent="0" marL="0">
-              <a:buNone/>
-            </a:pPr>
-            <a:r>
-              <a:rPr lang="en-US" sz="1100" dirty="0">
-                <a:solidFill>
-                  <a:srgbClr val="6B7886"/>
+            <a:off x="6675120" y="4617720"/>
+            <a:ext cx="3566160" cy="402336"/>
+          </a:xfrm>
+          <a:prstGeom prst="rect">
+            <a:avLst/>
+          </a:prstGeom>
+          <a:noFill/>
+          <a:ln/>
+        </p:spPr>
+        <p:txBody>
+          <a:bodyPr wrap="square" lIns="0" tIns="0" rIns="0" bIns="0" rtlCol="0" anchor="ctr"/>
+          <a:lstStyle/>
+          <a:p>
+            <a:pPr indent="0" marL="0">
+              <a:buNone/>
+            </a:pPr>
+            <a:r>
+              <a:rPr lang="en-US" sz="1050" dirty="0">
+                <a:solidFill>
+                  <a:srgbClr val="EFC23C"/>
                 </a:solidFill>
                 <a:latin typeface="Consolas" pitchFamily="34" charset="0"/>
                 <a:ea typeface="Consolas" pitchFamily="34" charset="-122"/>
                 <a:cs typeface="Consolas" pitchFamily="34" charset="-120"/>
               </a:rPr>
-              <a:t>NORMAL · permits clear</a:t>
-            </a:r>
-            <a:endParaRPr lang="en-US" sz="1100" dirty="0"/>
+              <a:t>WATCH · gas, no compound</a:t>
+            </a:r>
+            <a:endParaRPr lang="en-US" sz="1050" dirty="0"/>
           </a:p>
         </p:txBody>
       </p:sp>
@@ -6705,12 +6705,12 @@
         </p:nvSpPr>
         <p:spPr>
           <a:xfrm>
-            <a:off x="640080" y="5477256"/>
-            <a:ext cx="10908792" cy="457200"/>
+            <a:off x="640080" y="5065776"/>
+            <a:ext cx="10908792" cy="402336"/>
           </a:xfrm>
           <a:prstGeom prst="roundRect">
             <a:avLst>
-              <a:gd name="adj" fmla="val 18000"/>
+              <a:gd name="adj" fmla="val 20455"/>
             </a:avLst>
           </a:prstGeom>
           <a:solidFill>
@@ -6732,8 +6732,8 @@
         </p:nvSpPr>
         <p:spPr>
           <a:xfrm>
-            <a:off x="640080" y="5477256"/>
-            <a:ext cx="54864" cy="457200"/>
+            <a:off x="640080" y="5065776"/>
+            <a:ext cx="54864" cy="402336"/>
           </a:xfrm>
           <a:prstGeom prst="rect">
             <a:avLst/>
@@ -6752,24 +6752,24 @@
         </p:nvSpPr>
         <p:spPr>
           <a:xfrm>
-            <a:off x="868680" y="5477256"/>
-            <a:ext cx="5760720" cy="457200"/>
-          </a:xfrm>
-          <a:prstGeom prst="rect">
-            <a:avLst/>
-          </a:prstGeom>
-          <a:noFill/>
-          <a:ln/>
-        </p:spPr>
-        <p:txBody>
-          <a:bodyPr wrap="square" lIns="0" tIns="0" rIns="0" bIns="0" rtlCol="0" anchor="ctr"/>
-          <a:lstStyle/>
-          <a:p>
-            <a:pPr indent="0" marL="0">
-              <a:buNone/>
-            </a:pPr>
-            <a:r>
-              <a:rPr lang="en-US" sz="1300" b="1" dirty="0">
+            <a:off x="868680" y="5065776"/>
+            <a:ext cx="5760720" cy="402336"/>
+          </a:xfrm>
+          <a:prstGeom prst="rect">
+            <a:avLst/>
+          </a:prstGeom>
+          <a:noFill/>
+          <a:ln/>
+        </p:spPr>
+        <p:txBody>
+          <a:bodyPr wrap="square" lIns="0" tIns="0" rIns="0" bIns="0" rtlCol="0" anchor="ctr"/>
+          <a:lstStyle/>
+          <a:p>
+            <a:pPr indent="0" marL="0">
+              <a:buNone/>
+            </a:pPr>
+            <a:r>
+              <a:rPr lang="en-US" sz="1250" b="1" dirty="0">
                 <a:solidFill>
                   <a:srgbClr val="F7EFE1"/>
                 </a:solidFill>
@@ -6777,9 +6777,9 @@
                 <a:ea typeface="Trebuchet MS" pitchFamily="34" charset="-122"/>
                 <a:cs typeface="Trebuchet MS" pitchFamily="34" charset="-120"/>
               </a:rPr>
-              <a:t>Haldia — Pump House</a:t>
-            </a:r>
-            <a:endParaRPr lang="en-US" sz="1300" dirty="0"/>
+              <a:t>Bhilai Steel — Blast Furnace</a:t>
+            </a:r>
+            <a:endParaRPr lang="en-US" sz="1250" dirty="0"/>
           </a:p>
         </p:txBody>
       </p:sp>
@@ -6791,24 +6791,24 @@
         </p:nvSpPr>
         <p:spPr>
           <a:xfrm>
-            <a:off x="6675120" y="5477256"/>
-            <a:ext cx="3566160" cy="457200"/>
-          </a:xfrm>
-          <a:prstGeom prst="rect">
-            <a:avLst/>
-          </a:prstGeom>
-          <a:noFill/>
-          <a:ln/>
-        </p:spPr>
-        <p:txBody>
-          <a:bodyPr wrap="square" lIns="0" tIns="0" rIns="0" bIns="0" rtlCol="0" anchor="ctr"/>
-          <a:lstStyle/>
-          <a:p>
-            <a:pPr indent="0" marL="0">
-              <a:buNone/>
-            </a:pPr>
-            <a:r>
-              <a:rPr lang="en-US" sz="1100" dirty="0">
+            <a:off x="6675120" y="5065776"/>
+            <a:ext cx="3566160" cy="402336"/>
+          </a:xfrm>
+          <a:prstGeom prst="rect">
+            <a:avLst/>
+          </a:prstGeom>
+          <a:noFill/>
+          <a:ln/>
+        </p:spPr>
+        <p:txBody>
+          <a:bodyPr wrap="square" lIns="0" tIns="0" rIns="0" bIns="0" rtlCol="0" anchor="ctr"/>
+          <a:lstStyle/>
+          <a:p>
+            <a:pPr indent="0" marL="0">
+              <a:buNone/>
+            </a:pPr>
+            <a:r>
+              <a:rPr lang="en-US" sz="1050" dirty="0">
                 <a:solidFill>
                   <a:srgbClr val="6B7886"/>
                 </a:solidFill>
@@ -6816,15 +6816,140 @@
                 <a:ea typeface="Consolas" pitchFamily="34" charset="-122"/>
                 <a:cs typeface="Consolas" pitchFamily="34" charset="-120"/>
               </a:rPr>
+              <a:t>NORMAL · permits clear</a:t>
+            </a:r>
+            <a:endParaRPr lang="en-US" sz="1050" dirty="0"/>
+          </a:p>
+        </p:txBody>
+      </p:sp>
+      <p:sp>
+        <p:nvSpPr>
+          <p:cNvPr id="41" name="Shape 39"/>
+          <p:cNvSpPr/>
+          <p:nvPr/>
+        </p:nvSpPr>
+        <p:spPr>
+          <a:xfrm>
+            <a:off x="640080" y="5513832"/>
+            <a:ext cx="10908792" cy="402336"/>
+          </a:xfrm>
+          <a:prstGeom prst="roundRect">
+            <a:avLst>
+              <a:gd name="adj" fmla="val 20455"/>
+            </a:avLst>
+          </a:prstGeom>
+          <a:solidFill>
+            <a:srgbClr val="100C09"/>
+          </a:solidFill>
+          <a:ln w="12700">
+            <a:solidFill>
+              <a:srgbClr val="3B2E22"/>
+            </a:solidFill>
+            <a:prstDash val="solid"/>
+          </a:ln>
+        </p:spPr>
+      </p:sp>
+      <p:sp>
+        <p:nvSpPr>
+          <p:cNvPr id="42" name="Shape 40"/>
+          <p:cNvSpPr/>
+          <p:nvPr/>
+        </p:nvSpPr>
+        <p:spPr>
+          <a:xfrm>
+            <a:off x="640080" y="5513832"/>
+            <a:ext cx="54864" cy="402336"/>
+          </a:xfrm>
+          <a:prstGeom prst="rect">
+            <a:avLst/>
+          </a:prstGeom>
+          <a:solidFill>
+            <a:srgbClr val="6B7886"/>
+          </a:solidFill>
+          <a:ln/>
+        </p:spPr>
+      </p:sp>
+      <p:sp>
+        <p:nvSpPr>
+          <p:cNvPr id="43" name="Text 41"/>
+          <p:cNvSpPr/>
+          <p:nvPr/>
+        </p:nvSpPr>
+        <p:spPr>
+          <a:xfrm>
+            <a:off x="868680" y="5513832"/>
+            <a:ext cx="5760720" cy="402336"/>
+          </a:xfrm>
+          <a:prstGeom prst="rect">
+            <a:avLst/>
+          </a:prstGeom>
+          <a:noFill/>
+          <a:ln/>
+        </p:spPr>
+        <p:txBody>
+          <a:bodyPr wrap="square" lIns="0" tIns="0" rIns="0" bIns="0" rtlCol="0" anchor="ctr"/>
+          <a:lstStyle/>
+          <a:p>
+            <a:pPr indent="0" marL="0">
+              <a:buNone/>
+            </a:pPr>
+            <a:r>
+              <a:rPr lang="en-US" sz="1250" b="1" dirty="0">
+                <a:solidFill>
+                  <a:srgbClr val="F7EFE1"/>
+                </a:solidFill>
+                <a:latin typeface="Trebuchet MS" pitchFamily="34" charset="0"/>
+                <a:ea typeface="Trebuchet MS" pitchFamily="34" charset="-122"/>
+                <a:cs typeface="Trebuchet MS" pitchFamily="34" charset="-120"/>
+              </a:rPr>
+              <a:t>Haldia — Pump House</a:t>
+            </a:r>
+            <a:endParaRPr lang="en-US" sz="1250" dirty="0"/>
+          </a:p>
+        </p:txBody>
+      </p:sp>
+      <p:sp>
+        <p:nvSpPr>
+          <p:cNvPr id="44" name="Text 42"/>
+          <p:cNvSpPr/>
+          <p:nvPr/>
+        </p:nvSpPr>
+        <p:spPr>
+          <a:xfrm>
+            <a:off x="6675120" y="5513832"/>
+            <a:ext cx="3566160" cy="402336"/>
+          </a:xfrm>
+          <a:prstGeom prst="rect">
+            <a:avLst/>
+          </a:prstGeom>
+          <a:noFill/>
+          <a:ln/>
+        </p:spPr>
+        <p:txBody>
+          <a:bodyPr wrap="square" lIns="0" tIns="0" rIns="0" bIns="0" rtlCol="0" anchor="ctr"/>
+          <a:lstStyle/>
+          <a:p>
+            <a:pPr indent="0" marL="0">
+              <a:buNone/>
+            </a:pPr>
+            <a:r>
+              <a:rPr lang="en-US" sz="1050" dirty="0">
+                <a:solidFill>
+                  <a:srgbClr val="6B7886"/>
+                </a:solidFill>
+                <a:latin typeface="Consolas" pitchFamily="34" charset="0"/>
+                <a:ea typeface="Consolas" pitchFamily="34" charset="-122"/>
+                <a:cs typeface="Consolas" pitchFamily="34" charset="-120"/>
+              </a:rPr>
               <a:t>NORMAL · transient cleared</a:t>
             </a:r>
-            <a:endParaRPr lang="en-US" sz="1100" dirty="0"/>
-          </a:p>
-        </p:txBody>
-      </p:sp>
-      <p:sp>
-        <p:nvSpPr>
-          <p:cNvPr id="41" name="Text 39"/>
+            <a:endParaRPr lang="en-US" sz="1050" dirty="0"/>
+          </a:p>
+        </p:txBody>
+      </p:sp>
+      <p:sp>
+        <p:nvSpPr>
+          <p:cNvPr id="45" name="Text 43"/>
           <p:cNvSpPr/>
           <p:nvPr/>
         </p:nvSpPr>

</xml_diff>

<commit_message>
Round-2 credibility pass: honest incident framing, 28-count, asphyxiation narrative
Acts on the two round-2 reviews' lower-severity findings.
- The real-incident slide drops "VALIDATED ON REAL DISASTERS / no tuning" for
  "REPLAYED FROM TWO REAL INQUIRIES / reconstructed inputs"; the replay.py comment
  matches (the gas channel is a reconstruction, the engine is untuned).
- The moat slide's "data network effect" becomes a per-plant data moat / switching
  cost — what the per-plant flywheel actually is.
- README and the generalization docstring say 28, not 25.
- The demo script reads "prepared", consistent with the product.
- The asphyxiation + sensor-trust upgrade is documented: three new rows in the
  BACKTEST robustness table (now eight checks) and a line in the discriminating-
  negative section.
</commit_message>
<xml_diff>
--- a/docs/Trinetra_Deck.pptx
+++ b/docs/Trinetra_Deck.pptx
@@ -3868,7 +3868,7 @@
                 <a:ea typeface="Consolas" pitchFamily="34" charset="-122"/>
                 <a:cs typeface="Consolas" pitchFamily="34" charset="-120"/>
               </a:rPr>
-              <a:t>VALIDATED ON REAL DISASTERS</a:t>
+              <a:t>REPLAYED FROM TWO REAL INQUIRIES</a:t>
             </a:r>
             <a:endParaRPr lang="en-US" sz="1200" dirty="0"/>
           </a:p>
@@ -4495,7 +4495,7 @@
                 <a:ea typeface="Calibri" pitchFamily="34" charset="-122"/>
                 <a:cs typeface="Calibri" pitchFamily="34" charset="-120"/>
               </a:rPr>
-              <a:t>Same engine, no tuning.  </a:t>
+              <a:t>Same engine, reconstructed inputs.  </a:t>
             </a:r>
             <a:pPr indent="0" marL="0">
               <a:buNone/>
@@ -6814,7 +6814,7 @@
                 <a:ea typeface="Trebuchet MS" pitchFamily="34" charset="-122"/>
                 <a:cs typeface="Trebuchet MS" pitchFamily="34" charset="-120"/>
               </a:rPr>
-              <a:t>A data network effect</a:t>
+              <a:t>A per-plant data moat</a:t>
             </a:r>
             <a:endParaRPr lang="en-US" sz="1550" dirty="0"/>
           </a:p>
@@ -6853,7 +6853,7 @@
                 <a:ea typeface="Calibri" pitchFamily="34" charset="-122"/>
                 <a:cs typeface="Calibri" pitchFamily="34" charset="-120"/>
               </a:rPr>
-              <a:t>Each plant's operator feedback tunes its own nuisance profile (the flywheel). More sites → sharper per-plant precision; an incumbent's fixed hardware doesn't learn.</a:t>
+              <a:t>Each plant's operator feedback tunes its own nuisance profile (the flywheel) — proprietary data that compounds per site and raises switching cost. An incumbent's fixed hardware doesn't learn.</a:t>
             </a:r>
             <a:endParaRPr lang="en-US" sz="1250" dirty="0"/>
           </a:p>

</xml_diff>

<commit_message>
Fix the deck opening with a PowerPoint repair prompt
The brand-mark triangle drew its edges as line shapes with a raw width =
end - start, which goes negative when a segment runs right-to-left or
bottom-to-top. That emitted <a:ext cx="-914400"> on the title and close
slides — a negative extent is invalid OOXML, so PowerPoint flagged the file
("found a problem with content") and offered to repair on open.

Normalise each edge to a min-corner origin with absolute width/height and
flip the anti-diagonal, so the triangle is visually identical but every
extent is non-negative. The deck now opens cleanly (0 negative extents across
all 20 slides; loads without repair). Pre-existing latent defect — present in
every prior build — surfaced during deck QA. Engine untouched; gate set
byte-identical.
</commit_message>
<xml_diff>
--- a/docs/Trinetra_Deck.pptx
+++ b/docs/Trinetra_Deck.pptx
@@ -2597,8 +2597,8 @@
         </p:nvSpPr>
         <p:spPr>
           <a:xfrm>
-            <a:off x="6547104" y="2240280"/>
-            <a:ext cx="-914400" cy="0"/>
+            <a:off x="5632704" y="2240280"/>
+            <a:ext cx="914400" cy="0"/>
           </a:xfrm>
           <a:prstGeom prst="line">
             <a:avLst/>
@@ -2619,9 +2619,9 @@
           <p:nvPr/>
         </p:nvSpPr>
         <p:spPr>
-          <a:xfrm>
-            <a:off x="5632704" y="2240280"/>
-            <a:ext cx="457200" cy="-914400"/>
+          <a:xfrm flipH="1">
+            <a:off x="5632704" y="1325880"/>
+            <a:ext cx="457200" cy="914400"/>
           </a:xfrm>
           <a:prstGeom prst="line">
             <a:avLst/>
@@ -13247,8 +13247,8 @@
         </p:nvSpPr>
         <p:spPr>
           <a:xfrm>
-            <a:off x="6501384" y="1920240"/>
-            <a:ext cx="-822960" cy="0"/>
+            <a:off x="5678424" y="1920240"/>
+            <a:ext cx="822960" cy="0"/>
           </a:xfrm>
           <a:prstGeom prst="line">
             <a:avLst/>
@@ -13269,9 +13269,9 @@
           <p:nvPr/>
         </p:nvSpPr>
         <p:spPr>
-          <a:xfrm>
-            <a:off x="5678424" y="1920240"/>
-            <a:ext cx="411480" cy="-822960"/>
+          <a:xfrm flipH="1">
+            <a:off x="5678424" y="1097280"/>
+            <a:ext cx="411480" cy="822960"/>
           </a:xfrm>
           <a:prstGeom prst="line">
             <a:avLst/>

</xml_diff>

<commit_message>
Add a real architecture diagram + fix the field-validation slide overlap
Replace the capability-pills slide with a proper layered architecture
diagram: data sources -> ingest/twin -> the deterministic Compound Engine
(highlighted as the core) -> response -> control room, with the LLM
intelligence layer feeding the engine it explains. Makes the system, the
data flow, and the "no LLM in the decision" boundary legible at a glance.

Fix slide 3 (field validation): the response panel and the footnote
overlapped at the bottom — moved the panel up so they clear.

Deck + PDF regenerated. Engine untouched; gate set byte-identical.
</commit_message>
<xml_diff>
--- a/docs/Trinetra_Deck.pptx
+++ b/docs/Trinetra_Deck.pptx
@@ -14459,8 +14459,8 @@
         </p:nvSpPr>
         <p:spPr>
           <a:xfrm>
-            <a:off x="777240" y="4663440"/>
-            <a:ext cx="10637215" cy="1371600"/>
+            <a:off x="777240" y="4443984"/>
+            <a:ext cx="10637215" cy="1280160"/>
           </a:xfrm>
           <a:prstGeom prst="rect">
             <a:avLst/>
@@ -14484,8 +14484,8 @@
         </p:nvSpPr>
         <p:spPr>
           <a:xfrm>
-            <a:off x="777240" y="4663440"/>
-            <a:ext cx="45720" cy="1371600"/>
+            <a:off x="777240" y="4443984"/>
+            <a:ext cx="45720" cy="1280160"/>
           </a:xfrm>
           <a:prstGeom prst="rect">
             <a:avLst/>
@@ -14504,7 +14504,7 @@
         </p:nvSpPr>
         <p:spPr>
           <a:xfrm>
-            <a:off x="1097280" y="4846320"/>
+            <a:off x="1097280" y="4608576"/>
             <a:ext cx="7315200" cy="274320"/>
           </a:xfrm>
           <a:prstGeom prst="rect">
@@ -14543,8 +14543,8 @@
         </p:nvSpPr>
         <p:spPr>
           <a:xfrm>
-            <a:off x="1097280" y="5175504"/>
-            <a:ext cx="9997135" cy="777240"/>
+            <a:off x="1097280" y="4937760"/>
+            <a:ext cx="9997135" cy="731520"/>
           </a:xfrm>
           <a:prstGeom prst="rect">
             <a:avLst/>
@@ -14602,7 +14602,7 @@
         </p:nvSpPr>
         <p:spPr>
           <a:xfrm>
-            <a:off x="777240" y="5989320"/>
+            <a:off x="777240" y="5961888"/>
             <a:ext cx="10637215" cy="274320"/>
           </a:xfrm>
           <a:prstGeom prst="rect">
@@ -16504,7 +16504,7 @@
                 <a:ea typeface="Cascadia Mono" pitchFamily="34" charset="-122"/>
                 <a:cs typeface="Cascadia Mono" pitchFamily="34" charset="-120"/>
               </a:rPr>
-              <a:t>HOW IT WORKS</a:t>
+              <a:t>ARCHITECTURE</a:t>
             </a:r>
             <a:endParaRPr lang="en-US" sz="1050" dirty="0"/>
           </a:p>
@@ -16546,7 +16546,7 @@
                 <a:ea typeface="Bahnschrift SemiBold" pitchFamily="34" charset="-122"/>
                 <a:cs typeface="Bahnschrift SemiBold" pitchFamily="34" charset="-120"/>
               </a:rPr>
-              <a:t>One multi-modal brain</a:t>
+              <a:t>How it works</a:t>
             </a:r>
             <a:endParaRPr lang="en-US" sz="3300" dirty="0"/>
           </a:p>
@@ -16560,16 +16560,21 @@
         </p:nvSpPr>
         <p:spPr>
           <a:xfrm>
-            <a:off x="941832" y="2212848"/>
-            <a:ext cx="365760" cy="45720"/>
+            <a:off x="777240" y="1938528"/>
+            <a:ext cx="10637215" cy="676656"/>
           </a:xfrm>
           <a:prstGeom prst="rect">
             <a:avLst/>
           </a:prstGeom>
           <a:solidFill>
-            <a:srgbClr val="FF6A1A"/>
+            <a:srgbClr val="151009"/>
           </a:solidFill>
-          <a:ln/>
+          <a:ln w="12700">
+            <a:solidFill>
+              <a:srgbClr val="473726"/>
+            </a:solidFill>
+            <a:prstDash val="solid"/>
+          </a:ln>
         </p:spPr>
       </p:sp>
       <p:sp>
@@ -16580,24 +16585,24 @@
         </p:nvSpPr>
         <p:spPr>
           <a:xfrm>
-            <a:off x="941832" y="2377440"/>
-            <a:ext cx="1853123" cy="274320"/>
-          </a:xfrm>
-          <a:prstGeom prst="rect">
-            <a:avLst/>
-          </a:prstGeom>
-          <a:noFill/>
-          <a:ln/>
-        </p:spPr>
-        <p:txBody>
-          <a:bodyPr wrap="square" lIns="0" tIns="0" rIns="0" bIns="0" rtlCol="0" anchor="t"/>
-          <a:lstStyle/>
-          <a:p>
-            <a:pPr indent="0" marL="0">
-              <a:buNone/>
-            </a:pPr>
-            <a:r>
-              <a:rPr lang="en-US" sz="1000" dirty="0">
+            <a:off x="1005840" y="2048256"/>
+            <a:ext cx="7315200" cy="228600"/>
+          </a:xfrm>
+          <a:prstGeom prst="rect">
+            <a:avLst/>
+          </a:prstGeom>
+          <a:noFill/>
+          <a:ln/>
+        </p:spPr>
+        <p:txBody>
+          <a:bodyPr wrap="square" lIns="0" tIns="0" rIns="0" bIns="0" rtlCol="0" anchor="t"/>
+          <a:lstStyle/>
+          <a:p>
+            <a:pPr indent="0" marL="0">
+              <a:buNone/>
+            </a:pPr>
+            <a:r>
+              <a:rPr lang="en-US" sz="900" spc="100" kern="0" dirty="0">
                 <a:solidFill>
                   <a:srgbClr val="FF6A1A"/>
                 </a:solidFill>
@@ -16605,9 +16610,9 @@
                 <a:ea typeface="Cascadia Mono" pitchFamily="34" charset="-122"/>
                 <a:cs typeface="Cascadia Mono" pitchFamily="34" charset="-120"/>
               </a:rPr>
-              <a:t>01</a:t>
-            </a:r>
-            <a:endParaRPr lang="en-US" sz="1000" dirty="0"/>
+              <a:t>INTELLIGENCE LAYER · LLM-ASSISTED</a:t>
+            </a:r>
+            <a:endParaRPr lang="en-US" sz="900" dirty="0"/>
           </a:p>
         </p:txBody>
       </p:sp>
@@ -16619,89 +16624,24 @@
         </p:nvSpPr>
         <p:spPr>
           <a:xfrm>
-            <a:off x="941832" y="2697480"/>
-            <a:ext cx="1834835" cy="868680"/>
-          </a:xfrm>
-          <a:prstGeom prst="rect">
-            <a:avLst/>
-          </a:prstGeom>
-          <a:noFill/>
-          <a:ln/>
-        </p:spPr>
-        <p:txBody>
-          <a:bodyPr wrap="square" lIns="0" tIns="0" rIns="0" bIns="0" rtlCol="0" anchor="t"/>
-          <a:lstStyle/>
-          <a:p>
-            <a:pPr indent="0" marL="0">
-              <a:lnSpc>
-                <a:spcPct val="98000"/>
-              </a:lnSpc>
-              <a:buNone/>
-            </a:pPr>
-            <a:r>
-              <a:rPr lang="en-US" sz="1700" dirty="0">
-                <a:solidFill>
-                  <a:srgbClr val="FBF6EC"/>
-                </a:solidFill>
-                <a:latin typeface="Bahnschrift" pitchFamily="34" charset="0"/>
-                <a:ea typeface="Bahnschrift" pitchFamily="34" charset="-122"/>
-                <a:cs typeface="Bahnschrift" pitchFamily="34" charset="-120"/>
-              </a:rPr>
-              <a:t>Compound</a:t>
-            </a:r>
-            <a:endParaRPr lang="en-US" sz="1700" dirty="0"/>
-          </a:p>
-          <a:p>
-            <a:pPr indent="0" marL="0">
-              <a:lnSpc>
-                <a:spcPct val="98000"/>
-              </a:lnSpc>
-              <a:buNone/>
-            </a:pPr>
-            <a:r>
-              <a:rPr lang="en-US" sz="1700" dirty="0">
-                <a:solidFill>
-                  <a:srgbClr val="FBF6EC"/>
-                </a:solidFill>
-                <a:latin typeface="Bahnschrift" pitchFamily="34" charset="0"/>
-                <a:ea typeface="Bahnschrift" pitchFamily="34" charset="-122"/>
-                <a:cs typeface="Bahnschrift" pitchFamily="34" charset="-120"/>
-              </a:rPr>
-              <a:t>Engine</a:t>
-            </a:r>
-            <a:endParaRPr lang="en-US" sz="1700" dirty="0"/>
-          </a:p>
-        </p:txBody>
-      </p:sp>
-      <p:sp>
-        <p:nvSpPr>
-          <p:cNvPr id="12" name="Text 10"/>
-          <p:cNvSpPr/>
-          <p:nvPr/>
-        </p:nvSpPr>
-        <p:spPr>
-          <a:xfrm>
-            <a:off x="941832" y="3657600"/>
-            <a:ext cx="1834835" cy="822960"/>
-          </a:xfrm>
-          <a:prstGeom prst="rect">
-            <a:avLst/>
-          </a:prstGeom>
-          <a:noFill/>
-          <a:ln/>
-        </p:spPr>
-        <p:txBody>
-          <a:bodyPr wrap="square" lIns="0" tIns="0" rIns="0" bIns="0" rtlCol="0" anchor="t"/>
-          <a:lstStyle/>
-          <a:p>
-            <a:pPr indent="0" marL="0">
-              <a:lnSpc>
-                <a:spcPct val="110000"/>
-              </a:lnSpc>
-              <a:buNone/>
-            </a:pPr>
-            <a:r>
-              <a:rPr lang="en-US" sz="1200" dirty="0">
+            <a:off x="1005840" y="2276856"/>
+            <a:ext cx="10180015" cy="274320"/>
+          </a:xfrm>
+          <a:prstGeom prst="rect">
+            <a:avLst/>
+          </a:prstGeom>
+          <a:noFill/>
+          <a:ln/>
+        </p:spPr>
+        <p:txBody>
+          <a:bodyPr wrap="square" lIns="0" tIns="0" rIns="0" bIns="0" rtlCol="0" anchor="t"/>
+          <a:lstStyle/>
+          <a:p>
+            <a:pPr indent="0" marL="0">
+              <a:buNone/>
+            </a:pPr>
+            <a:r>
+              <a:rPr lang="en-US" sz="1100" dirty="0">
                 <a:solidFill>
                   <a:srgbClr val="C6B9A6"/>
                 </a:solidFill>
@@ -16709,732 +16649,28 @@
                 <a:ea typeface="Segoe UI" pitchFamily="34" charset="-122"/>
                 <a:cs typeface="Segoe UI" pitchFamily="34" charset="-120"/>
               </a:rPr>
-              <a:t>fuses gas trend + permits + people</a:t>
-            </a:r>
-            <a:endParaRPr lang="en-US" sz="1200" dirty="0"/>
-          </a:p>
-        </p:txBody>
-      </p:sp>
-      <p:sp>
-        <p:nvSpPr>
-          <p:cNvPr id="13" name="Shape 11"/>
-          <p:cNvSpPr/>
-          <p:nvPr/>
-        </p:nvSpPr>
-        <p:spPr>
-          <a:xfrm>
-            <a:off x="2904683" y="2194560"/>
-            <a:ext cx="0" cy="2286000"/>
-          </a:xfrm>
-          <a:prstGeom prst="line">
-            <a:avLst/>
-          </a:prstGeom>
-          <a:noFill/>
-          <a:ln w="12700">
-            <a:solidFill>
-              <a:srgbClr val="2A2118"/>
-            </a:solidFill>
-            <a:prstDash val="solid"/>
-          </a:ln>
-        </p:spPr>
-      </p:sp>
-      <p:sp>
-        <p:nvSpPr>
-          <p:cNvPr id="14" name="Shape 12"/>
-          <p:cNvSpPr/>
-          <p:nvPr/>
-        </p:nvSpPr>
-        <p:spPr>
-          <a:xfrm>
-            <a:off x="3069275" y="2212848"/>
-            <a:ext cx="365760" cy="45720"/>
+              <a:t>Vision (YOLOv8) · Disaster-Memory RAG (Gemini) · 6-stage reasoning graph · Compliance &amp; permit-gate · Pre-mortem · Knowledge graph</a:t>
+            </a:r>
+            <a:endParaRPr lang="en-US" sz="1100" dirty="0"/>
+          </a:p>
+        </p:txBody>
+      </p:sp>
+      <p:sp>
+        <p:nvSpPr>
+          <p:cNvPr id="12" name="Shape 10"/>
+          <p:cNvSpPr/>
+          <p:nvPr/>
+        </p:nvSpPr>
+        <p:spPr>
+          <a:xfrm>
+            <a:off x="777240" y="3310128"/>
+            <a:ext cx="1847088" cy="1664208"/>
           </a:xfrm>
           <a:prstGeom prst="rect">
             <a:avLst/>
           </a:prstGeom>
           <a:solidFill>
-            <a:srgbClr val="C6B9A6"/>
-          </a:solidFill>
-          <a:ln/>
-        </p:spPr>
-      </p:sp>
-      <p:sp>
-        <p:nvSpPr>
-          <p:cNvPr id="15" name="Text 13"/>
-          <p:cNvSpPr/>
-          <p:nvPr/>
-        </p:nvSpPr>
-        <p:spPr>
-          <a:xfrm>
-            <a:off x="3069275" y="2377440"/>
-            <a:ext cx="1853123" cy="274320"/>
-          </a:xfrm>
-          <a:prstGeom prst="rect">
-            <a:avLst/>
-          </a:prstGeom>
-          <a:noFill/>
-          <a:ln/>
-        </p:spPr>
-        <p:txBody>
-          <a:bodyPr wrap="square" lIns="0" tIns="0" rIns="0" bIns="0" rtlCol="0" anchor="t"/>
-          <a:lstStyle/>
-          <a:p>
-            <a:pPr indent="0" marL="0">
-              <a:buNone/>
-            </a:pPr>
-            <a:r>
-              <a:rPr lang="en-US" sz="1000" dirty="0">
-                <a:solidFill>
-                  <a:srgbClr val="C6B9A6"/>
-                </a:solidFill>
-                <a:latin typeface="Cascadia Mono" pitchFamily="34" charset="0"/>
-                <a:ea typeface="Cascadia Mono" pitchFamily="34" charset="-122"/>
-                <a:cs typeface="Cascadia Mono" pitchFamily="34" charset="-120"/>
-              </a:rPr>
-              <a:t>02</a:t>
-            </a:r>
-            <a:endParaRPr lang="en-US" sz="1000" dirty="0"/>
-          </a:p>
-        </p:txBody>
-      </p:sp>
-      <p:sp>
-        <p:nvSpPr>
-          <p:cNvPr id="16" name="Text 14"/>
-          <p:cNvSpPr/>
-          <p:nvPr/>
-        </p:nvSpPr>
-        <p:spPr>
-          <a:xfrm>
-            <a:off x="3069275" y="2697480"/>
-            <a:ext cx="1834835" cy="868680"/>
-          </a:xfrm>
-          <a:prstGeom prst="rect">
-            <a:avLst/>
-          </a:prstGeom>
-          <a:noFill/>
-          <a:ln/>
-        </p:spPr>
-        <p:txBody>
-          <a:bodyPr wrap="square" lIns="0" tIns="0" rIns="0" bIns="0" rtlCol="0" anchor="t"/>
-          <a:lstStyle/>
-          <a:p>
-            <a:pPr indent="0" marL="0">
-              <a:lnSpc>
-                <a:spcPct val="98000"/>
-              </a:lnSpc>
-              <a:buNone/>
-            </a:pPr>
-            <a:r>
-              <a:rPr lang="en-US" sz="1700" dirty="0">
-                <a:solidFill>
-                  <a:srgbClr val="FBF6EC"/>
-                </a:solidFill>
-                <a:latin typeface="Bahnschrift" pitchFamily="34" charset="0"/>
-                <a:ea typeface="Bahnschrift" pitchFamily="34" charset="-122"/>
-                <a:cs typeface="Bahnschrift" pitchFamily="34" charset="-120"/>
-              </a:rPr>
-              <a:t>Vision</a:t>
-            </a:r>
-            <a:endParaRPr lang="en-US" sz="1700" dirty="0"/>
-          </a:p>
-        </p:txBody>
-      </p:sp>
-      <p:sp>
-        <p:nvSpPr>
-          <p:cNvPr id="17" name="Text 15"/>
-          <p:cNvSpPr/>
-          <p:nvPr/>
-        </p:nvSpPr>
-        <p:spPr>
-          <a:xfrm>
-            <a:off x="3069275" y="3657600"/>
-            <a:ext cx="1834835" cy="822960"/>
-          </a:xfrm>
-          <a:prstGeom prst="rect">
-            <a:avLst/>
-          </a:prstGeom>
-          <a:noFill/>
-          <a:ln/>
-        </p:spPr>
-        <p:txBody>
-          <a:bodyPr wrap="square" lIns="0" tIns="0" rIns="0" bIns="0" rtlCol="0" anchor="t"/>
-          <a:lstStyle/>
-          <a:p>
-            <a:pPr indent="0" marL="0">
-              <a:lnSpc>
-                <a:spcPct val="110000"/>
-              </a:lnSpc>
-              <a:buNone/>
-            </a:pPr>
-            <a:r>
-              <a:rPr lang="en-US" sz="1200" dirty="0">
-                <a:solidFill>
-                  <a:srgbClr val="C6B9A6"/>
-                </a:solidFill>
-                <a:latin typeface="Segoe UI" pitchFamily="34" charset="0"/>
-                <a:ea typeface="Segoe UI" pitchFamily="34" charset="-122"/>
-                <a:cs typeface="Segoe UI" pitchFamily="34" charset="-120"/>
-              </a:rPr>
-              <a:t>person &amp; zone-intrusion (monitoring layer)</a:t>
-            </a:r>
-            <a:endParaRPr lang="en-US" sz="1200" dirty="0"/>
-          </a:p>
-        </p:txBody>
-      </p:sp>
-      <p:sp>
-        <p:nvSpPr>
-          <p:cNvPr id="18" name="Shape 16"/>
-          <p:cNvSpPr/>
-          <p:nvPr/>
-        </p:nvSpPr>
-        <p:spPr>
-          <a:xfrm>
-            <a:off x="5032126" y="2194560"/>
-            <a:ext cx="0" cy="2286000"/>
-          </a:xfrm>
-          <a:prstGeom prst="line">
-            <a:avLst/>
-          </a:prstGeom>
-          <a:noFill/>
-          <a:ln w="12700">
-            <a:solidFill>
-              <a:srgbClr val="2A2118"/>
-            </a:solidFill>
-            <a:prstDash val="solid"/>
-          </a:ln>
-        </p:spPr>
-      </p:sp>
-      <p:sp>
-        <p:nvSpPr>
-          <p:cNvPr id="19" name="Shape 17"/>
-          <p:cNvSpPr/>
-          <p:nvPr/>
-        </p:nvSpPr>
-        <p:spPr>
-          <a:xfrm>
-            <a:off x="5196718" y="2212848"/>
-            <a:ext cx="365760" cy="45720"/>
-          </a:xfrm>
-          <a:prstGeom prst="rect">
-            <a:avLst/>
-          </a:prstGeom>
-          <a:solidFill>
-            <a:srgbClr val="C6B9A6"/>
-          </a:solidFill>
-          <a:ln/>
-        </p:spPr>
-      </p:sp>
-      <p:sp>
-        <p:nvSpPr>
-          <p:cNvPr id="20" name="Text 18"/>
-          <p:cNvSpPr/>
-          <p:nvPr/>
-        </p:nvSpPr>
-        <p:spPr>
-          <a:xfrm>
-            <a:off x="5196718" y="2377440"/>
-            <a:ext cx="1853123" cy="274320"/>
-          </a:xfrm>
-          <a:prstGeom prst="rect">
-            <a:avLst/>
-          </a:prstGeom>
-          <a:noFill/>
-          <a:ln/>
-        </p:spPr>
-        <p:txBody>
-          <a:bodyPr wrap="square" lIns="0" tIns="0" rIns="0" bIns="0" rtlCol="0" anchor="t"/>
-          <a:lstStyle/>
-          <a:p>
-            <a:pPr indent="0" marL="0">
-              <a:buNone/>
-            </a:pPr>
-            <a:r>
-              <a:rPr lang="en-US" sz="1000" dirty="0">
-                <a:solidFill>
-                  <a:srgbClr val="C6B9A6"/>
-                </a:solidFill>
-                <a:latin typeface="Cascadia Mono" pitchFamily="34" charset="0"/>
-                <a:ea typeface="Cascadia Mono" pitchFamily="34" charset="-122"/>
-                <a:cs typeface="Cascadia Mono" pitchFamily="34" charset="-120"/>
-              </a:rPr>
-              <a:t>03</a:t>
-            </a:r>
-            <a:endParaRPr lang="en-US" sz="1000" dirty="0"/>
-          </a:p>
-        </p:txBody>
-      </p:sp>
-      <p:sp>
-        <p:nvSpPr>
-          <p:cNvPr id="21" name="Text 19"/>
-          <p:cNvSpPr/>
-          <p:nvPr/>
-        </p:nvSpPr>
-        <p:spPr>
-          <a:xfrm>
-            <a:off x="5196718" y="2697480"/>
-            <a:ext cx="1834835" cy="868680"/>
-          </a:xfrm>
-          <a:prstGeom prst="rect">
-            <a:avLst/>
-          </a:prstGeom>
-          <a:noFill/>
-          <a:ln/>
-        </p:spPr>
-        <p:txBody>
-          <a:bodyPr wrap="square" lIns="0" tIns="0" rIns="0" bIns="0" rtlCol="0" anchor="t"/>
-          <a:lstStyle/>
-          <a:p>
-            <a:pPr indent="0" marL="0">
-              <a:lnSpc>
-                <a:spcPct val="98000"/>
-              </a:lnSpc>
-              <a:buNone/>
-            </a:pPr>
-            <a:r>
-              <a:rPr lang="en-US" sz="1700" dirty="0">
-                <a:solidFill>
-                  <a:srgbClr val="FBF6EC"/>
-                </a:solidFill>
-                <a:latin typeface="Bahnschrift" pitchFamily="34" charset="0"/>
-                <a:ea typeface="Bahnschrift" pitchFamily="34" charset="-122"/>
-                <a:cs typeface="Bahnschrift" pitchFamily="34" charset="-120"/>
-              </a:rPr>
-              <a:t>Reasoning</a:t>
-            </a:r>
-            <a:endParaRPr lang="en-US" sz="1700" dirty="0"/>
-          </a:p>
-          <a:p>
-            <a:pPr indent="0" marL="0">
-              <a:lnSpc>
-                <a:spcPct val="98000"/>
-              </a:lnSpc>
-              <a:buNone/>
-            </a:pPr>
-            <a:r>
-              <a:rPr lang="en-US" sz="1700" dirty="0">
-                <a:solidFill>
-                  <a:srgbClr val="FBF6EC"/>
-                </a:solidFill>
-                <a:latin typeface="Bahnschrift" pitchFamily="34" charset="0"/>
-                <a:ea typeface="Bahnschrift" pitchFamily="34" charset="-122"/>
-                <a:cs typeface="Bahnschrift" pitchFamily="34" charset="-120"/>
-              </a:rPr>
-              <a:t>Graph</a:t>
-            </a:r>
-            <a:endParaRPr lang="en-US" sz="1700" dirty="0"/>
-          </a:p>
-        </p:txBody>
-      </p:sp>
-      <p:sp>
-        <p:nvSpPr>
-          <p:cNvPr id="22" name="Text 20"/>
-          <p:cNvSpPr/>
-          <p:nvPr/>
-        </p:nvSpPr>
-        <p:spPr>
-          <a:xfrm>
-            <a:off x="5196718" y="3657600"/>
-            <a:ext cx="1834835" cy="822960"/>
-          </a:xfrm>
-          <a:prstGeom prst="rect">
-            <a:avLst/>
-          </a:prstGeom>
-          <a:noFill/>
-          <a:ln/>
-        </p:spPr>
-        <p:txBody>
-          <a:bodyPr wrap="square" lIns="0" tIns="0" rIns="0" bIns="0" rtlCol="0" anchor="t"/>
-          <a:lstStyle/>
-          <a:p>
-            <a:pPr indent="0" marL="0">
-              <a:lnSpc>
-                <a:spcPct val="110000"/>
-              </a:lnSpc>
-              <a:buNone/>
-            </a:pPr>
-            <a:r>
-              <a:rPr lang="en-US" sz="1200" dirty="0">
-                <a:solidFill>
-                  <a:srgbClr val="C6B9A6"/>
-                </a:solidFill>
-                <a:latin typeface="Segoe UI" pitchFamily="34" charset="0"/>
-                <a:ea typeface="Segoe UI" pitchFamily="34" charset="-122"/>
-                <a:cs typeface="Segoe UI" pitchFamily="34" charset="-120"/>
-              </a:rPr>
-              <a:t>6-stage auditable trace</a:t>
-            </a:r>
-            <a:endParaRPr lang="en-US" sz="1200" dirty="0"/>
-          </a:p>
-        </p:txBody>
-      </p:sp>
-      <p:sp>
-        <p:nvSpPr>
-          <p:cNvPr id="23" name="Shape 21"/>
-          <p:cNvSpPr/>
-          <p:nvPr/>
-        </p:nvSpPr>
-        <p:spPr>
-          <a:xfrm>
-            <a:off x="7159569" y="2194560"/>
-            <a:ext cx="0" cy="2286000"/>
-          </a:xfrm>
-          <a:prstGeom prst="line">
-            <a:avLst/>
-          </a:prstGeom>
-          <a:noFill/>
-          <a:ln w="12700">
-            <a:solidFill>
-              <a:srgbClr val="2A2118"/>
-            </a:solidFill>
-            <a:prstDash val="solid"/>
-          </a:ln>
-        </p:spPr>
-      </p:sp>
-      <p:sp>
-        <p:nvSpPr>
-          <p:cNvPr id="24" name="Shape 22"/>
-          <p:cNvSpPr/>
-          <p:nvPr/>
-        </p:nvSpPr>
-        <p:spPr>
-          <a:xfrm>
-            <a:off x="7324161" y="2212848"/>
-            <a:ext cx="365760" cy="45720"/>
-          </a:xfrm>
-          <a:prstGeom prst="rect">
-            <a:avLst/>
-          </a:prstGeom>
-          <a:solidFill>
-            <a:srgbClr val="C6B9A6"/>
-          </a:solidFill>
-          <a:ln/>
-        </p:spPr>
-      </p:sp>
-      <p:sp>
-        <p:nvSpPr>
-          <p:cNvPr id="25" name="Text 23"/>
-          <p:cNvSpPr/>
-          <p:nvPr/>
-        </p:nvSpPr>
-        <p:spPr>
-          <a:xfrm>
-            <a:off x="7324161" y="2377440"/>
-            <a:ext cx="1853123" cy="274320"/>
-          </a:xfrm>
-          <a:prstGeom prst="rect">
-            <a:avLst/>
-          </a:prstGeom>
-          <a:noFill/>
-          <a:ln/>
-        </p:spPr>
-        <p:txBody>
-          <a:bodyPr wrap="square" lIns="0" tIns="0" rIns="0" bIns="0" rtlCol="0" anchor="t"/>
-          <a:lstStyle/>
-          <a:p>
-            <a:pPr indent="0" marL="0">
-              <a:buNone/>
-            </a:pPr>
-            <a:r>
-              <a:rPr lang="en-US" sz="1000" dirty="0">
-                <a:solidFill>
-                  <a:srgbClr val="C6B9A6"/>
-                </a:solidFill>
-                <a:latin typeface="Cascadia Mono" pitchFamily="34" charset="0"/>
-                <a:ea typeface="Cascadia Mono" pitchFamily="34" charset="-122"/>
-                <a:cs typeface="Cascadia Mono" pitchFamily="34" charset="-120"/>
-              </a:rPr>
-              <a:t>04</a:t>
-            </a:r>
-            <a:endParaRPr lang="en-US" sz="1000" dirty="0"/>
-          </a:p>
-        </p:txBody>
-      </p:sp>
-      <p:sp>
-        <p:nvSpPr>
-          <p:cNvPr id="26" name="Text 24"/>
-          <p:cNvSpPr/>
-          <p:nvPr/>
-        </p:nvSpPr>
-        <p:spPr>
-          <a:xfrm>
-            <a:off x="7324161" y="2697480"/>
-            <a:ext cx="1834835" cy="868680"/>
-          </a:xfrm>
-          <a:prstGeom prst="rect">
-            <a:avLst/>
-          </a:prstGeom>
-          <a:noFill/>
-          <a:ln/>
-        </p:spPr>
-        <p:txBody>
-          <a:bodyPr wrap="square" lIns="0" tIns="0" rIns="0" bIns="0" rtlCol="0" anchor="t"/>
-          <a:lstStyle/>
-          <a:p>
-            <a:pPr indent="0" marL="0">
-              <a:lnSpc>
-                <a:spcPct val="98000"/>
-              </a:lnSpc>
-              <a:buNone/>
-            </a:pPr>
-            <a:r>
-              <a:rPr lang="en-US" sz="1700" dirty="0">
-                <a:solidFill>
-                  <a:srgbClr val="FBF6EC"/>
-                </a:solidFill>
-                <a:latin typeface="Bahnschrift" pitchFamily="34" charset="0"/>
-                <a:ea typeface="Bahnschrift" pitchFamily="34" charset="-122"/>
-                <a:cs typeface="Bahnschrift" pitchFamily="34" charset="-120"/>
-              </a:rPr>
-              <a:t>Disaster</a:t>
-            </a:r>
-            <a:endParaRPr lang="en-US" sz="1700" dirty="0"/>
-          </a:p>
-          <a:p>
-            <a:pPr indent="0" marL="0">
-              <a:lnSpc>
-                <a:spcPct val="98000"/>
-              </a:lnSpc>
-              <a:buNone/>
-            </a:pPr>
-            <a:r>
-              <a:rPr lang="en-US" sz="1700" dirty="0">
-                <a:solidFill>
-                  <a:srgbClr val="FBF6EC"/>
-                </a:solidFill>
-                <a:latin typeface="Bahnschrift" pitchFamily="34" charset="0"/>
-                <a:ea typeface="Bahnschrift" pitchFamily="34" charset="-122"/>
-                <a:cs typeface="Bahnschrift" pitchFamily="34" charset="-120"/>
-              </a:rPr>
-              <a:t>RAG</a:t>
-            </a:r>
-            <a:endParaRPr lang="en-US" sz="1700" dirty="0"/>
-          </a:p>
-        </p:txBody>
-      </p:sp>
-      <p:sp>
-        <p:nvSpPr>
-          <p:cNvPr id="27" name="Text 25"/>
-          <p:cNvSpPr/>
-          <p:nvPr/>
-        </p:nvSpPr>
-        <p:spPr>
-          <a:xfrm>
-            <a:off x="7324161" y="3657600"/>
-            <a:ext cx="1834835" cy="822960"/>
-          </a:xfrm>
-          <a:prstGeom prst="rect">
-            <a:avLst/>
-          </a:prstGeom>
-          <a:noFill/>
-          <a:ln/>
-        </p:spPr>
-        <p:txBody>
-          <a:bodyPr wrap="square" lIns="0" tIns="0" rIns="0" bIns="0" rtlCol="0" anchor="t"/>
-          <a:lstStyle/>
-          <a:p>
-            <a:pPr indent="0" marL="0">
-              <a:lnSpc>
-                <a:spcPct val="110000"/>
-              </a:lnSpc>
-              <a:buNone/>
-            </a:pPr>
-            <a:r>
-              <a:rPr lang="en-US" sz="1200" dirty="0">
-                <a:solidFill>
-                  <a:srgbClr val="C6B9A6"/>
-                </a:solidFill>
-                <a:latin typeface="Segoe UI" pitchFamily="34" charset="0"/>
-                <a:ea typeface="Segoe UI" pitchFamily="34" charset="-122"/>
-                <a:cs typeface="Segoe UI" pitchFamily="34" charset="-120"/>
-              </a:rPr>
-              <a:t>Gemini precedent matching</a:t>
-            </a:r>
-            <a:endParaRPr lang="en-US" sz="1200" dirty="0"/>
-          </a:p>
-        </p:txBody>
-      </p:sp>
-      <p:sp>
-        <p:nvSpPr>
-          <p:cNvPr id="28" name="Shape 26"/>
-          <p:cNvSpPr/>
-          <p:nvPr/>
-        </p:nvSpPr>
-        <p:spPr>
-          <a:xfrm>
-            <a:off x="9287012" y="2194560"/>
-            <a:ext cx="0" cy="2286000"/>
-          </a:xfrm>
-          <a:prstGeom prst="line">
-            <a:avLst/>
-          </a:prstGeom>
-          <a:noFill/>
-          <a:ln w="12700">
-            <a:solidFill>
-              <a:srgbClr val="2A2118"/>
-            </a:solidFill>
-            <a:prstDash val="solid"/>
-          </a:ln>
-        </p:spPr>
-      </p:sp>
-      <p:sp>
-        <p:nvSpPr>
-          <p:cNvPr id="29" name="Shape 27"/>
-          <p:cNvSpPr/>
-          <p:nvPr/>
-        </p:nvSpPr>
-        <p:spPr>
-          <a:xfrm>
-            <a:off x="9451604" y="2212848"/>
-            <a:ext cx="365760" cy="45720"/>
-          </a:xfrm>
-          <a:prstGeom prst="rect">
-            <a:avLst/>
-          </a:prstGeom>
-          <a:solidFill>
-            <a:srgbClr val="FF2B4E"/>
-          </a:solidFill>
-          <a:ln/>
-        </p:spPr>
-      </p:sp>
-      <p:sp>
-        <p:nvSpPr>
-          <p:cNvPr id="30" name="Text 28"/>
-          <p:cNvSpPr/>
-          <p:nvPr/>
-        </p:nvSpPr>
-        <p:spPr>
-          <a:xfrm>
-            <a:off x="9451604" y="2377440"/>
-            <a:ext cx="1853123" cy="274320"/>
-          </a:xfrm>
-          <a:prstGeom prst="rect">
-            <a:avLst/>
-          </a:prstGeom>
-          <a:noFill/>
-          <a:ln/>
-        </p:spPr>
-        <p:txBody>
-          <a:bodyPr wrap="square" lIns="0" tIns="0" rIns="0" bIns="0" rtlCol="0" anchor="t"/>
-          <a:lstStyle/>
-          <a:p>
-            <a:pPr indent="0" marL="0">
-              <a:buNone/>
-            </a:pPr>
-            <a:r>
-              <a:rPr lang="en-US" sz="1000" dirty="0">
-                <a:solidFill>
-                  <a:srgbClr val="FF2B4E"/>
-                </a:solidFill>
-                <a:latin typeface="Cascadia Mono" pitchFamily="34" charset="0"/>
-                <a:ea typeface="Cascadia Mono" pitchFamily="34" charset="-122"/>
-                <a:cs typeface="Cascadia Mono" pitchFamily="34" charset="-120"/>
-              </a:rPr>
-              <a:t>05</a:t>
-            </a:r>
-            <a:endParaRPr lang="en-US" sz="1000" dirty="0"/>
-          </a:p>
-        </p:txBody>
-      </p:sp>
-      <p:sp>
-        <p:nvSpPr>
-          <p:cNvPr id="31" name="Text 29"/>
-          <p:cNvSpPr/>
-          <p:nvPr/>
-        </p:nvSpPr>
-        <p:spPr>
-          <a:xfrm>
-            <a:off x="9451604" y="2697480"/>
-            <a:ext cx="1834835" cy="868680"/>
-          </a:xfrm>
-          <a:prstGeom prst="rect">
-            <a:avLst/>
-          </a:prstGeom>
-          <a:noFill/>
-          <a:ln/>
-        </p:spPr>
-        <p:txBody>
-          <a:bodyPr wrap="square" lIns="0" tIns="0" rIns="0" bIns="0" rtlCol="0" anchor="t"/>
-          <a:lstStyle/>
-          <a:p>
-            <a:pPr indent="0" marL="0">
-              <a:lnSpc>
-                <a:spcPct val="98000"/>
-              </a:lnSpc>
-              <a:buNone/>
-            </a:pPr>
-            <a:r>
-              <a:rPr lang="en-US" sz="1700" dirty="0">
-                <a:solidFill>
-                  <a:srgbClr val="FBF6EC"/>
-                </a:solidFill>
-                <a:latin typeface="Bahnschrift" pitchFamily="34" charset="0"/>
-                <a:ea typeface="Bahnschrift" pitchFamily="34" charset="-122"/>
-                <a:cs typeface="Bahnschrift" pitchFamily="34" charset="-120"/>
-              </a:rPr>
-              <a:t>Response</a:t>
-            </a:r>
-            <a:endParaRPr lang="en-US" sz="1700" dirty="0"/>
-          </a:p>
-        </p:txBody>
-      </p:sp>
-      <p:sp>
-        <p:nvSpPr>
-          <p:cNvPr id="32" name="Text 30"/>
-          <p:cNvSpPr/>
-          <p:nvPr/>
-        </p:nvSpPr>
-        <p:spPr>
-          <a:xfrm>
-            <a:off x="9451604" y="3657600"/>
-            <a:ext cx="1834835" cy="822960"/>
-          </a:xfrm>
-          <a:prstGeom prst="rect">
-            <a:avLst/>
-          </a:prstGeom>
-          <a:noFill/>
-          <a:ln/>
-        </p:spPr>
-        <p:txBody>
-          <a:bodyPr wrap="square" lIns="0" tIns="0" rIns="0" bIns="0" rtlCol="0" anchor="t"/>
-          <a:lstStyle/>
-          <a:p>
-            <a:pPr indent="0" marL="0">
-              <a:lnSpc>
-                <a:spcPct val="110000"/>
-              </a:lnSpc>
-              <a:buNone/>
-            </a:pPr>
-            <a:r>
-              <a:rPr lang="en-US" sz="1200" dirty="0">
-                <a:solidFill>
-                  <a:srgbClr val="C6B9A6"/>
-                </a:solidFill>
-                <a:latin typeface="Segoe UI" pitchFamily="34" charset="0"/>
-                <a:ea typeface="Segoe UI" pitchFamily="34" charset="-122"/>
-                <a:cs typeface="Segoe UI" pitchFamily="34" charset="-120"/>
-              </a:rPr>
-              <a:t>report + multilingual alerts</a:t>
-            </a:r>
-            <a:endParaRPr lang="en-US" sz="1200" dirty="0"/>
-          </a:p>
-        </p:txBody>
-      </p:sp>
-      <p:sp>
-        <p:nvSpPr>
-          <p:cNvPr id="33" name="Shape 31"/>
-          <p:cNvSpPr/>
-          <p:nvPr/>
-        </p:nvSpPr>
-        <p:spPr>
-          <a:xfrm>
-            <a:off x="777240" y="4983480"/>
-            <a:ext cx="10637215" cy="914400"/>
-          </a:xfrm>
-          <a:prstGeom prst="rect">
-            <a:avLst/>
-          </a:prstGeom>
-          <a:solidFill>
-            <a:srgbClr val="151009"/>
+            <a:srgbClr val="120D08"/>
           </a:solidFill>
           <a:ln w="12700">
             <a:solidFill>
@@ -17446,14 +16682,424 @@
       </p:sp>
       <p:sp>
         <p:nvSpPr>
-          <p:cNvPr id="34" name="Shape 32"/>
-          <p:cNvSpPr/>
-          <p:nvPr/>
-        </p:nvSpPr>
-        <p:spPr>
-          <a:xfrm>
-            <a:off x="777240" y="4983480"/>
-            <a:ext cx="45720" cy="914400"/>
+          <p:cNvPr id="13" name="Text 11"/>
+          <p:cNvSpPr/>
+          <p:nvPr/>
+        </p:nvSpPr>
+        <p:spPr>
+          <a:xfrm>
+            <a:off x="923544" y="3447288"/>
+            <a:ext cx="1572768" cy="292608"/>
+          </a:xfrm>
+          <a:prstGeom prst="rect">
+            <a:avLst/>
+          </a:prstGeom>
+          <a:noFill/>
+          <a:ln/>
+        </p:spPr>
+        <p:txBody>
+          <a:bodyPr wrap="square" lIns="0" tIns="0" rIns="0" bIns="0" rtlCol="0" anchor="t"/>
+          <a:lstStyle/>
+          <a:p>
+            <a:pPr indent="0" marL="0">
+              <a:buNone/>
+            </a:pPr>
+            <a:r>
+              <a:rPr lang="en-US" sz="1250" dirty="0">
+                <a:solidFill>
+                  <a:srgbClr val="FBF6EC"/>
+                </a:solidFill>
+                <a:latin typeface="Bahnschrift" pitchFamily="34" charset="0"/>
+                <a:ea typeface="Bahnschrift" pitchFamily="34" charset="-122"/>
+                <a:cs typeface="Bahnschrift" pitchFamily="34" charset="-120"/>
+              </a:rPr>
+              <a:t>DATA SOURCES</a:t>
+            </a:r>
+            <a:endParaRPr lang="en-US" sz="1250" dirty="0"/>
+          </a:p>
+        </p:txBody>
+      </p:sp>
+      <p:sp>
+        <p:nvSpPr>
+          <p:cNvPr id="14" name="Text 12"/>
+          <p:cNvSpPr/>
+          <p:nvPr/>
+        </p:nvSpPr>
+        <p:spPr>
+          <a:xfrm>
+            <a:off x="923544" y="3822192"/>
+            <a:ext cx="1572768" cy="1060704"/>
+          </a:xfrm>
+          <a:prstGeom prst="rect">
+            <a:avLst/>
+          </a:prstGeom>
+          <a:noFill/>
+          <a:ln/>
+        </p:spPr>
+        <p:txBody>
+          <a:bodyPr wrap="square" lIns="0" tIns="0" rIns="0" bIns="0" rtlCol="0" anchor="t"/>
+          <a:lstStyle/>
+          <a:p>
+            <a:pPr indent="0" marL="0">
+              <a:lnSpc>
+                <a:spcPct val="122000"/>
+              </a:lnSpc>
+              <a:buNone/>
+            </a:pPr>
+            <a:r>
+              <a:rPr lang="en-US" sz="950" dirty="0">
+                <a:solidFill>
+                  <a:srgbClr val="C6B9A6"/>
+                </a:solidFill>
+                <a:latin typeface="Segoe UI" pitchFamily="34" charset="0"/>
+                <a:ea typeface="Segoe UI" pitchFamily="34" charset="-122"/>
+                <a:cs typeface="Segoe UI" pitchFamily="34" charset="-120"/>
+              </a:rPr>
+              <a:t>Gas sensors</a:t>
+            </a:r>
+            <a:endParaRPr lang="en-US" sz="950" dirty="0"/>
+          </a:p>
+          <a:p>
+            <a:pPr indent="0" marL="0">
+              <a:lnSpc>
+                <a:spcPct val="122000"/>
+              </a:lnSpc>
+              <a:buNone/>
+            </a:pPr>
+            <a:r>
+              <a:rPr lang="en-US" sz="950" dirty="0">
+                <a:solidFill>
+                  <a:srgbClr val="C6B9A6"/>
+                </a:solidFill>
+                <a:latin typeface="Segoe UI" pitchFamily="34" charset="0"/>
+                <a:ea typeface="Segoe UI" pitchFamily="34" charset="-122"/>
+                <a:cs typeface="Segoe UI" pitchFamily="34" charset="-120"/>
+              </a:rPr>
+              <a:t>Permit-to-work</a:t>
+            </a:r>
+            <a:endParaRPr lang="en-US" sz="950" dirty="0"/>
+          </a:p>
+          <a:p>
+            <a:pPr indent="0" marL="0">
+              <a:lnSpc>
+                <a:spcPct val="122000"/>
+              </a:lnSpc>
+              <a:buNone/>
+            </a:pPr>
+            <a:r>
+              <a:rPr lang="en-US" sz="950" dirty="0">
+                <a:solidFill>
+                  <a:srgbClr val="C6B9A6"/>
+                </a:solidFill>
+                <a:latin typeface="Segoe UI" pitchFamily="34" charset="0"/>
+                <a:ea typeface="Segoe UI" pitchFamily="34" charset="-122"/>
+                <a:cs typeface="Segoe UI" pitchFamily="34" charset="-120"/>
+              </a:rPr>
+              <a:t>CCTV · shift logs</a:t>
+            </a:r>
+            <a:endParaRPr lang="en-US" sz="950" dirty="0"/>
+          </a:p>
+          <a:p>
+            <a:pPr indent="0" marL="0">
+              <a:lnSpc>
+                <a:spcPct val="122000"/>
+              </a:lnSpc>
+              <a:buNone/>
+            </a:pPr>
+            <a:r>
+              <a:rPr lang="en-US" sz="950" dirty="0">
+                <a:solidFill>
+                  <a:srgbClr val="C6B9A6"/>
+                </a:solidFill>
+                <a:latin typeface="Segoe UI" pitchFamily="34" charset="0"/>
+                <a:ea typeface="Segoe UI" pitchFamily="34" charset="-122"/>
+                <a:cs typeface="Segoe UI" pitchFamily="34" charset="-120"/>
+              </a:rPr>
+              <a:t>SCADA / historian</a:t>
+            </a:r>
+            <a:endParaRPr lang="en-US" sz="950" dirty="0"/>
+          </a:p>
+        </p:txBody>
+      </p:sp>
+      <p:sp>
+        <p:nvSpPr>
+          <p:cNvPr id="15" name="Text 13"/>
+          <p:cNvSpPr/>
+          <p:nvPr/>
+        </p:nvSpPr>
+        <p:spPr>
+          <a:xfrm>
+            <a:off x="2624328" y="3310128"/>
+            <a:ext cx="274320" cy="1664208"/>
+          </a:xfrm>
+          <a:prstGeom prst="rect">
+            <a:avLst/>
+          </a:prstGeom>
+          <a:noFill/>
+          <a:ln/>
+        </p:spPr>
+        <p:txBody>
+          <a:bodyPr wrap="square" lIns="0" tIns="0" rIns="0" bIns="0" rtlCol="0" anchor="ctr"/>
+          <a:lstStyle/>
+          <a:p>
+            <a:pPr algn="ctr" indent="0" marL="0">
+              <a:buNone/>
+            </a:pPr>
+            <a:r>
+              <a:rPr lang="en-US" sz="1700" dirty="0">
+                <a:solidFill>
+                  <a:srgbClr val="FF6A1A"/>
+                </a:solidFill>
+                <a:latin typeface="Bahnschrift" pitchFamily="34" charset="0"/>
+                <a:ea typeface="Bahnschrift" pitchFamily="34" charset="-122"/>
+                <a:cs typeface="Bahnschrift" pitchFamily="34" charset="-120"/>
+              </a:rPr>
+              <a:t>→</a:t>
+            </a:r>
+            <a:endParaRPr lang="en-US" sz="1700" dirty="0"/>
+          </a:p>
+        </p:txBody>
+      </p:sp>
+      <p:sp>
+        <p:nvSpPr>
+          <p:cNvPr id="16" name="Shape 14"/>
+          <p:cNvSpPr/>
+          <p:nvPr/>
+        </p:nvSpPr>
+        <p:spPr>
+          <a:xfrm>
+            <a:off x="2880360" y="3310128"/>
+            <a:ext cx="1719072" cy="1664208"/>
+          </a:xfrm>
+          <a:prstGeom prst="rect">
+            <a:avLst/>
+          </a:prstGeom>
+          <a:solidFill>
+            <a:srgbClr val="120D08"/>
+          </a:solidFill>
+          <a:ln w="12700">
+            <a:solidFill>
+              <a:srgbClr val="2A2118"/>
+            </a:solidFill>
+            <a:prstDash val="solid"/>
+          </a:ln>
+        </p:spPr>
+      </p:sp>
+      <p:sp>
+        <p:nvSpPr>
+          <p:cNvPr id="17" name="Text 15"/>
+          <p:cNvSpPr/>
+          <p:nvPr/>
+        </p:nvSpPr>
+        <p:spPr>
+          <a:xfrm>
+            <a:off x="3026664" y="3447288"/>
+            <a:ext cx="1444752" cy="292608"/>
+          </a:xfrm>
+          <a:prstGeom prst="rect">
+            <a:avLst/>
+          </a:prstGeom>
+          <a:noFill/>
+          <a:ln/>
+        </p:spPr>
+        <p:txBody>
+          <a:bodyPr wrap="square" lIns="0" tIns="0" rIns="0" bIns="0" rtlCol="0" anchor="t"/>
+          <a:lstStyle/>
+          <a:p>
+            <a:pPr indent="0" marL="0">
+              <a:buNone/>
+            </a:pPr>
+            <a:r>
+              <a:rPr lang="en-US" sz="1250" dirty="0">
+                <a:solidFill>
+                  <a:srgbClr val="FBF6EC"/>
+                </a:solidFill>
+                <a:latin typeface="Bahnschrift" pitchFamily="34" charset="0"/>
+                <a:ea typeface="Bahnschrift" pitchFamily="34" charset="-122"/>
+                <a:cs typeface="Bahnschrift" pitchFamily="34" charset="-120"/>
+              </a:rPr>
+              <a:t>INGEST</a:t>
+            </a:r>
+            <a:endParaRPr lang="en-US" sz="1250" dirty="0"/>
+          </a:p>
+        </p:txBody>
+      </p:sp>
+      <p:sp>
+        <p:nvSpPr>
+          <p:cNvPr id="18" name="Text 16"/>
+          <p:cNvSpPr/>
+          <p:nvPr/>
+        </p:nvSpPr>
+        <p:spPr>
+          <a:xfrm>
+            <a:off x="3026664" y="3822192"/>
+            <a:ext cx="1444752" cy="1060704"/>
+          </a:xfrm>
+          <a:prstGeom prst="rect">
+            <a:avLst/>
+          </a:prstGeom>
+          <a:noFill/>
+          <a:ln/>
+        </p:spPr>
+        <p:txBody>
+          <a:bodyPr wrap="square" lIns="0" tIns="0" rIns="0" bIns="0" rtlCol="0" anchor="t"/>
+          <a:lstStyle/>
+          <a:p>
+            <a:pPr indent="0" marL="0">
+              <a:lnSpc>
+                <a:spcPct val="122000"/>
+              </a:lnSpc>
+              <a:buNone/>
+            </a:pPr>
+            <a:r>
+              <a:rPr lang="en-US" sz="950" dirty="0">
+                <a:solidFill>
+                  <a:srgbClr val="C6B9A6"/>
+                </a:solidFill>
+                <a:latin typeface="Segoe UI" pitchFamily="34" charset="0"/>
+                <a:ea typeface="Segoe UI" pitchFamily="34" charset="-122"/>
+                <a:cs typeface="Segoe UI" pitchFamily="34" charset="-120"/>
+              </a:rPr>
+              <a:t>OPC-UA · MQTT</a:t>
+            </a:r>
+            <a:endParaRPr lang="en-US" sz="950" dirty="0"/>
+          </a:p>
+          <a:p>
+            <a:pPr indent="0" marL="0">
+              <a:lnSpc>
+                <a:spcPct val="122000"/>
+              </a:lnSpc>
+              <a:buNone/>
+            </a:pPr>
+            <a:r>
+              <a:rPr lang="en-US" sz="950" dirty="0">
+                <a:solidFill>
+                  <a:srgbClr val="C6B9A6"/>
+                </a:solidFill>
+                <a:latin typeface="Segoe UI" pitchFamily="34" charset="0"/>
+                <a:ea typeface="Segoe UI" pitchFamily="34" charset="-122"/>
+                <a:cs typeface="Segoe UI" pitchFamily="34" charset="-120"/>
+              </a:rPr>
+              <a:t>CSV connector</a:t>
+            </a:r>
+            <a:endParaRPr lang="en-US" sz="950" dirty="0"/>
+          </a:p>
+          <a:p>
+            <a:pPr indent="0" marL="0">
+              <a:lnSpc>
+                <a:spcPct val="122000"/>
+              </a:lnSpc>
+              <a:buNone/>
+            </a:pPr>
+            <a:r>
+              <a:rPr lang="en-US" sz="950" dirty="0">
+                <a:solidFill>
+                  <a:srgbClr val="C6B9A6"/>
+                </a:solidFill>
+                <a:latin typeface="Segoe UI" pitchFamily="34" charset="0"/>
+                <a:ea typeface="Segoe UI" pitchFamily="34" charset="-122"/>
+                <a:cs typeface="Segoe UI" pitchFamily="34" charset="-120"/>
+              </a:rPr>
+              <a:t>Edge pre-filter</a:t>
+            </a:r>
+            <a:endParaRPr lang="en-US" sz="950" dirty="0"/>
+          </a:p>
+          <a:p>
+            <a:pPr indent="0" marL="0">
+              <a:lnSpc>
+                <a:spcPct val="122000"/>
+              </a:lnSpc>
+              <a:buNone/>
+            </a:pPr>
+            <a:r>
+              <a:rPr lang="en-US" sz="950" dirty="0">
+                <a:solidFill>
+                  <a:srgbClr val="C6B9A6"/>
+                </a:solidFill>
+                <a:latin typeface="Segoe UI" pitchFamily="34" charset="0"/>
+                <a:ea typeface="Segoe UI" pitchFamily="34" charset="-122"/>
+                <a:cs typeface="Segoe UI" pitchFamily="34" charset="-120"/>
+              </a:rPr>
+              <a:t>→ digital twin</a:t>
+            </a:r>
+            <a:endParaRPr lang="en-US" sz="950" dirty="0"/>
+          </a:p>
+        </p:txBody>
+      </p:sp>
+      <p:sp>
+        <p:nvSpPr>
+          <p:cNvPr id="19" name="Text 17"/>
+          <p:cNvSpPr/>
+          <p:nvPr/>
+        </p:nvSpPr>
+        <p:spPr>
+          <a:xfrm>
+            <a:off x="4599432" y="3310128"/>
+            <a:ext cx="274320" cy="1664208"/>
+          </a:xfrm>
+          <a:prstGeom prst="rect">
+            <a:avLst/>
+          </a:prstGeom>
+          <a:noFill/>
+          <a:ln/>
+        </p:spPr>
+        <p:txBody>
+          <a:bodyPr wrap="square" lIns="0" tIns="0" rIns="0" bIns="0" rtlCol="0" anchor="ctr"/>
+          <a:lstStyle/>
+          <a:p>
+            <a:pPr algn="ctr" indent="0" marL="0">
+              <a:buNone/>
+            </a:pPr>
+            <a:r>
+              <a:rPr lang="en-US" sz="1700" dirty="0">
+                <a:solidFill>
+                  <a:srgbClr val="FF6A1A"/>
+                </a:solidFill>
+                <a:latin typeface="Bahnschrift" pitchFamily="34" charset="0"/>
+                <a:ea typeface="Bahnschrift" pitchFamily="34" charset="-122"/>
+                <a:cs typeface="Bahnschrift" pitchFamily="34" charset="-120"/>
+              </a:rPr>
+              <a:t>→</a:t>
+            </a:r>
+            <a:endParaRPr lang="en-US" sz="1700" dirty="0"/>
+          </a:p>
+        </p:txBody>
+      </p:sp>
+      <p:sp>
+        <p:nvSpPr>
+          <p:cNvPr id="20" name="Shape 18"/>
+          <p:cNvSpPr/>
+          <p:nvPr/>
+        </p:nvSpPr>
+        <p:spPr>
+          <a:xfrm>
+            <a:off x="4855464" y="3310128"/>
+            <a:ext cx="2487168" cy="1664208"/>
+          </a:xfrm>
+          <a:prstGeom prst="rect">
+            <a:avLst/>
+          </a:prstGeom>
+          <a:solidFill>
+            <a:srgbClr val="1C140C"/>
+          </a:solidFill>
+          <a:ln w="25400">
+            <a:solidFill>
+              <a:srgbClr val="FF6A1A"/>
+            </a:solidFill>
+            <a:prstDash val="solid"/>
+          </a:ln>
+        </p:spPr>
+      </p:sp>
+      <p:sp>
+        <p:nvSpPr>
+          <p:cNvPr id="21" name="Shape 19"/>
+          <p:cNvSpPr/>
+          <p:nvPr/>
+        </p:nvSpPr>
+        <p:spPr>
+          <a:xfrm>
+            <a:off x="4855464" y="3310128"/>
+            <a:ext cx="2487168" cy="45720"/>
           </a:xfrm>
           <a:prstGeom prst="rect">
             <a:avLst/>
@@ -17466,33 +17112,30 @@
       </p:sp>
       <p:sp>
         <p:nvSpPr>
-          <p:cNvPr id="35" name="Text 33"/>
-          <p:cNvSpPr/>
-          <p:nvPr/>
-        </p:nvSpPr>
-        <p:spPr>
-          <a:xfrm>
-            <a:off x="1097280" y="4983480"/>
-            <a:ext cx="9997135" cy="914400"/>
-          </a:xfrm>
-          <a:prstGeom prst="rect">
-            <a:avLst/>
-          </a:prstGeom>
-          <a:noFill/>
-          <a:ln/>
-        </p:spPr>
-        <p:txBody>
-          <a:bodyPr wrap="square" lIns="0" tIns="0" rIns="0" bIns="0" rtlCol="0" anchor="ctr"/>
-          <a:lstStyle/>
-          <a:p>
-            <a:pPr indent="0" marL="0">
-              <a:lnSpc>
-                <a:spcPct val="115000"/>
-              </a:lnSpc>
-              <a:buNone/>
-            </a:pPr>
-            <a:r>
-              <a:rPr lang="en-US" sz="1450" b="1" dirty="0">
+          <p:cNvPr id="22" name="Text 20"/>
+          <p:cNvSpPr/>
+          <p:nvPr/>
+        </p:nvSpPr>
+        <p:spPr>
+          <a:xfrm>
+            <a:off x="5001768" y="3447288"/>
+            <a:ext cx="2212848" cy="292608"/>
+          </a:xfrm>
+          <a:prstGeom prst="rect">
+            <a:avLst/>
+          </a:prstGeom>
+          <a:noFill/>
+          <a:ln/>
+        </p:spPr>
+        <p:txBody>
+          <a:bodyPr wrap="square" lIns="0" tIns="0" rIns="0" bIns="0" rtlCol="0" anchor="t"/>
+          <a:lstStyle/>
+          <a:p>
+            <a:pPr indent="0" marL="0">
+              <a:buNone/>
+            </a:pPr>
+            <a:r>
+              <a:rPr lang="en-US" sz="1350" dirty="0">
                 <a:solidFill>
                   <a:srgbClr val="FF6A1A"/>
                 </a:solidFill>
@@ -17500,16 +17143,41 @@
                 <a:ea typeface="Bahnschrift" pitchFamily="34" charset="-122"/>
                 <a:cs typeface="Bahnschrift" pitchFamily="34" charset="-120"/>
               </a:rPr>
-              <a:t>Hybrid by design.  </a:t>
-            </a:r>
+              <a:t>COMPOUND ENGINE</a:t>
+            </a:r>
+            <a:endParaRPr lang="en-US" sz="1350" dirty="0"/>
+          </a:p>
+        </p:txBody>
+      </p:sp>
+      <p:sp>
+        <p:nvSpPr>
+          <p:cNvPr id="23" name="Text 21"/>
+          <p:cNvSpPr/>
+          <p:nvPr/>
+        </p:nvSpPr>
+        <p:spPr>
+          <a:xfrm>
+            <a:off x="5001768" y="3822192"/>
+            <a:ext cx="2212848" cy="1060704"/>
+          </a:xfrm>
+          <a:prstGeom prst="rect">
+            <a:avLst/>
+          </a:prstGeom>
+          <a:noFill/>
+          <a:ln/>
+        </p:spPr>
+        <p:txBody>
+          <a:bodyPr wrap="square" lIns="0" tIns="0" rIns="0" bIns="0" rtlCol="0" anchor="t"/>
+          <a:lstStyle/>
+          <a:p>
             <a:pPr indent="0" marL="0">
               <a:lnSpc>
-                <a:spcPct val="115000"/>
+                <a:spcPct val="122000"/>
               </a:lnSpc>
               <a:buNone/>
             </a:pPr>
             <a:r>
-              <a:rPr lang="en-US" sz="1450" dirty="0">
+              <a:rPr lang="en-US" sz="950" dirty="0">
                 <a:solidFill>
                   <a:srgbClr val="C6B9A6"/>
                 </a:solidFill>
@@ -17517,9 +17185,563 @@
                 <a:ea typeface="Segoe UI" pitchFamily="34" charset="-122"/>
                 <a:cs typeface="Segoe UI" pitchFamily="34" charset="-120"/>
               </a:rPr>
-              <a:t>A transparent, deterministic backbone makes the life-safety decision — the LLM only explains, retrieves precedent, and drafts reports. No black box in the loop.</a:t>
-            </a:r>
-            <a:endParaRPr lang="en-US" sz="1450" dirty="0"/>
+              <a:t>gas level + trend</a:t>
+            </a:r>
+            <a:endParaRPr lang="en-US" sz="950" dirty="0"/>
+          </a:p>
+          <a:p>
+            <a:pPr indent="0" marL="0">
+              <a:lnSpc>
+                <a:spcPct val="122000"/>
+              </a:lnSpc>
+              <a:buNone/>
+            </a:pPr>
+            <a:r>
+              <a:rPr lang="en-US" sz="950" dirty="0">
+                <a:solidFill>
+                  <a:srgbClr val="C6B9A6"/>
+                </a:solidFill>
+                <a:latin typeface="Segoe UI" pitchFamily="34" charset="0"/>
+                <a:ea typeface="Segoe UI" pitchFamily="34" charset="-122"/>
+                <a:cs typeface="Segoe UI" pitchFamily="34" charset="-120"/>
+              </a:rPr>
+              <a:t>+ ignition + personnel</a:t>
+            </a:r>
+            <a:endParaRPr lang="en-US" sz="950" dirty="0"/>
+          </a:p>
+          <a:p>
+            <a:pPr indent="0" marL="0">
+              <a:lnSpc>
+                <a:spcPct val="122000"/>
+              </a:lnSpc>
+              <a:buNone/>
+            </a:pPr>
+            <a:r>
+              <a:rPr lang="en-US" sz="950" dirty="0">
+                <a:solidFill>
+                  <a:srgbClr val="C6B9A6"/>
+                </a:solidFill>
+                <a:latin typeface="Segoe UI" pitchFamily="34" charset="0"/>
+                <a:ea typeface="Segoe UI" pitchFamily="34" charset="-122"/>
+                <a:cs typeface="Segoe UI" pitchFamily="34" charset="-120"/>
+              </a:rPr>
+              <a:t>+ blast-radius · O2 gate</a:t>
+            </a:r>
+            <a:endParaRPr lang="en-US" sz="950" dirty="0"/>
+          </a:p>
+          <a:p>
+            <a:pPr indent="0" marL="0">
+              <a:lnSpc>
+                <a:spcPct val="122000"/>
+              </a:lnSpc>
+              <a:buNone/>
+            </a:pPr>
+            <a:r>
+              <a:rPr lang="en-US" sz="950" dirty="0">
+                <a:solidFill>
+                  <a:srgbClr val="C6B9A6"/>
+                </a:solidFill>
+                <a:latin typeface="Segoe UI" pitchFamily="34" charset="0"/>
+                <a:ea typeface="Segoe UI" pitchFamily="34" charset="-122"/>
+                <a:cs typeface="Segoe UI" pitchFamily="34" charset="-120"/>
+              </a:rPr>
+              <a:t>→ verdict · lead · actions</a:t>
+            </a:r>
+            <a:endParaRPr lang="en-US" sz="950" dirty="0"/>
+          </a:p>
+        </p:txBody>
+      </p:sp>
+      <p:sp>
+        <p:nvSpPr>
+          <p:cNvPr id="24" name="Text 22"/>
+          <p:cNvSpPr/>
+          <p:nvPr/>
+        </p:nvSpPr>
+        <p:spPr>
+          <a:xfrm>
+            <a:off x="7342632" y="3310128"/>
+            <a:ext cx="274320" cy="1664208"/>
+          </a:xfrm>
+          <a:prstGeom prst="rect">
+            <a:avLst/>
+          </a:prstGeom>
+          <a:noFill/>
+          <a:ln/>
+        </p:spPr>
+        <p:txBody>
+          <a:bodyPr wrap="square" lIns="0" tIns="0" rIns="0" bIns="0" rtlCol="0" anchor="ctr"/>
+          <a:lstStyle/>
+          <a:p>
+            <a:pPr algn="ctr" indent="0" marL="0">
+              <a:buNone/>
+            </a:pPr>
+            <a:r>
+              <a:rPr lang="en-US" sz="1700" dirty="0">
+                <a:solidFill>
+                  <a:srgbClr val="FF6A1A"/>
+                </a:solidFill>
+                <a:latin typeface="Bahnschrift" pitchFamily="34" charset="0"/>
+                <a:ea typeface="Bahnschrift" pitchFamily="34" charset="-122"/>
+                <a:cs typeface="Bahnschrift" pitchFamily="34" charset="-120"/>
+              </a:rPr>
+              <a:t>→</a:t>
+            </a:r>
+            <a:endParaRPr lang="en-US" sz="1700" dirty="0"/>
+          </a:p>
+        </p:txBody>
+      </p:sp>
+      <p:sp>
+        <p:nvSpPr>
+          <p:cNvPr id="25" name="Shape 23"/>
+          <p:cNvSpPr/>
+          <p:nvPr/>
+        </p:nvSpPr>
+        <p:spPr>
+          <a:xfrm>
+            <a:off x="7598664" y="3310128"/>
+            <a:ext cx="1792224" cy="1664208"/>
+          </a:xfrm>
+          <a:prstGeom prst="rect">
+            <a:avLst/>
+          </a:prstGeom>
+          <a:solidFill>
+            <a:srgbClr val="120D08"/>
+          </a:solidFill>
+          <a:ln w="12700">
+            <a:solidFill>
+              <a:srgbClr val="2A2118"/>
+            </a:solidFill>
+            <a:prstDash val="solid"/>
+          </a:ln>
+        </p:spPr>
+      </p:sp>
+      <p:sp>
+        <p:nvSpPr>
+          <p:cNvPr id="26" name="Text 24"/>
+          <p:cNvSpPr/>
+          <p:nvPr/>
+        </p:nvSpPr>
+        <p:spPr>
+          <a:xfrm>
+            <a:off x="7744968" y="3447288"/>
+            <a:ext cx="1517904" cy="292608"/>
+          </a:xfrm>
+          <a:prstGeom prst="rect">
+            <a:avLst/>
+          </a:prstGeom>
+          <a:noFill/>
+          <a:ln/>
+        </p:spPr>
+        <p:txBody>
+          <a:bodyPr wrap="square" lIns="0" tIns="0" rIns="0" bIns="0" rtlCol="0" anchor="t"/>
+          <a:lstStyle/>
+          <a:p>
+            <a:pPr indent="0" marL="0">
+              <a:buNone/>
+            </a:pPr>
+            <a:r>
+              <a:rPr lang="en-US" sz="1250" dirty="0">
+                <a:solidFill>
+                  <a:srgbClr val="FBF6EC"/>
+                </a:solidFill>
+                <a:latin typeface="Bahnschrift" pitchFamily="34" charset="0"/>
+                <a:ea typeface="Bahnschrift" pitchFamily="34" charset="-122"/>
+                <a:cs typeface="Bahnschrift" pitchFamily="34" charset="-120"/>
+              </a:rPr>
+              <a:t>RESPONSE</a:t>
+            </a:r>
+            <a:endParaRPr lang="en-US" sz="1250" dirty="0"/>
+          </a:p>
+        </p:txBody>
+      </p:sp>
+      <p:sp>
+        <p:nvSpPr>
+          <p:cNvPr id="27" name="Text 25"/>
+          <p:cNvSpPr/>
+          <p:nvPr/>
+        </p:nvSpPr>
+        <p:spPr>
+          <a:xfrm>
+            <a:off x="7744968" y="3822192"/>
+            <a:ext cx="1517904" cy="1060704"/>
+          </a:xfrm>
+          <a:prstGeom prst="rect">
+            <a:avLst/>
+          </a:prstGeom>
+          <a:noFill/>
+          <a:ln/>
+        </p:spPr>
+        <p:txBody>
+          <a:bodyPr wrap="square" lIns="0" tIns="0" rIns="0" bIns="0" rtlCol="0" anchor="t"/>
+          <a:lstStyle/>
+          <a:p>
+            <a:pPr indent="0" marL="0">
+              <a:lnSpc>
+                <a:spcPct val="122000"/>
+              </a:lnSpc>
+              <a:buNone/>
+            </a:pPr>
+            <a:r>
+              <a:rPr lang="en-US" sz="950" dirty="0">
+                <a:solidFill>
+                  <a:srgbClr val="C6B9A6"/>
+                </a:solidFill>
+                <a:latin typeface="Segoe UI" pitchFamily="34" charset="0"/>
+                <a:ea typeface="Segoe UI" pitchFamily="34" charset="-122"/>
+                <a:cs typeface="Segoe UI" pitchFamily="34" charset="-120"/>
+              </a:rPr>
+              <a:t>Incident report</a:t>
+            </a:r>
+            <a:endParaRPr lang="en-US" sz="950" dirty="0"/>
+          </a:p>
+          <a:p>
+            <a:pPr indent="0" marL="0">
+              <a:lnSpc>
+                <a:spcPct val="122000"/>
+              </a:lnSpc>
+              <a:buNone/>
+            </a:pPr>
+            <a:r>
+              <a:rPr lang="en-US" sz="950" dirty="0">
+                <a:solidFill>
+                  <a:srgbClr val="C6B9A6"/>
+                </a:solidFill>
+                <a:latin typeface="Segoe UI" pitchFamily="34" charset="0"/>
+                <a:ea typeface="Segoe UI" pitchFamily="34" charset="-122"/>
+                <a:cs typeface="Segoe UI" pitchFamily="34" charset="-120"/>
+              </a:rPr>
+              <a:t>Multilingual alert</a:t>
+            </a:r>
+            <a:endParaRPr lang="en-US" sz="950" dirty="0"/>
+          </a:p>
+          <a:p>
+            <a:pPr indent="0" marL="0">
+              <a:lnSpc>
+                <a:spcPct val="122000"/>
+              </a:lnSpc>
+              <a:buNone/>
+            </a:pPr>
+            <a:r>
+              <a:rPr lang="en-US" sz="950" dirty="0">
+                <a:solidFill>
+                  <a:srgbClr val="C6B9A6"/>
+                </a:solidFill>
+                <a:latin typeface="Segoe UI" pitchFamily="34" charset="0"/>
+                <a:ea typeface="Segoe UI" pitchFamily="34" charset="-122"/>
+                <a:cs typeface="Segoe UI" pitchFamily="34" charset="-120"/>
+              </a:rPr>
+              <a:t>Multi-channel dispatch</a:t>
+            </a:r>
+            <a:endParaRPr lang="en-US" sz="950" dirty="0"/>
+          </a:p>
+          <a:p>
+            <a:pPr indent="0" marL="0">
+              <a:lnSpc>
+                <a:spcPct val="122000"/>
+              </a:lnSpc>
+              <a:buNone/>
+            </a:pPr>
+            <a:r>
+              <a:rPr lang="en-US" sz="950" dirty="0">
+                <a:solidFill>
+                  <a:srgbClr val="C6B9A6"/>
+                </a:solidFill>
+                <a:latin typeface="Segoe UI" pitchFamily="34" charset="0"/>
+                <a:ea typeface="Segoe UI" pitchFamily="34" charset="-122"/>
+                <a:cs typeface="Segoe UI" pitchFamily="34" charset="-120"/>
+              </a:rPr>
+              <a:t>Evidence freeze</a:t>
+            </a:r>
+            <a:endParaRPr lang="en-US" sz="950" dirty="0"/>
+          </a:p>
+        </p:txBody>
+      </p:sp>
+      <p:sp>
+        <p:nvSpPr>
+          <p:cNvPr id="28" name="Text 26"/>
+          <p:cNvSpPr/>
+          <p:nvPr/>
+        </p:nvSpPr>
+        <p:spPr>
+          <a:xfrm>
+            <a:off x="9390888" y="3310128"/>
+            <a:ext cx="274320" cy="1664208"/>
+          </a:xfrm>
+          <a:prstGeom prst="rect">
+            <a:avLst/>
+          </a:prstGeom>
+          <a:noFill/>
+          <a:ln/>
+        </p:spPr>
+        <p:txBody>
+          <a:bodyPr wrap="square" lIns="0" tIns="0" rIns="0" bIns="0" rtlCol="0" anchor="ctr"/>
+          <a:lstStyle/>
+          <a:p>
+            <a:pPr algn="ctr" indent="0" marL="0">
+              <a:buNone/>
+            </a:pPr>
+            <a:r>
+              <a:rPr lang="en-US" sz="1700" dirty="0">
+                <a:solidFill>
+                  <a:srgbClr val="FF6A1A"/>
+                </a:solidFill>
+                <a:latin typeface="Bahnschrift" pitchFamily="34" charset="0"/>
+                <a:ea typeface="Bahnschrift" pitchFamily="34" charset="-122"/>
+                <a:cs typeface="Bahnschrift" pitchFamily="34" charset="-120"/>
+              </a:rPr>
+              <a:t>→</a:t>
+            </a:r>
+            <a:endParaRPr lang="en-US" sz="1700" dirty="0"/>
+          </a:p>
+        </p:txBody>
+      </p:sp>
+      <p:sp>
+        <p:nvSpPr>
+          <p:cNvPr id="29" name="Shape 27"/>
+          <p:cNvSpPr/>
+          <p:nvPr/>
+        </p:nvSpPr>
+        <p:spPr>
+          <a:xfrm>
+            <a:off x="9637776" y="3310128"/>
+            <a:ext cx="1773936" cy="1664208"/>
+          </a:xfrm>
+          <a:prstGeom prst="rect">
+            <a:avLst/>
+          </a:prstGeom>
+          <a:solidFill>
+            <a:srgbClr val="120D08"/>
+          </a:solidFill>
+          <a:ln w="12700">
+            <a:solidFill>
+              <a:srgbClr val="2A2118"/>
+            </a:solidFill>
+            <a:prstDash val="solid"/>
+          </a:ln>
+        </p:spPr>
+      </p:sp>
+      <p:sp>
+        <p:nvSpPr>
+          <p:cNvPr id="30" name="Text 28"/>
+          <p:cNvSpPr/>
+          <p:nvPr/>
+        </p:nvSpPr>
+        <p:spPr>
+          <a:xfrm>
+            <a:off x="9784080" y="3447288"/>
+            <a:ext cx="1499616" cy="292608"/>
+          </a:xfrm>
+          <a:prstGeom prst="rect">
+            <a:avLst/>
+          </a:prstGeom>
+          <a:noFill/>
+          <a:ln/>
+        </p:spPr>
+        <p:txBody>
+          <a:bodyPr wrap="square" lIns="0" tIns="0" rIns="0" bIns="0" rtlCol="0" anchor="t"/>
+          <a:lstStyle/>
+          <a:p>
+            <a:pPr indent="0" marL="0">
+              <a:buNone/>
+            </a:pPr>
+            <a:r>
+              <a:rPr lang="en-US" sz="1250" dirty="0">
+                <a:solidFill>
+                  <a:srgbClr val="FBF6EC"/>
+                </a:solidFill>
+                <a:latin typeface="Bahnschrift" pitchFamily="34" charset="0"/>
+                <a:ea typeface="Bahnschrift" pitchFamily="34" charset="-122"/>
+                <a:cs typeface="Bahnschrift" pitchFamily="34" charset="-120"/>
+              </a:rPr>
+              <a:t>CONTROL ROOM</a:t>
+            </a:r>
+            <a:endParaRPr lang="en-US" sz="1250" dirty="0"/>
+          </a:p>
+        </p:txBody>
+      </p:sp>
+      <p:sp>
+        <p:nvSpPr>
+          <p:cNvPr id="31" name="Text 29"/>
+          <p:cNvSpPr/>
+          <p:nvPr/>
+        </p:nvSpPr>
+        <p:spPr>
+          <a:xfrm>
+            <a:off x="9784080" y="3822192"/>
+            <a:ext cx="1499616" cy="1060704"/>
+          </a:xfrm>
+          <a:prstGeom prst="rect">
+            <a:avLst/>
+          </a:prstGeom>
+          <a:noFill/>
+          <a:ln/>
+        </p:spPr>
+        <p:txBody>
+          <a:bodyPr wrap="square" lIns="0" tIns="0" rIns="0" bIns="0" rtlCol="0" anchor="t"/>
+          <a:lstStyle/>
+          <a:p>
+            <a:pPr indent="0" marL="0">
+              <a:lnSpc>
+                <a:spcPct val="122000"/>
+              </a:lnSpc>
+              <a:buNone/>
+            </a:pPr>
+            <a:r>
+              <a:rPr lang="en-US" sz="950" dirty="0">
+                <a:solidFill>
+                  <a:srgbClr val="C6B9A6"/>
+                </a:solidFill>
+                <a:latin typeface="Segoe UI" pitchFamily="34" charset="0"/>
+                <a:ea typeface="Segoe UI" pitchFamily="34" charset="-122"/>
+                <a:cs typeface="Segoe UI" pitchFamily="34" charset="-120"/>
+              </a:rPr>
+              <a:t>Next.js split-reality</a:t>
+            </a:r>
+            <a:endParaRPr lang="en-US" sz="950" dirty="0"/>
+          </a:p>
+          <a:p>
+            <a:pPr indent="0" marL="0">
+              <a:lnSpc>
+                <a:spcPct val="122000"/>
+              </a:lnSpc>
+              <a:buNone/>
+            </a:pPr>
+            <a:r>
+              <a:rPr lang="en-US" sz="950" dirty="0">
+                <a:solidFill>
+                  <a:srgbClr val="C6B9A6"/>
+                </a:solidFill>
+                <a:latin typeface="Segoe UI" pitchFamily="34" charset="0"/>
+                <a:ea typeface="Segoe UI" pitchFamily="34" charset="-122"/>
+                <a:cs typeface="Segoe UI" pitchFamily="34" charset="-120"/>
+              </a:rPr>
+              <a:t>HMI · plant · fleet</a:t>
+            </a:r>
+            <a:endParaRPr lang="en-US" sz="950" dirty="0"/>
+          </a:p>
+          <a:p>
+            <a:pPr indent="0" marL="0">
+              <a:lnSpc>
+                <a:spcPct val="122000"/>
+              </a:lnSpc>
+              <a:buNone/>
+            </a:pPr>
+            <a:r>
+              <a:rPr lang="en-US" sz="950" dirty="0">
+                <a:solidFill>
+                  <a:srgbClr val="C6B9A6"/>
+                </a:solidFill>
+                <a:latin typeface="Segoe UI" pitchFamily="34" charset="0"/>
+                <a:ea typeface="Segoe UI" pitchFamily="34" charset="-122"/>
+                <a:cs typeface="Segoe UI" pitchFamily="34" charset="-120"/>
+              </a:rPr>
+              <a:t>FastAPI REST + WS</a:t>
+            </a:r>
+            <a:endParaRPr lang="en-US" sz="950" dirty="0"/>
+          </a:p>
+        </p:txBody>
+      </p:sp>
+      <p:sp>
+        <p:nvSpPr>
+          <p:cNvPr id="32" name="Shape 30"/>
+          <p:cNvSpPr/>
+          <p:nvPr/>
+        </p:nvSpPr>
+        <p:spPr>
+          <a:xfrm>
+            <a:off x="6099048" y="2615184"/>
+            <a:ext cx="0" cy="694944"/>
+          </a:xfrm>
+          <a:prstGeom prst="line">
+            <a:avLst/>
+          </a:prstGeom>
+          <a:noFill/>
+          <a:ln w="12700">
+            <a:solidFill>
+              <a:srgbClr val="473726"/>
+            </a:solidFill>
+            <a:prstDash val="dash"/>
+          </a:ln>
+        </p:spPr>
+      </p:sp>
+      <p:sp>
+        <p:nvSpPr>
+          <p:cNvPr id="33" name="Text 31"/>
+          <p:cNvSpPr/>
+          <p:nvPr/>
+        </p:nvSpPr>
+        <p:spPr>
+          <a:xfrm>
+            <a:off x="4855464" y="5047488"/>
+            <a:ext cx="2487168" cy="228600"/>
+          </a:xfrm>
+          <a:prstGeom prst="rect">
+            <a:avLst/>
+          </a:prstGeom>
+          <a:noFill/>
+          <a:ln/>
+        </p:spPr>
+        <p:txBody>
+          <a:bodyPr wrap="square" lIns="0" tIns="0" rIns="0" bIns="0" rtlCol="0" anchor="t"/>
+          <a:lstStyle/>
+          <a:p>
+            <a:pPr algn="ctr" indent="0" marL="0">
+              <a:buNone/>
+            </a:pPr>
+            <a:r>
+              <a:rPr lang="en-US" sz="750" spc="50" kern="0" dirty="0">
+                <a:solidFill>
+                  <a:srgbClr val="FF6A1A"/>
+                </a:solidFill>
+                <a:latin typeface="Cascadia Mono" pitchFamily="34" charset="0"/>
+                <a:ea typeface="Cascadia Mono" pitchFamily="34" charset="-122"/>
+                <a:cs typeface="Cascadia Mono" pitchFamily="34" charset="-120"/>
+              </a:rPr>
+              <a:t>DETERMINISTIC · AUDITABLE · NO LLM IN THE DECISION</a:t>
+            </a:r>
+            <a:endParaRPr lang="en-US" sz="750" dirty="0"/>
+          </a:p>
+        </p:txBody>
+      </p:sp>
+      <p:sp>
+        <p:nvSpPr>
+          <p:cNvPr id="34" name="Text 32"/>
+          <p:cNvSpPr/>
+          <p:nvPr/>
+        </p:nvSpPr>
+        <p:spPr>
+          <a:xfrm>
+            <a:off x="777240" y="5925312"/>
+            <a:ext cx="10637215" cy="365760"/>
+          </a:xfrm>
+          <a:prstGeom prst="rect">
+            <a:avLst/>
+          </a:prstGeom>
+          <a:noFill/>
+          <a:ln/>
+        </p:spPr>
+        <p:txBody>
+          <a:bodyPr wrap="square" lIns="0" tIns="0" rIns="0" bIns="0" rtlCol="0" anchor="t"/>
+          <a:lstStyle/>
+          <a:p>
+            <a:pPr indent="0" marL="0">
+              <a:lnSpc>
+                <a:spcPct val="110000"/>
+              </a:lnSpc>
+              <a:buNone/>
+            </a:pPr>
+            <a:r>
+              <a:rPr lang="en-US" sz="1100" i="1" dirty="0">
+                <a:solidFill>
+                  <a:srgbClr val="8A7B68"/>
+                </a:solidFill>
+                <a:latin typeface="Segoe UI" pitchFamily="34" charset="0"/>
+                <a:ea typeface="Segoe UI" pitchFamily="34" charset="-122"/>
+                <a:cs typeface="Segoe UI" pitchFamily="34" charset="-120"/>
+              </a:rPr>
+              <a:t>Hybrid by design — the deterministic engine makes every life-safety call; the LLM layer only explains it, retrieves precedent, and drafts reports.</a:t>
+            </a:r>
+            <a:endParaRPr lang="en-US" sz="1100" dirty="0"/>
           </a:p>
         </p:txBody>
       </p:sp>

</xml_diff>